<commit_message>
Add language access handoff enhancement
Updates the public demo, README, pitch deck, static package, and submission bundle with the language-access sidecar and responder handoff validation.
</commit_message>
<xml_diff>
--- a/resilience_copilot_pitch_v2.pptx
+++ b/resilience_copilot_pitch_v2.pptx
@@ -2,20 +2,20 @@
 <file path=ppt/presentation.xml><?xml version="1.0" encoding="utf-8"?>
 <p:presentation xmlns:p="http://schemas.openxmlformats.org/presentationml/2006/main">
   <p:sldMasterIdLst>
-    <p:sldMasterId xmlns:r="http://schemas.openxmlformats.org/officeDocument/2006/relationships" id="2147483648" r:id="R670423d568984d41"/>
+    <p:sldMasterId xmlns:r="http://schemas.openxmlformats.org/officeDocument/2006/relationships" id="2147483648" r:id="Rbc11bd6f84164f8b"/>
   </p:sldMasterIdLst>
   <p:notesMasterIdLst>
-    <p:notesMasterId xmlns:r="http://schemas.openxmlformats.org/officeDocument/2006/relationships" r:id="R37583221485748e3"/>
+    <p:notesMasterId xmlns:r="http://schemas.openxmlformats.org/officeDocument/2006/relationships" r:id="R57aef327187c4408"/>
   </p:notesMasterIdLst>
   <p:sldIdLst>
-    <p:sldId xmlns:r="http://schemas.openxmlformats.org/officeDocument/2006/relationships" id="256" r:id="R8e6eaa5862574a6c"/>
-    <p:sldId xmlns:r="http://schemas.openxmlformats.org/officeDocument/2006/relationships" id="257" r:id="R1f9e71e17cee48e2"/>
-    <p:sldId xmlns:r="http://schemas.openxmlformats.org/officeDocument/2006/relationships" id="258" r:id="R33c189bda9de46a6"/>
-    <p:sldId xmlns:r="http://schemas.openxmlformats.org/officeDocument/2006/relationships" id="259" r:id="R8ad86272ab004946"/>
-    <p:sldId xmlns:r="http://schemas.openxmlformats.org/officeDocument/2006/relationships" id="260" r:id="R1b2ad63b49794383"/>
-    <p:sldId xmlns:r="http://schemas.openxmlformats.org/officeDocument/2006/relationships" id="261" r:id="Rb00891bbc2ca400d"/>
-    <p:sldId xmlns:r="http://schemas.openxmlformats.org/officeDocument/2006/relationships" id="262" r:id="R6ff711d11449412c"/>
-    <p:sldId xmlns:r="http://schemas.openxmlformats.org/officeDocument/2006/relationships" id="263" r:id="Rf3edcbac4908406c"/>
+    <p:sldId xmlns:r="http://schemas.openxmlformats.org/officeDocument/2006/relationships" id="256" r:id="Rdd00103168c343ba"/>
+    <p:sldId xmlns:r="http://schemas.openxmlformats.org/officeDocument/2006/relationships" id="257" r:id="R06886fad992a474a"/>
+    <p:sldId xmlns:r="http://schemas.openxmlformats.org/officeDocument/2006/relationships" id="258" r:id="Ra24b02fd6cfc4a4d"/>
+    <p:sldId xmlns:r="http://schemas.openxmlformats.org/officeDocument/2006/relationships" id="259" r:id="R9ac742180f234fc9"/>
+    <p:sldId xmlns:r="http://schemas.openxmlformats.org/officeDocument/2006/relationships" id="260" r:id="R87b5aa5e7bac4bd7"/>
+    <p:sldId xmlns:r="http://schemas.openxmlformats.org/officeDocument/2006/relationships" id="261" r:id="Rd4ce05ef30a643da"/>
+    <p:sldId xmlns:r="http://schemas.openxmlformats.org/officeDocument/2006/relationships" id="262" r:id="R1c5e654dbc8e43a4"/>
+    <p:sldId xmlns:r="http://schemas.openxmlformats.org/officeDocument/2006/relationships" id="263" r:id="R55fddb203b1945fc"/>
   </p:sldIdLst>
   <p:sldSz cx="18288000" cy="10287000"/>
   <p:notesSz cx="6858000" cy="9144000"/>
@@ -1024,7 +1024,7 @@
   </p:cSld>
   <p:clrMap bg1="lt1" tx1="dk1" bg2="lt2" tx2="dk2" accent1="accent1" accent2="accent2" accent3="accent3" accent4="accent4" accent5="accent5" accent6="accent6" hlink="hlink" folHlink="folHlink"/>
   <p:sldLayoutIdLst>
-    <p:sldLayoutId xmlns:r="http://schemas.openxmlformats.org/officeDocument/2006/relationships" id="2147483649" r:id="Rfce293e6cf694d6e"/>
+    <p:sldLayoutId xmlns:r="http://schemas.openxmlformats.org/officeDocument/2006/relationships" id="2147483649" r:id="R405d943c95214bc9"/>
   </p:sldLayoutIdLst>
   <p:txStyles>
     <p:titleStyle>
@@ -1363,7 +1363,7 @@
                 <c:v>2</c:v>
               </c:pt>
               <c:pt idx="2">
-                <c:v>4</c:v>
+                <c:v>5</c:v>
               </c:pt>
             </c:numLit>
           </c:val>
@@ -1399,7 +1399,7 @@
                 <c:v>2</c:v>
               </c:pt>
               <c:pt idx="2">
-                <c:v>4</c:v>
+                <c:v>5</c:v>
               </c:pt>
             </c:numLit>
           </c:val>
@@ -1515,7 +1515,7 @@
           <p:cNvPr id="1" name="background">
             <a:extLst xmlns:a="http://schemas.openxmlformats.org/drawingml/2006/main">
               <a:ext uri="{FF2B5EF4-FFF2-40B4-BE49-F238E27FC236}">
-                <a16:creationId xmlns:a16="http://schemas.microsoft.com/office/drawing/2014/main" id="{79DBBECB-A9FE-4B22-A7A5-0E950635821A}"/>
+                <a16:creationId xmlns:a16="http://schemas.microsoft.com/office/drawing/2014/main" id="{CDB85DEC-0B99-48A0-9D12-1B23EFAE5556}"/>
               </a:ext>
             </a:extLst>
           </p:cNvPr>
@@ -1542,7 +1542,7 @@
           <p:cNvPr id="2" name="badge-gemma-4-good">
             <a:extLst xmlns:a="http://schemas.openxmlformats.org/drawingml/2006/main">
               <a:ext uri="{FF2B5EF4-FFF2-40B4-BE49-F238E27FC236}">
-                <a16:creationId xmlns:a16="http://schemas.microsoft.com/office/drawing/2014/main" id="{7E96B167-C822-425A-BA14-ABCB0EB382F8}"/>
+                <a16:creationId xmlns:a16="http://schemas.microsoft.com/office/drawing/2014/main" id="{6CD1382F-382D-4D01-9E2A-9869B62E5040}"/>
               </a:ext>
             </a:extLst>
           </p:cNvPr>
@@ -1571,7 +1571,7 @@
           <p:cNvPr id="3" name="">
             <a:extLst xmlns:a="http://schemas.openxmlformats.org/drawingml/2006/main">
               <a:ext uri="{FF2B5EF4-FFF2-40B4-BE49-F238E27FC236}">
-                <a16:creationId xmlns:a16="http://schemas.microsoft.com/office/drawing/2014/main" id="{CD3A1C0E-8C1A-4109-9F48-2A20A98EB8C4}"/>
+                <a16:creationId xmlns:a16="http://schemas.microsoft.com/office/drawing/2014/main" id="{7A4376DA-5B53-476A-AD09-A1DCD9579A7F}"/>
               </a:ext>
             </a:extLst>
           </p:cNvPr>
@@ -1616,7 +1616,7 @@
           <p:cNvPr id="4" name="badge-safety-first-crisis-ai">
             <a:extLst xmlns:a="http://schemas.openxmlformats.org/drawingml/2006/main">
               <a:ext uri="{FF2B5EF4-FFF2-40B4-BE49-F238E27FC236}">
-                <a16:creationId xmlns:a16="http://schemas.microsoft.com/office/drawing/2014/main" id="{2EF0D4E0-E508-45D2-853F-C3550DAA9DC0}"/>
+                <a16:creationId xmlns:a16="http://schemas.microsoft.com/office/drawing/2014/main" id="{8B43C3B5-A675-494E-A815-CA7289F3ECCF}"/>
               </a:ext>
             </a:extLst>
           </p:cNvPr>
@@ -1645,7 +1645,7 @@
           <p:cNvPr id="5" name="">
             <a:extLst xmlns:a="http://schemas.openxmlformats.org/drawingml/2006/main">
               <a:ext uri="{FF2B5EF4-FFF2-40B4-BE49-F238E27FC236}">
-                <a16:creationId xmlns:a16="http://schemas.microsoft.com/office/drawing/2014/main" id="{3F510F3B-D74C-44D1-A7F5-186C2B6C1DCB}"/>
+                <a16:creationId xmlns:a16="http://schemas.microsoft.com/office/drawing/2014/main" id="{F5F59C55-4261-41BF-8DDB-BD59F181EDC2}"/>
               </a:ext>
             </a:extLst>
           </p:cNvPr>
@@ -1690,7 +1690,7 @@
           <p:cNvPr id="6" name="">
             <a:extLst xmlns:a="http://schemas.openxmlformats.org/drawingml/2006/main">
               <a:ext uri="{FF2B5EF4-FFF2-40B4-BE49-F238E27FC236}">
-                <a16:creationId xmlns:a16="http://schemas.microsoft.com/office/drawing/2014/main" id="{7A33DAC2-D395-4CB9-BFE4-732F98987DD0}"/>
+                <a16:creationId xmlns:a16="http://schemas.microsoft.com/office/drawing/2014/main" id="{A8063E23-4AB6-48FE-A1D0-28F8506F3806}"/>
               </a:ext>
             </a:extLst>
           </p:cNvPr>
@@ -1752,7 +1752,7 @@
           <p:cNvPr id="7" name="">
             <a:extLst xmlns:a="http://schemas.openxmlformats.org/drawingml/2006/main">
               <a:ext uri="{FF2B5EF4-FFF2-40B4-BE49-F238E27FC236}">
-                <a16:creationId xmlns:a16="http://schemas.microsoft.com/office/drawing/2014/main" id="{BC9266C8-538B-4CA7-9C16-C95BAD10CDAF}"/>
+                <a16:creationId xmlns:a16="http://schemas.microsoft.com/office/drawing/2014/main" id="{227F7CE9-A81C-4CB5-B536-3A58E998981D}"/>
               </a:ext>
             </a:extLst>
           </p:cNvPr>
@@ -1797,7 +1797,7 @@
           <p:cNvPr id="8" name="">
             <a:extLst xmlns:a="http://schemas.openxmlformats.org/drawingml/2006/main">
               <a:ext uri="{FF2B5EF4-FFF2-40B4-BE49-F238E27FC236}">
-                <a16:creationId xmlns:a16="http://schemas.microsoft.com/office/drawing/2014/main" id="{7DC6A4FC-66B9-4842-8798-14A8149EDA26}"/>
+                <a16:creationId xmlns:a16="http://schemas.microsoft.com/office/drawing/2014/main" id="{2FA334D5-997B-4126-A689-E20805587643}"/>
               </a:ext>
             </a:extLst>
           </p:cNvPr>
@@ -1826,7 +1826,7 @@
           <p:cNvPr id="9" name="">
             <a:extLst xmlns:a="http://schemas.openxmlformats.org/drawingml/2006/main">
               <a:ext uri="{FF2B5EF4-FFF2-40B4-BE49-F238E27FC236}">
-                <a16:creationId xmlns:a16="http://schemas.microsoft.com/office/drawing/2014/main" id="{C278AAE6-3BA9-46F5-BF32-5F1C2072D953}"/>
+                <a16:creationId xmlns:a16="http://schemas.microsoft.com/office/drawing/2014/main" id="{3EA8C7B6-C80B-44DB-B1C4-8D7D95921ACF}"/>
               </a:ext>
             </a:extLst>
           </p:cNvPr>
@@ -1871,7 +1871,7 @@
           <p:cNvPr id="10" name="">
             <a:extLst xmlns:a="http://schemas.openxmlformats.org/drawingml/2006/main">
               <a:ext uri="{FF2B5EF4-FFF2-40B4-BE49-F238E27FC236}">
-                <a16:creationId xmlns:a16="http://schemas.microsoft.com/office/drawing/2014/main" id="{823D941C-CF6D-4611-AA84-B1461D55B1D7}"/>
+                <a16:creationId xmlns:a16="http://schemas.microsoft.com/office/drawing/2014/main" id="{7E263490-2018-4164-ACC8-7209C042F913}"/>
               </a:ext>
             </a:extLst>
           </p:cNvPr>
@@ -1910,8 +1910,8 @@
           <p:nvPr/>
         </p:nvPicPr>
         <p:blipFill>
-          <a:blip xmlns:r="http://schemas.openxmlformats.org/officeDocument/2006/relationships" xmlns:a="http://schemas.openxmlformats.org/drawingml/2006/main" r:embed="R9ca9ae2db8cb486b"/>
-          <a:srcRect xmlns:a="http://schemas.openxmlformats.org/drawingml/2006/main" l="27116" t="0" r="27116" b="0"/>
+          <a:blip xmlns:r="http://schemas.openxmlformats.org/officeDocument/2006/relationships" xmlns:a="http://schemas.openxmlformats.org/drawingml/2006/main" r:embed="R5cef95f4ff0041a5"/>
+          <a:srcRect xmlns:a="http://schemas.openxmlformats.org/drawingml/2006/main" l="8504" t="0" r="8504" b="0"/>
           <a:stretch xmlns:a="http://schemas.openxmlformats.org/drawingml/2006/main">
             <a:fillRect l="0" t="0" r="0" b="0"/>
           </a:stretch>
@@ -1929,7 +1929,7 @@
     </p:spTree>
     <p:extLst>
       <p:ext uri="{BB962C8B-B14F-4D97-AF65-F5344CB8AC3E}">
-        <p14:creationId xmlns:p14="http://schemas.microsoft.com/office/powerpoint/2010/main" val="1995584965"/>
+        <p14:creationId xmlns:p14="http://schemas.microsoft.com/office/powerpoint/2010/main" val="395040374"/>
       </p:ext>
     </p:extLst>
   </p:cSld>
@@ -1953,7 +1953,7 @@
           <p:cNvPr id="1" name="background">
             <a:extLst xmlns:a="http://schemas.openxmlformats.org/drawingml/2006/main">
               <a:ext uri="{FF2B5EF4-FFF2-40B4-BE49-F238E27FC236}">
-                <a16:creationId xmlns:a16="http://schemas.microsoft.com/office/drawing/2014/main" id="{01FE5109-FDF1-4B19-B5F6-A2B1C55FF84E}"/>
+                <a16:creationId xmlns:a16="http://schemas.microsoft.com/office/drawing/2014/main" id="{A0614F06-9FFB-42EA-A2BD-8B63D75E79D7}"/>
               </a:ext>
             </a:extLst>
           </p:cNvPr>
@@ -1980,7 +1980,7 @@
           <p:cNvPr id="2" name="">
             <a:extLst xmlns:a="http://schemas.openxmlformats.org/drawingml/2006/main">
               <a:ext uri="{FF2B5EF4-FFF2-40B4-BE49-F238E27FC236}">
-                <a16:creationId xmlns:a16="http://schemas.microsoft.com/office/drawing/2014/main" id="{9BAE6F7A-5D3D-4E50-BE2E-F3A3748DFFC2}"/>
+                <a16:creationId xmlns:a16="http://schemas.microsoft.com/office/drawing/2014/main" id="{DFA49C8D-B55D-4F95-93FD-F153D2935DFB}"/>
               </a:ext>
             </a:extLst>
           </p:cNvPr>
@@ -2007,7 +2007,7 @@
           <p:cNvPr id="3" name="">
             <a:extLst xmlns:a="http://schemas.openxmlformats.org/drawingml/2006/main">
               <a:ext uri="{FF2B5EF4-FFF2-40B4-BE49-F238E27FC236}">
-                <a16:creationId xmlns:a16="http://schemas.microsoft.com/office/drawing/2014/main" id="{2140B701-9D6D-4A36-9BE2-3078BB6DEA40}"/>
+                <a16:creationId xmlns:a16="http://schemas.microsoft.com/office/drawing/2014/main" id="{48F43E79-E4DC-4BEB-9468-A198B4AB1DA9}"/>
               </a:ext>
             </a:extLst>
           </p:cNvPr>
@@ -2052,7 +2052,7 @@
           <p:cNvPr id="4" name="">
             <a:extLst xmlns:a="http://schemas.openxmlformats.org/drawingml/2006/main">
               <a:ext uri="{FF2B5EF4-FFF2-40B4-BE49-F238E27FC236}">
-                <a16:creationId xmlns:a16="http://schemas.microsoft.com/office/drawing/2014/main" id="{32C92A68-1162-4A95-B4B8-FD1731C47412}"/>
+                <a16:creationId xmlns:a16="http://schemas.microsoft.com/office/drawing/2014/main" id="{8FBD8109-E5D6-4069-BAAD-AD88CD043EF3}"/>
               </a:ext>
             </a:extLst>
           </p:cNvPr>
@@ -2097,7 +2097,7 @@
           <p:cNvPr id="5" name="">
             <a:extLst xmlns:a="http://schemas.openxmlformats.org/drawingml/2006/main">
               <a:ext uri="{FF2B5EF4-FFF2-40B4-BE49-F238E27FC236}">
-                <a16:creationId xmlns:a16="http://schemas.microsoft.com/office/drawing/2014/main" id="{CA871624-EE29-4EE3-A185-F5F2F6304898}"/>
+                <a16:creationId xmlns:a16="http://schemas.microsoft.com/office/drawing/2014/main" id="{828B8C0A-4F7C-4FCE-AB87-6AE4F85F3C77}"/>
               </a:ext>
             </a:extLst>
           </p:cNvPr>
@@ -2142,7 +2142,7 @@
           <p:cNvPr id="6" name="footer">
             <a:extLst xmlns:a="http://schemas.openxmlformats.org/drawingml/2006/main">
               <a:ext uri="{FF2B5EF4-FFF2-40B4-BE49-F238E27FC236}">
-                <a16:creationId xmlns:a16="http://schemas.microsoft.com/office/drawing/2014/main" id="{EFE12E32-36C3-4279-8F01-359C66FBF1AA}"/>
+                <a16:creationId xmlns:a16="http://schemas.microsoft.com/office/drawing/2014/main" id="{E524297C-9591-4056-A3F2-61B15E71C012}"/>
               </a:ext>
             </a:extLst>
           </p:cNvPr>
@@ -2187,7 +2187,7 @@
           <p:cNvPr id="7" name="">
             <a:extLst xmlns:a="http://schemas.openxmlformats.org/drawingml/2006/main">
               <a:ext uri="{FF2B5EF4-FFF2-40B4-BE49-F238E27FC236}">
-                <a16:creationId xmlns:a16="http://schemas.microsoft.com/office/drawing/2014/main" id="{87EF46D9-F2E8-4A6D-A036-E7ACF0DF8C5E}"/>
+                <a16:creationId xmlns:a16="http://schemas.microsoft.com/office/drawing/2014/main" id="{4461E4D9-B82B-46C2-8190-CA302E88ECCF}"/>
               </a:ext>
             </a:extLst>
           </p:cNvPr>
@@ -2222,7 +2222,7 @@
           <p:cNvPr id="8" name="">
             <a:extLst xmlns:a="http://schemas.openxmlformats.org/drawingml/2006/main">
               <a:ext uri="{FF2B5EF4-FFF2-40B4-BE49-F238E27FC236}">
-                <a16:creationId xmlns:a16="http://schemas.microsoft.com/office/drawing/2014/main" id="{5A7E6F04-CD76-4711-8094-C6F41EDE5B6A}"/>
+                <a16:creationId xmlns:a16="http://schemas.microsoft.com/office/drawing/2014/main" id="{7E104DAD-D44D-4349-B738-D5C4679C01CA}"/>
               </a:ext>
             </a:extLst>
           </p:cNvPr>
@@ -2249,7 +2249,7 @@
           <p:cNvPr id="9" name="">
             <a:extLst xmlns:a="http://schemas.openxmlformats.org/drawingml/2006/main">
               <a:ext uri="{FF2B5EF4-FFF2-40B4-BE49-F238E27FC236}">
-                <a16:creationId xmlns:a16="http://schemas.microsoft.com/office/drawing/2014/main" id="{51E75D83-3D02-4E07-BAD5-0FA727B15593}"/>
+                <a16:creationId xmlns:a16="http://schemas.microsoft.com/office/drawing/2014/main" id="{8B0B4C2C-A20A-4AC9-8ED6-C6C83D1E6AA9}"/>
               </a:ext>
             </a:extLst>
           </p:cNvPr>
@@ -2294,7 +2294,7 @@
           <p:cNvPr id="10" name="">
             <a:extLst xmlns:a="http://schemas.openxmlformats.org/drawingml/2006/main">
               <a:ext uri="{FF2B5EF4-FFF2-40B4-BE49-F238E27FC236}">
-                <a16:creationId xmlns:a16="http://schemas.microsoft.com/office/drawing/2014/main" id="{A69D21DC-0843-40D4-9D62-B51D9B10DB33}"/>
+                <a16:creationId xmlns:a16="http://schemas.microsoft.com/office/drawing/2014/main" id="{F1613CD6-BBE7-475D-BE38-EA7BBE65F2C8}"/>
               </a:ext>
             </a:extLst>
           </p:cNvPr>
@@ -2339,7 +2339,7 @@
           <p:cNvPr id="11" name="">
             <a:extLst xmlns:a="http://schemas.openxmlformats.org/drawingml/2006/main">
               <a:ext uri="{FF2B5EF4-FFF2-40B4-BE49-F238E27FC236}">
-                <a16:creationId xmlns:a16="http://schemas.microsoft.com/office/drawing/2014/main" id="{1B4BBA52-BC77-4FC3-B381-8D8753C73EA1}"/>
+                <a16:creationId xmlns:a16="http://schemas.microsoft.com/office/drawing/2014/main" id="{48EE42AE-DF94-4950-A153-C6D860D695E8}"/>
               </a:ext>
             </a:extLst>
           </p:cNvPr>
@@ -2366,7 +2366,7 @@
           <p:cNvPr id="12" name="">
             <a:extLst xmlns:a="http://schemas.openxmlformats.org/drawingml/2006/main">
               <a:ext uri="{FF2B5EF4-FFF2-40B4-BE49-F238E27FC236}">
-                <a16:creationId xmlns:a16="http://schemas.microsoft.com/office/drawing/2014/main" id="{1E800F36-0B3B-4A58-9CE5-9B887D7BE4D7}"/>
+                <a16:creationId xmlns:a16="http://schemas.microsoft.com/office/drawing/2014/main" id="{AFC0ABEF-FA4D-47FE-A137-3D350873AED1}"/>
               </a:ext>
             </a:extLst>
           </p:cNvPr>
@@ -2411,7 +2411,7 @@
           <p:cNvPr id="13" name="">
             <a:extLst xmlns:a="http://schemas.openxmlformats.org/drawingml/2006/main">
               <a:ext uri="{FF2B5EF4-FFF2-40B4-BE49-F238E27FC236}">
-                <a16:creationId xmlns:a16="http://schemas.microsoft.com/office/drawing/2014/main" id="{5462851E-2179-4C26-A0FF-C9B19E477109}"/>
+                <a16:creationId xmlns:a16="http://schemas.microsoft.com/office/drawing/2014/main" id="{EB70C86B-C366-4E80-A309-9D63938C2518}"/>
               </a:ext>
             </a:extLst>
           </p:cNvPr>
@@ -2456,7 +2456,7 @@
           <p:cNvPr id="14" name="">
             <a:extLst xmlns:a="http://schemas.openxmlformats.org/drawingml/2006/main">
               <a:ext uri="{FF2B5EF4-FFF2-40B4-BE49-F238E27FC236}">
-                <a16:creationId xmlns:a16="http://schemas.microsoft.com/office/drawing/2014/main" id="{3B2F469D-E5F6-4911-B7A7-451AD36706F4}"/>
+                <a16:creationId xmlns:a16="http://schemas.microsoft.com/office/drawing/2014/main" id="{26AE3A30-0595-4CF5-AFB7-C6A984C89B39}"/>
               </a:ext>
             </a:extLst>
           </p:cNvPr>
@@ -2483,7 +2483,7 @@
           <p:cNvPr id="15" name="">
             <a:extLst xmlns:a="http://schemas.openxmlformats.org/drawingml/2006/main">
               <a:ext uri="{FF2B5EF4-FFF2-40B4-BE49-F238E27FC236}">
-                <a16:creationId xmlns:a16="http://schemas.microsoft.com/office/drawing/2014/main" id="{54B96FCF-A45C-4D3A-9486-B4B28603BF7B}"/>
+                <a16:creationId xmlns:a16="http://schemas.microsoft.com/office/drawing/2014/main" id="{84CA2582-ECBA-4642-9700-F25A4DA8C008}"/>
               </a:ext>
             </a:extLst>
           </p:cNvPr>
@@ -2528,7 +2528,7 @@
           <p:cNvPr id="16" name="">
             <a:extLst xmlns:a="http://schemas.openxmlformats.org/drawingml/2006/main">
               <a:ext uri="{FF2B5EF4-FFF2-40B4-BE49-F238E27FC236}">
-                <a16:creationId xmlns:a16="http://schemas.microsoft.com/office/drawing/2014/main" id="{0F62869C-4930-4AB5-ABC8-A2419B63ED46}"/>
+                <a16:creationId xmlns:a16="http://schemas.microsoft.com/office/drawing/2014/main" id="{E7DEE004-89F6-4980-AD01-23548AB5B594}"/>
               </a:ext>
             </a:extLst>
           </p:cNvPr>
@@ -2573,7 +2573,7 @@
           <p:cNvPr id="17" name="">
             <a:extLst xmlns:a="http://schemas.openxmlformats.org/drawingml/2006/main">
               <a:ext uri="{FF2B5EF4-FFF2-40B4-BE49-F238E27FC236}">
-                <a16:creationId xmlns:a16="http://schemas.microsoft.com/office/drawing/2014/main" id="{E7CD976E-F7CE-4E1B-9D97-700A91C7555D}"/>
+                <a16:creationId xmlns:a16="http://schemas.microsoft.com/office/drawing/2014/main" id="{78FA254B-1C8E-4459-AEB2-25401E634655}"/>
               </a:ext>
             </a:extLst>
           </p:cNvPr>
@@ -2608,7 +2608,7 @@
                   <a:srgbClr val="FF5A66"/>
                 </a:solidFill>
               </a:rPr>
-              <a:t>5</a:t>
+              <a:t>7</a:t>
             </a:r>
           </a:p>
         </p:txBody>
@@ -2618,7 +2618,7 @@
           <p:cNvPr id="18" name="">
             <a:extLst xmlns:a="http://schemas.openxmlformats.org/drawingml/2006/main">
               <a:ext uri="{FF2B5EF4-FFF2-40B4-BE49-F238E27FC236}">
-                <a16:creationId xmlns:a16="http://schemas.microsoft.com/office/drawing/2014/main" id="{BF46883C-51DF-4E95-8A50-A02F045D6DF2}"/>
+                <a16:creationId xmlns:a16="http://schemas.microsoft.com/office/drawing/2014/main" id="{45EEA05B-5F8D-4097-B6DA-90FDD4D46513}"/>
               </a:ext>
             </a:extLst>
           </p:cNvPr>
@@ -2663,7 +2663,7 @@
           <p:cNvPr id="19" name="">
             <a:extLst xmlns:a="http://schemas.openxmlformats.org/drawingml/2006/main">
               <a:ext uri="{FF2B5EF4-FFF2-40B4-BE49-F238E27FC236}">
-                <a16:creationId xmlns:a16="http://schemas.microsoft.com/office/drawing/2014/main" id="{16B323B2-A868-421E-BBC7-78F67B230C07}"/>
+                <a16:creationId xmlns:a16="http://schemas.microsoft.com/office/drawing/2014/main" id="{5DFD4242-B478-4502-9F92-17B04CB5F46B}"/>
               </a:ext>
             </a:extLst>
           </p:cNvPr>
@@ -2698,7 +2698,7 @@
                   <a:srgbClr val="4EA5FF"/>
                 </a:solidFill>
               </a:rPr>
-              <a:t>8</a:t>
+              <a:t>9</a:t>
             </a:r>
           </a:p>
         </p:txBody>
@@ -2708,7 +2708,7 @@
           <p:cNvPr id="20" name="">
             <a:extLst xmlns:a="http://schemas.openxmlformats.org/drawingml/2006/main">
               <a:ext uri="{FF2B5EF4-FFF2-40B4-BE49-F238E27FC236}">
-                <a16:creationId xmlns:a16="http://schemas.microsoft.com/office/drawing/2014/main" id="{FFC45988-3EAF-4DED-9665-5B40D301A7CC}"/>
+                <a16:creationId xmlns:a16="http://schemas.microsoft.com/office/drawing/2014/main" id="{395C22FA-E269-4261-AAD7-6F743B4E4690}"/>
               </a:ext>
             </a:extLst>
           </p:cNvPr>
@@ -2753,7 +2753,7 @@
           <p:cNvPr id="21" name="">
             <a:extLst xmlns:a="http://schemas.openxmlformats.org/drawingml/2006/main">
               <a:ext uri="{FF2B5EF4-FFF2-40B4-BE49-F238E27FC236}">
-                <a16:creationId xmlns:a16="http://schemas.microsoft.com/office/drawing/2014/main" id="{5923F6C4-ECC7-480D-8A78-A5B74B657617}"/>
+                <a16:creationId xmlns:a16="http://schemas.microsoft.com/office/drawing/2014/main" id="{C3C1DA6A-8582-4264-B385-9D52D7D99CF7}"/>
               </a:ext>
             </a:extLst>
           </p:cNvPr>
@@ -2798,7 +2798,7 @@
           <p:cNvPr id="22" name="">
             <a:extLst xmlns:a="http://schemas.openxmlformats.org/drawingml/2006/main">
               <a:ext uri="{FF2B5EF4-FFF2-40B4-BE49-F238E27FC236}">
-                <a16:creationId xmlns:a16="http://schemas.microsoft.com/office/drawing/2014/main" id="{1860FDD1-1D1B-4E05-B519-CC38C622A561}"/>
+                <a16:creationId xmlns:a16="http://schemas.microsoft.com/office/drawing/2014/main" id="{EBB34678-3A51-4F8A-A812-012EA86913C0}"/>
               </a:ext>
             </a:extLst>
           </p:cNvPr>
@@ -2841,7 +2841,7 @@
     </p:spTree>
     <p:extLst>
       <p:ext uri="{BB962C8B-B14F-4D97-AF65-F5344CB8AC3E}">
-        <p14:creationId xmlns:p14="http://schemas.microsoft.com/office/powerpoint/2010/main" val="291905568"/>
+        <p14:creationId xmlns:p14="http://schemas.microsoft.com/office/powerpoint/2010/main" val="840705894"/>
       </p:ext>
     </p:extLst>
   </p:cSld>
@@ -2865,7 +2865,7 @@
           <p:cNvPr id="1" name="background">
             <a:extLst xmlns:a="http://schemas.openxmlformats.org/drawingml/2006/main">
               <a:ext uri="{FF2B5EF4-FFF2-40B4-BE49-F238E27FC236}">
-                <a16:creationId xmlns:a16="http://schemas.microsoft.com/office/drawing/2014/main" id="{D366982B-0074-454E-A5CA-F8DE53538FA1}"/>
+                <a16:creationId xmlns:a16="http://schemas.microsoft.com/office/drawing/2014/main" id="{F27AC55D-1378-4A8B-B871-0F75FBC661D6}"/>
               </a:ext>
             </a:extLst>
           </p:cNvPr>
@@ -2892,7 +2892,7 @@
           <p:cNvPr id="2" name="">
             <a:extLst xmlns:a="http://schemas.openxmlformats.org/drawingml/2006/main">
               <a:ext uri="{FF2B5EF4-FFF2-40B4-BE49-F238E27FC236}">
-                <a16:creationId xmlns:a16="http://schemas.microsoft.com/office/drawing/2014/main" id="{C3D1DD3B-FD6E-422B-AC56-947930B9870F}"/>
+                <a16:creationId xmlns:a16="http://schemas.microsoft.com/office/drawing/2014/main" id="{4A2A05CC-C3B6-4DFE-8EF2-DBEACE867510}"/>
               </a:ext>
             </a:extLst>
           </p:cNvPr>
@@ -2919,7 +2919,7 @@
           <p:cNvPr id="3" name="">
             <a:extLst xmlns:a="http://schemas.openxmlformats.org/drawingml/2006/main">
               <a:ext uri="{FF2B5EF4-FFF2-40B4-BE49-F238E27FC236}">
-                <a16:creationId xmlns:a16="http://schemas.microsoft.com/office/drawing/2014/main" id="{055B4070-29B6-45BC-8306-BFD7F9726C2A}"/>
+                <a16:creationId xmlns:a16="http://schemas.microsoft.com/office/drawing/2014/main" id="{44734F81-4D57-42E9-9750-CAA605FBF988}"/>
               </a:ext>
             </a:extLst>
           </p:cNvPr>
@@ -2964,7 +2964,7 @@
           <p:cNvPr id="4" name="">
             <a:extLst xmlns:a="http://schemas.openxmlformats.org/drawingml/2006/main">
               <a:ext uri="{FF2B5EF4-FFF2-40B4-BE49-F238E27FC236}">
-                <a16:creationId xmlns:a16="http://schemas.microsoft.com/office/drawing/2014/main" id="{FDF6E979-5132-4A08-B6B6-D1480B6B3BC3}"/>
+                <a16:creationId xmlns:a16="http://schemas.microsoft.com/office/drawing/2014/main" id="{F34DB1E1-2CD1-4217-BA5D-B84DBBA2AF30}"/>
               </a:ext>
             </a:extLst>
           </p:cNvPr>
@@ -3009,7 +3009,7 @@
           <p:cNvPr id="5" name="">
             <a:extLst xmlns:a="http://schemas.openxmlformats.org/drawingml/2006/main">
               <a:ext uri="{FF2B5EF4-FFF2-40B4-BE49-F238E27FC236}">
-                <a16:creationId xmlns:a16="http://schemas.microsoft.com/office/drawing/2014/main" id="{A7AAC1CC-1BB7-4A4A-9C34-29BE847F58D1}"/>
+                <a16:creationId xmlns:a16="http://schemas.microsoft.com/office/drawing/2014/main" id="{8145DE71-88AF-4099-9B73-997CAA397E81}"/>
               </a:ext>
             </a:extLst>
           </p:cNvPr>
@@ -3038,7 +3038,7 @@
           <p:cNvPr id="6" name="badge-1">
             <a:extLst xmlns:a="http://schemas.openxmlformats.org/drawingml/2006/main">
               <a:ext uri="{FF2B5EF4-FFF2-40B4-BE49-F238E27FC236}">
-                <a16:creationId xmlns:a16="http://schemas.microsoft.com/office/drawing/2014/main" id="{E71AB251-80B9-4356-BF3C-8C9488D96C16}"/>
+                <a16:creationId xmlns:a16="http://schemas.microsoft.com/office/drawing/2014/main" id="{F3145B90-6A60-42C0-8A6C-0E7A85B74936}"/>
               </a:ext>
             </a:extLst>
           </p:cNvPr>
@@ -3067,7 +3067,7 @@
           <p:cNvPr id="7" name="">
             <a:extLst xmlns:a="http://schemas.openxmlformats.org/drawingml/2006/main">
               <a:ext uri="{FF2B5EF4-FFF2-40B4-BE49-F238E27FC236}">
-                <a16:creationId xmlns:a16="http://schemas.microsoft.com/office/drawing/2014/main" id="{3F71A4C4-9A75-4C22-ABEB-6E5F40C495FD}"/>
+                <a16:creationId xmlns:a16="http://schemas.microsoft.com/office/drawing/2014/main" id="{0DE05020-4724-48E5-BDF8-5F53898B2387}"/>
               </a:ext>
             </a:extLst>
           </p:cNvPr>
@@ -3112,7 +3112,7 @@
           <p:cNvPr id="8" name="">
             <a:extLst xmlns:a="http://schemas.openxmlformats.org/drawingml/2006/main">
               <a:ext uri="{FF2B5EF4-FFF2-40B4-BE49-F238E27FC236}">
-                <a16:creationId xmlns:a16="http://schemas.microsoft.com/office/drawing/2014/main" id="{CD28F21F-E6D6-475D-8295-49CE9CA06757}"/>
+                <a16:creationId xmlns:a16="http://schemas.microsoft.com/office/drawing/2014/main" id="{B87A058B-8B3D-4A40-8F78-2CC2E421DBC9}"/>
               </a:ext>
             </a:extLst>
           </p:cNvPr>
@@ -3157,7 +3157,7 @@
           <p:cNvPr id="9" name="">
             <a:extLst xmlns:a="http://schemas.openxmlformats.org/drawingml/2006/main">
               <a:ext uri="{FF2B5EF4-FFF2-40B4-BE49-F238E27FC236}">
-                <a16:creationId xmlns:a16="http://schemas.microsoft.com/office/drawing/2014/main" id="{0CE202DE-91DE-4636-9EB1-CBF48F2D3AD4}"/>
+                <a16:creationId xmlns:a16="http://schemas.microsoft.com/office/drawing/2014/main" id="{1A53FCC3-41A1-46F9-9E66-E009DE60B6CF}"/>
               </a:ext>
             </a:extLst>
           </p:cNvPr>
@@ -3202,7 +3202,7 @@
           <p:cNvPr id="10" name="">
             <a:extLst xmlns:a="http://schemas.openxmlformats.org/drawingml/2006/main">
               <a:ext uri="{FF2B5EF4-FFF2-40B4-BE49-F238E27FC236}">
-                <a16:creationId xmlns:a16="http://schemas.microsoft.com/office/drawing/2014/main" id="{DE0543C4-D671-4072-80A8-0025E244093D}"/>
+                <a16:creationId xmlns:a16="http://schemas.microsoft.com/office/drawing/2014/main" id="{515EB9C0-E988-4CB6-82CE-B70DE999B4BC}"/>
               </a:ext>
             </a:extLst>
           </p:cNvPr>
@@ -3247,7 +3247,7 @@
           <p:cNvPr id="11" name="">
             <a:extLst xmlns:a="http://schemas.openxmlformats.org/drawingml/2006/main">
               <a:ext uri="{FF2B5EF4-FFF2-40B4-BE49-F238E27FC236}">
-                <a16:creationId xmlns:a16="http://schemas.microsoft.com/office/drawing/2014/main" id="{FC2459CD-ACD4-42D8-9363-A56C8721418D}"/>
+                <a16:creationId xmlns:a16="http://schemas.microsoft.com/office/drawing/2014/main" id="{3DF2DAF4-5B7C-4A86-B358-782EDE40AD4A}"/>
               </a:ext>
             </a:extLst>
           </p:cNvPr>
@@ -3276,7 +3276,7 @@
           <p:cNvPr id="12" name="badge-2">
             <a:extLst xmlns:a="http://schemas.openxmlformats.org/drawingml/2006/main">
               <a:ext uri="{FF2B5EF4-FFF2-40B4-BE49-F238E27FC236}">
-                <a16:creationId xmlns:a16="http://schemas.microsoft.com/office/drawing/2014/main" id="{C66559BC-B8E4-455B-9C3C-3F98BEE61FAD}"/>
+                <a16:creationId xmlns:a16="http://schemas.microsoft.com/office/drawing/2014/main" id="{13C97689-9640-46FC-868A-8B1317EAC151}"/>
               </a:ext>
             </a:extLst>
           </p:cNvPr>
@@ -3305,7 +3305,7 @@
           <p:cNvPr id="13" name="">
             <a:extLst xmlns:a="http://schemas.openxmlformats.org/drawingml/2006/main">
               <a:ext uri="{FF2B5EF4-FFF2-40B4-BE49-F238E27FC236}">
-                <a16:creationId xmlns:a16="http://schemas.microsoft.com/office/drawing/2014/main" id="{03E2EF1A-0C83-4DB7-94DF-34E1DEF04051}"/>
+                <a16:creationId xmlns:a16="http://schemas.microsoft.com/office/drawing/2014/main" id="{D7E8B24D-DE45-4C21-A3DB-A89C5352E254}"/>
               </a:ext>
             </a:extLst>
           </p:cNvPr>
@@ -3350,7 +3350,7 @@
           <p:cNvPr id="14" name="">
             <a:extLst xmlns:a="http://schemas.openxmlformats.org/drawingml/2006/main">
               <a:ext uri="{FF2B5EF4-FFF2-40B4-BE49-F238E27FC236}">
-                <a16:creationId xmlns:a16="http://schemas.microsoft.com/office/drawing/2014/main" id="{B6555EB9-50D5-48E4-98A1-1AB6F9D28F29}"/>
+                <a16:creationId xmlns:a16="http://schemas.microsoft.com/office/drawing/2014/main" id="{222A9A0C-09AA-482D-8DFC-149EBE4813A6}"/>
               </a:ext>
             </a:extLst>
           </p:cNvPr>
@@ -3395,7 +3395,7 @@
           <p:cNvPr id="15" name="">
             <a:extLst xmlns:a="http://schemas.openxmlformats.org/drawingml/2006/main">
               <a:ext uri="{FF2B5EF4-FFF2-40B4-BE49-F238E27FC236}">
-                <a16:creationId xmlns:a16="http://schemas.microsoft.com/office/drawing/2014/main" id="{2F660E74-4AE4-4C47-A430-5861C9C265C1}"/>
+                <a16:creationId xmlns:a16="http://schemas.microsoft.com/office/drawing/2014/main" id="{6C9383B5-044B-449D-80CE-1EE8A88F9D39}"/>
               </a:ext>
             </a:extLst>
           </p:cNvPr>
@@ -3440,7 +3440,7 @@
           <p:cNvPr id="16" name="">
             <a:extLst xmlns:a="http://schemas.openxmlformats.org/drawingml/2006/main">
               <a:ext uri="{FF2B5EF4-FFF2-40B4-BE49-F238E27FC236}">
-                <a16:creationId xmlns:a16="http://schemas.microsoft.com/office/drawing/2014/main" id="{B1EC9C47-E9FA-46D5-A3D9-C5AC744E8B18}"/>
+                <a16:creationId xmlns:a16="http://schemas.microsoft.com/office/drawing/2014/main" id="{081B59CF-D5D3-44A4-9640-58576603E3FB}"/>
               </a:ext>
             </a:extLst>
           </p:cNvPr>
@@ -3485,7 +3485,7 @@
           <p:cNvPr id="17" name="">
             <a:extLst xmlns:a="http://schemas.openxmlformats.org/drawingml/2006/main">
               <a:ext uri="{FF2B5EF4-FFF2-40B4-BE49-F238E27FC236}">
-                <a16:creationId xmlns:a16="http://schemas.microsoft.com/office/drawing/2014/main" id="{8EF32E66-798D-4591-9966-F5BB5C26EB18}"/>
+                <a16:creationId xmlns:a16="http://schemas.microsoft.com/office/drawing/2014/main" id="{038554B6-C64A-43BE-B3FF-7F9FFBF1970D}"/>
               </a:ext>
             </a:extLst>
           </p:cNvPr>
@@ -3514,7 +3514,7 @@
           <p:cNvPr id="18" name="badge-3">
             <a:extLst xmlns:a="http://schemas.openxmlformats.org/drawingml/2006/main">
               <a:ext uri="{FF2B5EF4-FFF2-40B4-BE49-F238E27FC236}">
-                <a16:creationId xmlns:a16="http://schemas.microsoft.com/office/drawing/2014/main" id="{B3E09E8F-53DC-4538-8AD6-8E97833E997C}"/>
+                <a16:creationId xmlns:a16="http://schemas.microsoft.com/office/drawing/2014/main" id="{098743DC-294E-4171-8FF2-C15AC59D8A37}"/>
               </a:ext>
             </a:extLst>
           </p:cNvPr>
@@ -3543,7 +3543,7 @@
           <p:cNvPr id="19" name="">
             <a:extLst xmlns:a="http://schemas.openxmlformats.org/drawingml/2006/main">
               <a:ext uri="{FF2B5EF4-FFF2-40B4-BE49-F238E27FC236}">
-                <a16:creationId xmlns:a16="http://schemas.microsoft.com/office/drawing/2014/main" id="{2B0D6731-1FCB-4270-A0B7-F10CD9A3752B}"/>
+                <a16:creationId xmlns:a16="http://schemas.microsoft.com/office/drawing/2014/main" id="{6956D98D-06B9-4436-8261-647F40947C46}"/>
               </a:ext>
             </a:extLst>
           </p:cNvPr>
@@ -3588,7 +3588,7 @@
           <p:cNvPr id="20" name="">
             <a:extLst xmlns:a="http://schemas.openxmlformats.org/drawingml/2006/main">
               <a:ext uri="{FF2B5EF4-FFF2-40B4-BE49-F238E27FC236}">
-                <a16:creationId xmlns:a16="http://schemas.microsoft.com/office/drawing/2014/main" id="{C3323FF2-5A03-4817-8849-388CF619CFF1}"/>
+                <a16:creationId xmlns:a16="http://schemas.microsoft.com/office/drawing/2014/main" id="{5691A0CB-6D14-489F-B328-31040C8749C8}"/>
               </a:ext>
             </a:extLst>
           </p:cNvPr>
@@ -3633,7 +3633,7 @@
           <p:cNvPr id="21" name="">
             <a:extLst xmlns:a="http://schemas.openxmlformats.org/drawingml/2006/main">
               <a:ext uri="{FF2B5EF4-FFF2-40B4-BE49-F238E27FC236}">
-                <a16:creationId xmlns:a16="http://schemas.microsoft.com/office/drawing/2014/main" id="{DA21FEC9-AF34-4F13-B3BF-81984325EAEF}"/>
+                <a16:creationId xmlns:a16="http://schemas.microsoft.com/office/drawing/2014/main" id="{E28E3E0B-EAF1-4A91-9E2C-B828E1FA45B0}"/>
               </a:ext>
             </a:extLst>
           </p:cNvPr>
@@ -3678,7 +3678,7 @@
           <p:cNvPr id="22" name="">
             <a:extLst xmlns:a="http://schemas.openxmlformats.org/drawingml/2006/main">
               <a:ext uri="{FF2B5EF4-FFF2-40B4-BE49-F238E27FC236}">
-                <a16:creationId xmlns:a16="http://schemas.microsoft.com/office/drawing/2014/main" id="{CB24A636-E36C-4B03-ACA6-A21A8FC79781}"/>
+                <a16:creationId xmlns:a16="http://schemas.microsoft.com/office/drawing/2014/main" id="{DAE80CDC-7BCA-46D1-8A5F-5059F7067301}"/>
               </a:ext>
             </a:extLst>
           </p:cNvPr>
@@ -3723,7 +3723,7 @@
           <p:cNvPr id="23" name="">
             <a:extLst xmlns:a="http://schemas.openxmlformats.org/drawingml/2006/main">
               <a:ext uri="{FF2B5EF4-FFF2-40B4-BE49-F238E27FC236}">
-                <a16:creationId xmlns:a16="http://schemas.microsoft.com/office/drawing/2014/main" id="{04E584D4-5EA0-49A7-AC75-24C05D14D7DC}"/>
+                <a16:creationId xmlns:a16="http://schemas.microsoft.com/office/drawing/2014/main" id="{612F770E-DACD-406B-ACF4-BCA63BD6F391}"/>
               </a:ext>
             </a:extLst>
           </p:cNvPr>
@@ -3752,7 +3752,7 @@
           <p:cNvPr id="24" name="badge-4">
             <a:extLst xmlns:a="http://schemas.openxmlformats.org/drawingml/2006/main">
               <a:ext uri="{FF2B5EF4-FFF2-40B4-BE49-F238E27FC236}">
-                <a16:creationId xmlns:a16="http://schemas.microsoft.com/office/drawing/2014/main" id="{8321CC16-47D8-443F-AB12-A48980131F2E}"/>
+                <a16:creationId xmlns:a16="http://schemas.microsoft.com/office/drawing/2014/main" id="{4833D977-E3AF-4655-9E3E-E6B629842B6B}"/>
               </a:ext>
             </a:extLst>
           </p:cNvPr>
@@ -3781,7 +3781,7 @@
           <p:cNvPr id="25" name="">
             <a:extLst xmlns:a="http://schemas.openxmlformats.org/drawingml/2006/main">
               <a:ext uri="{FF2B5EF4-FFF2-40B4-BE49-F238E27FC236}">
-                <a16:creationId xmlns:a16="http://schemas.microsoft.com/office/drawing/2014/main" id="{D86BA931-31EC-45E3-AF12-B1C524024FDE}"/>
+                <a16:creationId xmlns:a16="http://schemas.microsoft.com/office/drawing/2014/main" id="{A8D9F9F0-FA9E-4110-A4BA-AF9CFB446706}"/>
               </a:ext>
             </a:extLst>
           </p:cNvPr>
@@ -3826,7 +3826,7 @@
           <p:cNvPr id="26" name="">
             <a:extLst xmlns:a="http://schemas.openxmlformats.org/drawingml/2006/main">
               <a:ext uri="{FF2B5EF4-FFF2-40B4-BE49-F238E27FC236}">
-                <a16:creationId xmlns:a16="http://schemas.microsoft.com/office/drawing/2014/main" id="{21087E5C-5332-4D46-A92C-D71557393D27}"/>
+                <a16:creationId xmlns:a16="http://schemas.microsoft.com/office/drawing/2014/main" id="{813D38AC-581D-4F41-BD59-897E54038513}"/>
               </a:ext>
             </a:extLst>
           </p:cNvPr>
@@ -3871,7 +3871,7 @@
           <p:cNvPr id="27" name="">
             <a:extLst xmlns:a="http://schemas.openxmlformats.org/drawingml/2006/main">
               <a:ext uri="{FF2B5EF4-FFF2-40B4-BE49-F238E27FC236}">
-                <a16:creationId xmlns:a16="http://schemas.microsoft.com/office/drawing/2014/main" id="{A4CA0042-B385-48BA-BC4B-330BC2F74B76}"/>
+                <a16:creationId xmlns:a16="http://schemas.microsoft.com/office/drawing/2014/main" id="{10D9A4DF-5B89-451D-897F-F0B891A23064}"/>
               </a:ext>
             </a:extLst>
           </p:cNvPr>
@@ -3914,7 +3914,7 @@
     </p:spTree>
     <p:extLst>
       <p:ext uri="{BB962C8B-B14F-4D97-AF65-F5344CB8AC3E}">
-        <p14:creationId xmlns:p14="http://schemas.microsoft.com/office/powerpoint/2010/main" val="1096916045"/>
+        <p14:creationId xmlns:p14="http://schemas.microsoft.com/office/powerpoint/2010/main" val="1944253356"/>
       </p:ext>
     </p:extLst>
   </p:cSld>
@@ -3938,7 +3938,7 @@
           <p:cNvPr id="1" name="background">
             <a:extLst xmlns:a="http://schemas.openxmlformats.org/drawingml/2006/main">
               <a:ext uri="{FF2B5EF4-FFF2-40B4-BE49-F238E27FC236}">
-                <a16:creationId xmlns:a16="http://schemas.microsoft.com/office/drawing/2014/main" id="{70B1951C-8FD1-4BE0-A155-4AEDD615FD9F}"/>
+                <a16:creationId xmlns:a16="http://schemas.microsoft.com/office/drawing/2014/main" id="{D12B4F31-F0F3-4B4E-89B8-846CFCF7EB42}"/>
               </a:ext>
             </a:extLst>
           </p:cNvPr>
@@ -3965,7 +3965,7 @@
           <p:cNvPr id="2" name="">
             <a:extLst xmlns:a="http://schemas.openxmlformats.org/drawingml/2006/main">
               <a:ext uri="{FF2B5EF4-FFF2-40B4-BE49-F238E27FC236}">
-                <a16:creationId xmlns:a16="http://schemas.microsoft.com/office/drawing/2014/main" id="{4286D97B-30A4-497C-AE44-EA858750BE3F}"/>
+                <a16:creationId xmlns:a16="http://schemas.microsoft.com/office/drawing/2014/main" id="{3FAFEC23-00E9-4506-9E59-7E16FB9A97F7}"/>
               </a:ext>
             </a:extLst>
           </p:cNvPr>
@@ -3992,7 +3992,7 @@
           <p:cNvPr id="3" name="">
             <a:extLst xmlns:a="http://schemas.openxmlformats.org/drawingml/2006/main">
               <a:ext uri="{FF2B5EF4-FFF2-40B4-BE49-F238E27FC236}">
-                <a16:creationId xmlns:a16="http://schemas.microsoft.com/office/drawing/2014/main" id="{7E0F17B2-787D-43B2-8DBF-4E0CDD72B074}"/>
+                <a16:creationId xmlns:a16="http://schemas.microsoft.com/office/drawing/2014/main" id="{56F788BE-EE3F-4429-87AA-AEFB4C48A5E7}"/>
               </a:ext>
             </a:extLst>
           </p:cNvPr>
@@ -4037,7 +4037,7 @@
           <p:cNvPr id="4" name="">
             <a:extLst xmlns:a="http://schemas.openxmlformats.org/drawingml/2006/main">
               <a:ext uri="{FF2B5EF4-FFF2-40B4-BE49-F238E27FC236}">
-                <a16:creationId xmlns:a16="http://schemas.microsoft.com/office/drawing/2014/main" id="{787FA2E1-0193-4947-B67B-971A46CFF99D}"/>
+                <a16:creationId xmlns:a16="http://schemas.microsoft.com/office/drawing/2014/main" id="{C791BDD3-0A5C-4D86-896C-7DF3B2744FC3}"/>
               </a:ext>
             </a:extLst>
           </p:cNvPr>
@@ -4082,7 +4082,7 @@
           <p:cNvPr id="5" name="">
             <a:extLst xmlns:a="http://schemas.openxmlformats.org/drawingml/2006/main">
               <a:ext uri="{FF2B5EF4-FFF2-40B4-BE49-F238E27FC236}">
-                <a16:creationId xmlns:a16="http://schemas.microsoft.com/office/drawing/2014/main" id="{55ACB031-58BC-40B3-BD93-155AF8FF9845}"/>
+                <a16:creationId xmlns:a16="http://schemas.microsoft.com/office/drawing/2014/main" id="{0FDA8E57-8E18-4360-A1E9-525B133F984B}"/>
               </a:ext>
             </a:extLst>
           </p:cNvPr>
@@ -4094,7 +4094,7 @@
         <p:spPr>
           <a:xfrm xmlns:a="http://schemas.openxmlformats.org/drawingml/2006/main">
             <a:off x="857250" y="3752850"/>
-            <a:ext cx="6496050" cy="933450"/>
+            <a:ext cx="6477000" cy="628650"/>
           </a:xfrm>
           <a:prstGeom xmlns:a="http://schemas.openxmlformats.org/drawingml/2006/main" prst="rect">
             <a:avLst/>
@@ -4117,7 +4117,7 @@
                   <a:srgbClr val="5D6470"/>
                 </a:solidFill>
               </a:rPr>
-              <a:t>The public demo exposes the same five-section output used in local validation, so the project is inspectable instead of purely described.</a:t>
+              <a:t>The public demo exposes the same seven-section output used in local validation, including language support and handoff.</a:t>
             </a:r>
           </a:p>
         </p:txBody>
@@ -4127,18 +4127,18 @@
           <p:cNvPr id="6" name="badge-public-demo">
             <a:extLst xmlns:a="http://schemas.openxmlformats.org/drawingml/2006/main">
               <a:ext uri="{FF2B5EF4-FFF2-40B4-BE49-F238E27FC236}">
-                <a16:creationId xmlns:a16="http://schemas.microsoft.com/office/drawing/2014/main" id="{FEF762E5-74D1-4F52-85CA-B24EAD41C1E2}"/>
-              </a:ext>
-            </a:extLst>
-          </p:cNvPr>
-          <p:cNvSpPr>
-            <a:spLocks xmlns:a="http://schemas.openxmlformats.org/drawingml/2006/main" noGrp="1"/>
-          </p:cNvSpPr>
-          <p:nvPr/>
-        </p:nvSpPr>
-        <p:spPr>
-          <a:xfrm xmlns:a="http://schemas.openxmlformats.org/drawingml/2006/main">
-            <a:off x="857250" y="4861560"/>
+                <a16:creationId xmlns:a16="http://schemas.microsoft.com/office/drawing/2014/main" id="{46C94D3E-57D7-45EB-9321-EE836EA07336}"/>
+              </a:ext>
+            </a:extLst>
+          </p:cNvPr>
+          <p:cNvSpPr>
+            <a:spLocks xmlns:a="http://schemas.openxmlformats.org/drawingml/2006/main" noGrp="1"/>
+          </p:cNvSpPr>
+          <p:nvPr/>
+        </p:nvSpPr>
+        <p:spPr>
+          <a:xfrm xmlns:a="http://schemas.openxmlformats.org/drawingml/2006/main">
+            <a:off x="857250" y="4552950"/>
             <a:ext cx="1223581" cy="582930"/>
           </a:xfrm>
           <a:prstGeom xmlns:a="http://schemas.openxmlformats.org/drawingml/2006/main" prst="roundRect">
@@ -4156,18 +4156,18 @@
           <p:cNvPr id="7" name="">
             <a:extLst xmlns:a="http://schemas.openxmlformats.org/drawingml/2006/main">
               <a:ext uri="{FF2B5EF4-FFF2-40B4-BE49-F238E27FC236}">
-                <a16:creationId xmlns:a16="http://schemas.microsoft.com/office/drawing/2014/main" id="{847B8E20-DCBC-4434-B135-44611E019E59}"/>
-              </a:ext>
-            </a:extLst>
-          </p:cNvPr>
-          <p:cNvSpPr>
-            <a:spLocks xmlns:a="http://schemas.openxmlformats.org/drawingml/2006/main" noGrp="1"/>
-          </p:cNvSpPr>
-          <p:nvPr/>
-        </p:nvSpPr>
-        <p:spPr>
-          <a:xfrm xmlns:a="http://schemas.openxmlformats.org/drawingml/2006/main">
-            <a:off x="1028700" y="4933950"/>
+                <a16:creationId xmlns:a16="http://schemas.microsoft.com/office/drawing/2014/main" id="{4FAD6ADA-B6E0-4BE0-8E91-E68564D53271}"/>
+              </a:ext>
+            </a:extLst>
+          </p:cNvPr>
+          <p:cNvSpPr>
+            <a:spLocks xmlns:a="http://schemas.openxmlformats.org/drawingml/2006/main" noGrp="1"/>
+          </p:cNvSpPr>
+          <p:nvPr/>
+        </p:nvSpPr>
+        <p:spPr>
+          <a:xfrm xmlns:a="http://schemas.openxmlformats.org/drawingml/2006/main">
+            <a:off x="1028700" y="4629150"/>
             <a:ext cx="876300" cy="419100"/>
           </a:xfrm>
           <a:prstGeom xmlns:a="http://schemas.openxmlformats.org/drawingml/2006/main" prst="rect">
@@ -4201,18 +4201,18 @@
           <p:cNvPr id="8" name="badge-public-code">
             <a:extLst xmlns:a="http://schemas.openxmlformats.org/drawingml/2006/main">
               <a:ext uri="{FF2B5EF4-FFF2-40B4-BE49-F238E27FC236}">
-                <a16:creationId xmlns:a16="http://schemas.microsoft.com/office/drawing/2014/main" id="{EE8BD395-F6E8-4B0F-85C5-B0DEA68C7098}"/>
-              </a:ext>
-            </a:extLst>
-          </p:cNvPr>
-          <p:cNvSpPr>
-            <a:spLocks xmlns:a="http://schemas.openxmlformats.org/drawingml/2006/main" noGrp="1"/>
-          </p:cNvSpPr>
-          <p:nvPr/>
-        </p:nvSpPr>
-        <p:spPr>
-          <a:xfrm xmlns:a="http://schemas.openxmlformats.org/drawingml/2006/main">
-            <a:off x="2195131" y="4861560"/>
+                <a16:creationId xmlns:a16="http://schemas.microsoft.com/office/drawing/2014/main" id="{1B449D45-5359-4636-94A7-A50F9DA8EC90}"/>
+              </a:ext>
+            </a:extLst>
+          </p:cNvPr>
+          <p:cNvSpPr>
+            <a:spLocks xmlns:a="http://schemas.openxmlformats.org/drawingml/2006/main" noGrp="1"/>
+          </p:cNvSpPr>
+          <p:nvPr/>
+        </p:nvSpPr>
+        <p:spPr>
+          <a:xfrm xmlns:a="http://schemas.openxmlformats.org/drawingml/2006/main">
+            <a:off x="2195131" y="4552950"/>
             <a:ext cx="1155001" cy="582930"/>
           </a:xfrm>
           <a:prstGeom xmlns:a="http://schemas.openxmlformats.org/drawingml/2006/main" prst="roundRect">
@@ -4230,18 +4230,18 @@
           <p:cNvPr id="9" name="">
             <a:extLst xmlns:a="http://schemas.openxmlformats.org/drawingml/2006/main">
               <a:ext uri="{FF2B5EF4-FFF2-40B4-BE49-F238E27FC236}">
-                <a16:creationId xmlns:a16="http://schemas.microsoft.com/office/drawing/2014/main" id="{FB03F2D5-C9D4-4999-A31C-7AAB83B4EE28}"/>
-              </a:ext>
-            </a:extLst>
-          </p:cNvPr>
-          <p:cNvSpPr>
-            <a:spLocks xmlns:a="http://schemas.openxmlformats.org/drawingml/2006/main" noGrp="1"/>
-          </p:cNvSpPr>
-          <p:nvPr/>
-        </p:nvSpPr>
-        <p:spPr>
-          <a:xfrm xmlns:a="http://schemas.openxmlformats.org/drawingml/2006/main">
-            <a:off x="2381250" y="4933950"/>
+                <a16:creationId xmlns:a16="http://schemas.microsoft.com/office/drawing/2014/main" id="{B7E4B11A-2C7A-4C96-BD45-DB0C0EBB18E8}"/>
+              </a:ext>
+            </a:extLst>
+          </p:cNvPr>
+          <p:cNvSpPr>
+            <a:spLocks xmlns:a="http://schemas.openxmlformats.org/drawingml/2006/main" noGrp="1"/>
+          </p:cNvSpPr>
+          <p:nvPr/>
+        </p:nvSpPr>
+        <p:spPr>
+          <a:xfrm xmlns:a="http://schemas.openxmlformats.org/drawingml/2006/main">
+            <a:off x="2381250" y="4629150"/>
             <a:ext cx="800100" cy="419100"/>
           </a:xfrm>
           <a:prstGeom xmlns:a="http://schemas.openxmlformats.org/drawingml/2006/main" prst="rect">
@@ -4275,18 +4275,18 @@
           <p:cNvPr id="10" name="badge-video-pitch">
             <a:extLst xmlns:a="http://schemas.openxmlformats.org/drawingml/2006/main">
               <a:ext uri="{FF2B5EF4-FFF2-40B4-BE49-F238E27FC236}">
-                <a16:creationId xmlns:a16="http://schemas.microsoft.com/office/drawing/2014/main" id="{03295FCF-7A71-4D1D-80FB-FBCC856F1FA7}"/>
-              </a:ext>
-            </a:extLst>
-          </p:cNvPr>
-          <p:cNvSpPr>
-            <a:spLocks xmlns:a="http://schemas.openxmlformats.org/drawingml/2006/main" noGrp="1"/>
-          </p:cNvSpPr>
-          <p:nvPr/>
-        </p:nvSpPr>
-        <p:spPr>
-          <a:xfrm xmlns:a="http://schemas.openxmlformats.org/drawingml/2006/main">
-            <a:off x="3464433" y="4861560"/>
+                <a16:creationId xmlns:a16="http://schemas.microsoft.com/office/drawing/2014/main" id="{9C0C0E55-CBE3-4A56-B641-D58B93CC0E61}"/>
+              </a:ext>
+            </a:extLst>
+          </p:cNvPr>
+          <p:cNvSpPr>
+            <a:spLocks xmlns:a="http://schemas.openxmlformats.org/drawingml/2006/main" noGrp="1"/>
+          </p:cNvSpPr>
+          <p:nvPr/>
+        </p:nvSpPr>
+        <p:spPr>
+          <a:xfrm xmlns:a="http://schemas.openxmlformats.org/drawingml/2006/main">
+            <a:off x="3464433" y="4552950"/>
             <a:ext cx="1130522" cy="582930"/>
           </a:xfrm>
           <a:prstGeom xmlns:a="http://schemas.openxmlformats.org/drawingml/2006/main" prst="roundRect">
@@ -4304,18 +4304,18 @@
           <p:cNvPr id="11" name="">
             <a:extLst xmlns:a="http://schemas.openxmlformats.org/drawingml/2006/main">
               <a:ext uri="{FF2B5EF4-FFF2-40B4-BE49-F238E27FC236}">
-                <a16:creationId xmlns:a16="http://schemas.microsoft.com/office/drawing/2014/main" id="{E34B2CB3-0DDA-4013-B9F1-2DD94B41D7EC}"/>
-              </a:ext>
-            </a:extLst>
-          </p:cNvPr>
-          <p:cNvSpPr>
-            <a:spLocks xmlns:a="http://schemas.openxmlformats.org/drawingml/2006/main" noGrp="1"/>
-          </p:cNvSpPr>
-          <p:nvPr/>
-        </p:nvSpPr>
-        <p:spPr>
-          <a:xfrm xmlns:a="http://schemas.openxmlformats.org/drawingml/2006/main">
-            <a:off x="3638550" y="4933950"/>
+                <a16:creationId xmlns:a16="http://schemas.microsoft.com/office/drawing/2014/main" id="{B79C4783-14EB-418C-89A7-E891A8F2DBC6}"/>
+              </a:ext>
+            </a:extLst>
+          </p:cNvPr>
+          <p:cNvSpPr>
+            <a:spLocks xmlns:a="http://schemas.openxmlformats.org/drawingml/2006/main" noGrp="1"/>
+          </p:cNvSpPr>
+          <p:nvPr/>
+        </p:nvSpPr>
+        <p:spPr>
+          <a:xfrm xmlns:a="http://schemas.openxmlformats.org/drawingml/2006/main">
+            <a:off x="3638550" y="4629150"/>
             <a:ext cx="800100" cy="419100"/>
           </a:xfrm>
           <a:prstGeom xmlns:a="http://schemas.openxmlformats.org/drawingml/2006/main" prst="rect">
@@ -4349,7 +4349,7 @@
           <p:cNvPr id="12" name="footer">
             <a:extLst xmlns:a="http://schemas.openxmlformats.org/drawingml/2006/main">
               <a:ext uri="{FF2B5EF4-FFF2-40B4-BE49-F238E27FC236}">
-                <a16:creationId xmlns:a16="http://schemas.microsoft.com/office/drawing/2014/main" id="{F7936711-8BD7-4511-ABD4-4B74DD8C4EA4}"/>
+                <a16:creationId xmlns:a16="http://schemas.microsoft.com/office/drawing/2014/main" id="{E534D0E1-682F-4EDA-A8AE-83A10E5D2274}"/>
               </a:ext>
             </a:extLst>
           </p:cNvPr>
@@ -4394,7 +4394,7 @@
           <p:cNvPr id="13" name="">
             <a:extLst xmlns:a="http://schemas.openxmlformats.org/drawingml/2006/main">
               <a:ext uri="{FF2B5EF4-FFF2-40B4-BE49-F238E27FC236}">
-                <a16:creationId xmlns:a16="http://schemas.microsoft.com/office/drawing/2014/main" id="{0D43D1D2-2FAE-43F6-9FE2-6AC1A6D4B827}"/>
+                <a16:creationId xmlns:a16="http://schemas.microsoft.com/office/drawing/2014/main" id="{E0310317-E98A-46B7-A58D-4B59E6E806AC}"/>
               </a:ext>
             </a:extLst>
           </p:cNvPr>
@@ -4433,13 +4433,13 @@
           <p:nvPr/>
         </p:nvPicPr>
         <p:blipFill>
-          <a:blip xmlns:r="http://schemas.openxmlformats.org/officeDocument/2006/relationships" xmlns:a="http://schemas.openxmlformats.org/drawingml/2006/main" r:embed="R040fa328b7b1441b"/>
+          <a:blip xmlns:r="http://schemas.openxmlformats.org/officeDocument/2006/relationships" xmlns:a="http://schemas.openxmlformats.org/drawingml/2006/main" r:embed="Re2da131b43ea421a"/>
           <a:stretch xmlns:a="http://schemas.openxmlformats.org/drawingml/2006/main"/>
         </p:blipFill>
         <p:spPr>
           <a:xfrm xmlns:a="http://schemas.openxmlformats.org/drawingml/2006/main">
-            <a:off x="7753160" y="2910477"/>
-            <a:ext cx="9582341" cy="4466046"/>
+            <a:off x="8994174" y="2143125"/>
+            <a:ext cx="7100312" cy="6000750"/>
           </a:xfrm>
           <a:prstGeom xmlns:a="http://schemas.openxmlformats.org/drawingml/2006/main" prst="rect">
             <a:avLst/>
@@ -4449,7 +4449,7 @@
     </p:spTree>
     <p:extLst>
       <p:ext uri="{BB962C8B-B14F-4D97-AF65-F5344CB8AC3E}">
-        <p14:creationId xmlns:p14="http://schemas.microsoft.com/office/powerpoint/2010/main" val="1674960230"/>
+        <p14:creationId xmlns:p14="http://schemas.microsoft.com/office/powerpoint/2010/main" val="1303754007"/>
       </p:ext>
     </p:extLst>
   </p:cSld>
@@ -4473,7 +4473,7 @@
           <p:cNvPr id="1" name="background">
             <a:extLst xmlns:a="http://schemas.openxmlformats.org/drawingml/2006/main">
               <a:ext uri="{FF2B5EF4-FFF2-40B4-BE49-F238E27FC236}">
-                <a16:creationId xmlns:a16="http://schemas.microsoft.com/office/drawing/2014/main" id="{24D0D4CB-44C0-4702-8AB5-D86B28079008}"/>
+                <a16:creationId xmlns:a16="http://schemas.microsoft.com/office/drawing/2014/main" id="{AB61F127-2FD0-45EE-9E64-F7577F9846F9}"/>
               </a:ext>
             </a:extLst>
           </p:cNvPr>
@@ -4500,7 +4500,7 @@
           <p:cNvPr id="2" name="">
             <a:extLst xmlns:a="http://schemas.openxmlformats.org/drawingml/2006/main">
               <a:ext uri="{FF2B5EF4-FFF2-40B4-BE49-F238E27FC236}">
-                <a16:creationId xmlns:a16="http://schemas.microsoft.com/office/drawing/2014/main" id="{C000821F-0E76-4510-9B2D-D1502F4B57B5}"/>
+                <a16:creationId xmlns:a16="http://schemas.microsoft.com/office/drawing/2014/main" id="{95DD73B8-B637-4D82-BABE-DAB5370C9BE2}"/>
               </a:ext>
             </a:extLst>
           </p:cNvPr>
@@ -4527,7 +4527,7 @@
           <p:cNvPr id="3" name="">
             <a:extLst xmlns:a="http://schemas.openxmlformats.org/drawingml/2006/main">
               <a:ext uri="{FF2B5EF4-FFF2-40B4-BE49-F238E27FC236}">
-                <a16:creationId xmlns:a16="http://schemas.microsoft.com/office/drawing/2014/main" id="{A79F70B0-8979-4753-9DDC-A41412708755}"/>
+                <a16:creationId xmlns:a16="http://schemas.microsoft.com/office/drawing/2014/main" id="{6CD1BE14-D957-42E0-B117-8645B1FC5C4A}"/>
               </a:ext>
             </a:extLst>
           </p:cNvPr>
@@ -4572,7 +4572,7 @@
           <p:cNvPr id="4" name="">
             <a:extLst xmlns:a="http://schemas.openxmlformats.org/drawingml/2006/main">
               <a:ext uri="{FF2B5EF4-FFF2-40B4-BE49-F238E27FC236}">
-                <a16:creationId xmlns:a16="http://schemas.microsoft.com/office/drawing/2014/main" id="{BF9A37F9-6609-48DD-9D65-CA7D1416619E}"/>
+                <a16:creationId xmlns:a16="http://schemas.microsoft.com/office/drawing/2014/main" id="{89B3B61F-DD5A-482F-B755-B00C86D27FA6}"/>
               </a:ext>
             </a:extLst>
           </p:cNvPr>
@@ -4617,7 +4617,7 @@
           <p:cNvPr id="5" name="">
             <a:extLst xmlns:a="http://schemas.openxmlformats.org/drawingml/2006/main">
               <a:ext uri="{FF2B5EF4-FFF2-40B4-BE49-F238E27FC236}">
-                <a16:creationId xmlns:a16="http://schemas.microsoft.com/office/drawing/2014/main" id="{07CACB57-435A-4159-B3A6-EE534CD1C076}"/>
+                <a16:creationId xmlns:a16="http://schemas.microsoft.com/office/drawing/2014/main" id="{19C75169-1CA0-460C-B000-8F854E9AC228}"/>
               </a:ext>
             </a:extLst>
           </p:cNvPr>
@@ -4662,7 +4662,7 @@
           <p:cNvPr id="6" name="badge-children-cold-exposure">
             <a:extLst xmlns:a="http://schemas.openxmlformats.org/drawingml/2006/main">
               <a:ext uri="{FF2B5EF4-FFF2-40B4-BE49-F238E27FC236}">
-                <a16:creationId xmlns:a16="http://schemas.microsoft.com/office/drawing/2014/main" id="{2B8D9F53-8DC5-44B5-ACE7-AE01371AB9C6}"/>
+                <a16:creationId xmlns:a16="http://schemas.microsoft.com/office/drawing/2014/main" id="{E98239F8-4F45-4B01-A85C-33E06F8A4D4B}"/>
               </a:ext>
             </a:extLst>
           </p:cNvPr>
@@ -4691,7 +4691,7 @@
           <p:cNvPr id="7" name="">
             <a:extLst xmlns:a="http://schemas.openxmlformats.org/drawingml/2006/main">
               <a:ext uri="{FF2B5EF4-FFF2-40B4-BE49-F238E27FC236}">
-                <a16:creationId xmlns:a16="http://schemas.microsoft.com/office/drawing/2014/main" id="{A075E9A5-513C-42CE-AF5F-15DDE12705C9}"/>
+                <a16:creationId xmlns:a16="http://schemas.microsoft.com/office/drawing/2014/main" id="{85031FED-6EF5-40BA-B05E-CD0A5DB89DB9}"/>
               </a:ext>
             </a:extLst>
           </p:cNvPr>
@@ -4736,7 +4736,7 @@
           <p:cNvPr id="8" name="badge-medication-interruption">
             <a:extLst xmlns:a="http://schemas.openxmlformats.org/drawingml/2006/main">
               <a:ext uri="{FF2B5EF4-FFF2-40B4-BE49-F238E27FC236}">
-                <a16:creationId xmlns:a16="http://schemas.microsoft.com/office/drawing/2014/main" id="{46F8D621-C51D-4D73-9A86-F3AF079FD025}"/>
+                <a16:creationId xmlns:a16="http://schemas.microsoft.com/office/drawing/2014/main" id="{227922DD-DC49-4A11-9F91-B8ACD4C22C9C}"/>
               </a:ext>
             </a:extLst>
           </p:cNvPr>
@@ -4765,7 +4765,7 @@
           <p:cNvPr id="9" name="">
             <a:extLst xmlns:a="http://schemas.openxmlformats.org/drawingml/2006/main">
               <a:ext uri="{FF2B5EF4-FFF2-40B4-BE49-F238E27FC236}">
-                <a16:creationId xmlns:a16="http://schemas.microsoft.com/office/drawing/2014/main" id="{C6B9AE08-3C76-495D-AB84-AA9454129FC7}"/>
+                <a16:creationId xmlns:a16="http://schemas.microsoft.com/office/drawing/2014/main" id="{800B39FD-8610-4BD1-9DFE-BDC4B5B9706A}"/>
               </a:ext>
             </a:extLst>
           </p:cNvPr>
@@ -4810,7 +4810,7 @@
           <p:cNvPr id="10" name="badge-pregnancy-insulin">
             <a:extLst xmlns:a="http://schemas.openxmlformats.org/drawingml/2006/main">
               <a:ext uri="{FF2B5EF4-FFF2-40B4-BE49-F238E27FC236}">
-                <a16:creationId xmlns:a16="http://schemas.microsoft.com/office/drawing/2014/main" id="{DBB5879A-880A-486C-B3D0-920E5F168F14}"/>
+                <a16:creationId xmlns:a16="http://schemas.microsoft.com/office/drawing/2014/main" id="{7C7F3941-522A-43D3-BAC9-C91F990A1468}"/>
               </a:ext>
             </a:extLst>
           </p:cNvPr>
@@ -4839,7 +4839,7 @@
           <p:cNvPr id="11" name="">
             <a:extLst xmlns:a="http://schemas.openxmlformats.org/drawingml/2006/main">
               <a:ext uri="{FF2B5EF4-FFF2-40B4-BE49-F238E27FC236}">
-                <a16:creationId xmlns:a16="http://schemas.microsoft.com/office/drawing/2014/main" id="{9514FA55-CB95-4BB4-918B-A174439E8B2D}"/>
+                <a16:creationId xmlns:a16="http://schemas.microsoft.com/office/drawing/2014/main" id="{581E7F01-E587-4DBC-BFD2-9BAD4CF423B5}"/>
               </a:ext>
             </a:extLst>
           </p:cNvPr>
@@ -4884,7 +4884,7 @@
           <p:cNvPr id="12" name="badge-oxygen-power-loss">
             <a:extLst xmlns:a="http://schemas.openxmlformats.org/drawingml/2006/main">
               <a:ext uri="{FF2B5EF4-FFF2-40B4-BE49-F238E27FC236}">
-                <a16:creationId xmlns:a16="http://schemas.microsoft.com/office/drawing/2014/main" id="{1DC23560-3449-4DCA-9213-6757BA0E57FD}"/>
+                <a16:creationId xmlns:a16="http://schemas.microsoft.com/office/drawing/2014/main" id="{235E1DF7-D0C4-4351-9D3F-0E8741451A6D}"/>
               </a:ext>
             </a:extLst>
           </p:cNvPr>
@@ -4913,7 +4913,7 @@
           <p:cNvPr id="13" name="">
             <a:extLst xmlns:a="http://schemas.openxmlformats.org/drawingml/2006/main">
               <a:ext uri="{FF2B5EF4-FFF2-40B4-BE49-F238E27FC236}">
-                <a16:creationId xmlns:a16="http://schemas.microsoft.com/office/drawing/2014/main" id="{B87CD763-3242-47B4-A396-EE61635363C5}"/>
+                <a16:creationId xmlns:a16="http://schemas.microsoft.com/office/drawing/2014/main" id="{ACB26979-D4E2-40C7-ABF7-B2B7E1838AE8}"/>
               </a:ext>
             </a:extLst>
           </p:cNvPr>
@@ -4958,7 +4958,7 @@
           <p:cNvPr id="14" name="badge-language-access-barrier">
             <a:extLst xmlns:a="http://schemas.openxmlformats.org/drawingml/2006/main">
               <a:ext uri="{FF2B5EF4-FFF2-40B4-BE49-F238E27FC236}">
-                <a16:creationId xmlns:a16="http://schemas.microsoft.com/office/drawing/2014/main" id="{03E54575-B52A-4931-A201-C97188DB12FA}"/>
+                <a16:creationId xmlns:a16="http://schemas.microsoft.com/office/drawing/2014/main" id="{9BA6AA05-E0F4-4DDC-B747-2ECA234123D2}"/>
               </a:ext>
             </a:extLst>
           </p:cNvPr>
@@ -4987,7 +4987,7 @@
           <p:cNvPr id="15" name="">
             <a:extLst xmlns:a="http://schemas.openxmlformats.org/drawingml/2006/main">
               <a:ext uri="{FF2B5EF4-FFF2-40B4-BE49-F238E27FC236}">
-                <a16:creationId xmlns:a16="http://schemas.microsoft.com/office/drawing/2014/main" id="{3D55A3CD-397A-473F-9EA0-3D0AFB33E97C}"/>
+                <a16:creationId xmlns:a16="http://schemas.microsoft.com/office/drawing/2014/main" id="{9A1162E7-BAEB-4E1F-B85D-8D6AABD9B001}"/>
               </a:ext>
             </a:extLst>
           </p:cNvPr>
@@ -5032,7 +5032,7 @@
           <p:cNvPr id="16" name="badge-unverified-shelter-rumor">
             <a:extLst xmlns:a="http://schemas.openxmlformats.org/drawingml/2006/main">
               <a:ext uri="{FF2B5EF4-FFF2-40B4-BE49-F238E27FC236}">
-                <a16:creationId xmlns:a16="http://schemas.microsoft.com/office/drawing/2014/main" id="{ECEEC201-08D3-4F17-9D61-F58334806364}"/>
+                <a16:creationId xmlns:a16="http://schemas.microsoft.com/office/drawing/2014/main" id="{DC93771D-EA0B-4E3B-B1E8-76528F92CF02}"/>
               </a:ext>
             </a:extLst>
           </p:cNvPr>
@@ -5061,7 +5061,7 @@
           <p:cNvPr id="17" name="">
             <a:extLst xmlns:a="http://schemas.openxmlformats.org/drawingml/2006/main">
               <a:ext uri="{FF2B5EF4-FFF2-40B4-BE49-F238E27FC236}">
-                <a16:creationId xmlns:a16="http://schemas.microsoft.com/office/drawing/2014/main" id="{573B1461-2516-4636-AB53-6BFC89FD5668}"/>
+                <a16:creationId xmlns:a16="http://schemas.microsoft.com/office/drawing/2014/main" id="{80B8AE17-445B-42F3-9084-9B9519C988D0}"/>
               </a:ext>
             </a:extLst>
           </p:cNvPr>
@@ -5106,7 +5106,7 @@
           <p:cNvPr id="18" name="badge-floodwater-hazard">
             <a:extLst xmlns:a="http://schemas.openxmlformats.org/drawingml/2006/main">
               <a:ext uri="{FF2B5EF4-FFF2-40B4-BE49-F238E27FC236}">
-                <a16:creationId xmlns:a16="http://schemas.microsoft.com/office/drawing/2014/main" id="{115164DC-5FB9-4423-BFBE-79ADD9B7F161}"/>
+                <a16:creationId xmlns:a16="http://schemas.microsoft.com/office/drawing/2014/main" id="{AC81040C-5A96-4DA8-B6FA-324678420F40}"/>
               </a:ext>
             </a:extLst>
           </p:cNvPr>
@@ -5135,7 +5135,7 @@
           <p:cNvPr id="19" name="">
             <a:extLst xmlns:a="http://schemas.openxmlformats.org/drawingml/2006/main">
               <a:ext uri="{FF2B5EF4-FFF2-40B4-BE49-F238E27FC236}">
-                <a16:creationId xmlns:a16="http://schemas.microsoft.com/office/drawing/2014/main" id="{2DEE6B6B-7E7C-44CE-ABA2-51BEBA3F2A74}"/>
+                <a16:creationId xmlns:a16="http://schemas.microsoft.com/office/drawing/2014/main" id="{F28D7CAC-AD17-43B9-B2F7-3982FBBEA578}"/>
               </a:ext>
             </a:extLst>
           </p:cNvPr>
@@ -5180,7 +5180,7 @@
           <p:cNvPr id="20" name="badge-responder-escalation">
             <a:extLst xmlns:a="http://schemas.openxmlformats.org/drawingml/2006/main">
               <a:ext uri="{FF2B5EF4-FFF2-40B4-BE49-F238E27FC236}">
-                <a16:creationId xmlns:a16="http://schemas.microsoft.com/office/drawing/2014/main" id="{919D1BC0-9E63-4D2D-B475-F8E7662C1619}"/>
+                <a16:creationId xmlns:a16="http://schemas.microsoft.com/office/drawing/2014/main" id="{B6078D25-9C14-4976-B8B4-04E12DFB28F0}"/>
               </a:ext>
             </a:extLst>
           </p:cNvPr>
@@ -5209,7 +5209,7 @@
           <p:cNvPr id="21" name="">
             <a:extLst xmlns:a="http://schemas.openxmlformats.org/drawingml/2006/main">
               <a:ext uri="{FF2B5EF4-FFF2-40B4-BE49-F238E27FC236}">
-                <a16:creationId xmlns:a16="http://schemas.microsoft.com/office/drawing/2014/main" id="{E4888901-73E7-4ED2-9CC2-2F3635A274A7}"/>
+                <a16:creationId xmlns:a16="http://schemas.microsoft.com/office/drawing/2014/main" id="{9FAF0F34-8725-4BDB-A3C4-C3BA22DCCDA0}"/>
               </a:ext>
             </a:extLst>
           </p:cNvPr>
@@ -5252,7 +5252,7 @@
     </p:spTree>
     <p:extLst>
       <p:ext uri="{BB962C8B-B14F-4D97-AF65-F5344CB8AC3E}">
-        <p14:creationId xmlns:p14="http://schemas.microsoft.com/office/powerpoint/2010/main" val="1823285915"/>
+        <p14:creationId xmlns:p14="http://schemas.microsoft.com/office/powerpoint/2010/main" val="455392586"/>
       </p:ext>
     </p:extLst>
   </p:cSld>
@@ -5276,7 +5276,7 @@
           <p:cNvPr id="1" name="background">
             <a:extLst xmlns:a="http://schemas.openxmlformats.org/drawingml/2006/main">
               <a:ext uri="{FF2B5EF4-FFF2-40B4-BE49-F238E27FC236}">
-                <a16:creationId xmlns:a16="http://schemas.microsoft.com/office/drawing/2014/main" id="{FDCC9E56-26B0-408C-9EC3-15E3902BD7E0}"/>
+                <a16:creationId xmlns:a16="http://schemas.microsoft.com/office/drawing/2014/main" id="{F1DAB8DE-1346-4DCE-8E65-997CE9C44C62}"/>
               </a:ext>
             </a:extLst>
           </p:cNvPr>
@@ -5303,7 +5303,7 @@
           <p:cNvPr id="2" name="">
             <a:extLst xmlns:a="http://schemas.openxmlformats.org/drawingml/2006/main">
               <a:ext uri="{FF2B5EF4-FFF2-40B4-BE49-F238E27FC236}">
-                <a16:creationId xmlns:a16="http://schemas.microsoft.com/office/drawing/2014/main" id="{7F815DCD-FE55-414B-9A3A-28CA36B0E333}"/>
+                <a16:creationId xmlns:a16="http://schemas.microsoft.com/office/drawing/2014/main" id="{2AAFE63F-7EBA-437A-89D3-9EF0F61B1D04}"/>
               </a:ext>
             </a:extLst>
           </p:cNvPr>
@@ -5330,7 +5330,7 @@
           <p:cNvPr id="3" name="">
             <a:extLst xmlns:a="http://schemas.openxmlformats.org/drawingml/2006/main">
               <a:ext uri="{FF2B5EF4-FFF2-40B4-BE49-F238E27FC236}">
-                <a16:creationId xmlns:a16="http://schemas.microsoft.com/office/drawing/2014/main" id="{D870D755-FC50-4DD3-9F39-D3CD7A76295C}"/>
+                <a16:creationId xmlns:a16="http://schemas.microsoft.com/office/drawing/2014/main" id="{4972FFAB-3E34-4117-B231-102ABA0C90A3}"/>
               </a:ext>
             </a:extLst>
           </p:cNvPr>
@@ -5375,7 +5375,7 @@
           <p:cNvPr id="4" name="">
             <a:extLst xmlns:a="http://schemas.openxmlformats.org/drawingml/2006/main">
               <a:ext uri="{FF2B5EF4-FFF2-40B4-BE49-F238E27FC236}">
-                <a16:creationId xmlns:a16="http://schemas.microsoft.com/office/drawing/2014/main" id="{F8272E4E-E90E-4A4C-BBD1-207B0753981C}"/>
+                <a16:creationId xmlns:a16="http://schemas.microsoft.com/office/drawing/2014/main" id="{C5FE7818-652B-4705-9671-4D5FD38C38CC}"/>
               </a:ext>
             </a:extLst>
           </p:cNvPr>
@@ -5420,7 +5420,7 @@
           <p:cNvPr id="5" name="">
             <a:extLst xmlns:a="http://schemas.openxmlformats.org/drawingml/2006/main">
               <a:ext uri="{FF2B5EF4-FFF2-40B4-BE49-F238E27FC236}">
-                <a16:creationId xmlns:a16="http://schemas.microsoft.com/office/drawing/2014/main" id="{D39AAF68-4567-4634-8066-E71973A5FF98}"/>
+                <a16:creationId xmlns:a16="http://schemas.microsoft.com/office/drawing/2014/main" id="{01400FC5-FD5D-4162-8F7C-1DBBE573F549}"/>
               </a:ext>
             </a:extLst>
           </p:cNvPr>
@@ -5472,7 +5472,7 @@
         </p:xfrm>
         <a:graphic xmlns:a="http://schemas.openxmlformats.org/drawingml/2006/main">
           <a:graphicData uri="http://schemas.openxmlformats.org/drawingml/2006/chart">
-            <c:chart xmlns:r="http://schemas.openxmlformats.org/officeDocument/2006/relationships" xmlns:c="http://schemas.openxmlformats.org/drawingml/2006/chart" r:id="Rcb02850fae5c4309"/>
+            <c:chart xmlns:r="http://schemas.openxmlformats.org/officeDocument/2006/relationships" xmlns:c="http://schemas.openxmlformats.org/drawingml/2006/chart" r:id="Reb44abe68c3a4d15"/>
           </a:graphicData>
         </a:graphic>
       </p:graphicFrame>
@@ -5481,7 +5481,7 @@
           <p:cNvPr id="7" name="">
             <a:extLst xmlns:a="http://schemas.openxmlformats.org/drawingml/2006/main">
               <a:ext uri="{FF2B5EF4-FFF2-40B4-BE49-F238E27FC236}">
-                <a16:creationId xmlns:a16="http://schemas.microsoft.com/office/drawing/2014/main" id="{B77B0447-185D-418E-8DF1-2699FD16F787}"/>
+                <a16:creationId xmlns:a16="http://schemas.microsoft.com/office/drawing/2014/main" id="{D7E91095-ACDE-462B-9324-EBAF50F9DF86}"/>
               </a:ext>
             </a:extLst>
           </p:cNvPr>
@@ -5526,7 +5526,7 @@
           <p:cNvPr id="8" name="">
             <a:extLst xmlns:a="http://schemas.openxmlformats.org/drawingml/2006/main">
               <a:ext uri="{FF2B5EF4-FFF2-40B4-BE49-F238E27FC236}">
-                <a16:creationId xmlns:a16="http://schemas.microsoft.com/office/drawing/2014/main" id="{1BE5987B-519F-4747-A2BB-DC3F1641B228}"/>
+                <a16:creationId xmlns:a16="http://schemas.microsoft.com/office/drawing/2014/main" id="{086C4E62-CA16-4E56-8F0A-08950EDFA95C}"/>
               </a:ext>
             </a:extLst>
           </p:cNvPr>
@@ -5571,7 +5571,7 @@
           <p:cNvPr id="9" name="">
             <a:extLst xmlns:a="http://schemas.openxmlformats.org/drawingml/2006/main">
               <a:ext uri="{FF2B5EF4-FFF2-40B4-BE49-F238E27FC236}">
-                <a16:creationId xmlns:a16="http://schemas.microsoft.com/office/drawing/2014/main" id="{3A9C74AA-4C0B-4324-8F7D-6D69245B5012}"/>
+                <a16:creationId xmlns:a16="http://schemas.microsoft.com/office/drawing/2014/main" id="{B38C2F03-CAE6-4800-9CBF-85EF092695ED}"/>
               </a:ext>
             </a:extLst>
           </p:cNvPr>
@@ -5616,7 +5616,7 @@
           <p:cNvPr id="10" name="">
             <a:extLst xmlns:a="http://schemas.openxmlformats.org/drawingml/2006/main">
               <a:ext uri="{FF2B5EF4-FFF2-40B4-BE49-F238E27FC236}">
-                <a16:creationId xmlns:a16="http://schemas.microsoft.com/office/drawing/2014/main" id="{9283B6DD-67AD-40EF-AD7E-8377E5831866}"/>
+                <a16:creationId xmlns:a16="http://schemas.microsoft.com/office/drawing/2014/main" id="{1C89836F-3828-4503-A389-FE173AC28D06}"/>
               </a:ext>
             </a:extLst>
           </p:cNvPr>
@@ -5661,7 +5661,7 @@
           <p:cNvPr id="11" name="">
             <a:extLst xmlns:a="http://schemas.openxmlformats.org/drawingml/2006/main">
               <a:ext uri="{FF2B5EF4-FFF2-40B4-BE49-F238E27FC236}">
-                <a16:creationId xmlns:a16="http://schemas.microsoft.com/office/drawing/2014/main" id="{57611C75-25BD-4588-8D8F-026D8591B45C}"/>
+                <a16:creationId xmlns:a16="http://schemas.microsoft.com/office/drawing/2014/main" id="{925D28A0-0C15-4B5B-945A-8B3FF3C465F6}"/>
               </a:ext>
             </a:extLst>
           </p:cNvPr>
@@ -5696,7 +5696,7 @@
                   <a:srgbClr val="FF5A66"/>
                 </a:solidFill>
               </a:rPr>
-              <a:t>4/4</a:t>
+              <a:t>5/5</a:t>
             </a:r>
           </a:p>
         </p:txBody>
@@ -5706,7 +5706,7 @@
           <p:cNvPr id="12" name="">
             <a:extLst xmlns:a="http://schemas.openxmlformats.org/drawingml/2006/main">
               <a:ext uri="{FF2B5EF4-FFF2-40B4-BE49-F238E27FC236}">
-                <a16:creationId xmlns:a16="http://schemas.microsoft.com/office/drawing/2014/main" id="{08507BBF-B864-4EB4-9750-ADBBD7FA0097}"/>
+                <a16:creationId xmlns:a16="http://schemas.microsoft.com/office/drawing/2014/main" id="{AC67A56C-55CB-451E-90C9-4E9D8F39C69D}"/>
               </a:ext>
             </a:extLst>
           </p:cNvPr>
@@ -5751,7 +5751,7 @@
           <p:cNvPr id="13" name="footer">
             <a:extLst xmlns:a="http://schemas.openxmlformats.org/drawingml/2006/main">
               <a:ext uri="{FF2B5EF4-FFF2-40B4-BE49-F238E27FC236}">
-                <a16:creationId xmlns:a16="http://schemas.microsoft.com/office/drawing/2014/main" id="{54F8F018-CCB3-417A-9F92-6610618A01DF}"/>
+                <a16:creationId xmlns:a16="http://schemas.microsoft.com/office/drawing/2014/main" id="{C818BD44-32A9-4799-A548-2BBC163C3F1D}"/>
               </a:ext>
             </a:extLst>
           </p:cNvPr>
@@ -5794,7 +5794,7 @@
     </p:spTree>
     <p:extLst>
       <p:ext uri="{BB962C8B-B14F-4D97-AF65-F5344CB8AC3E}">
-        <p14:creationId xmlns:p14="http://schemas.microsoft.com/office/powerpoint/2010/main" val="1719177425"/>
+        <p14:creationId xmlns:p14="http://schemas.microsoft.com/office/powerpoint/2010/main" val="1924052551"/>
       </p:ext>
     </p:extLst>
   </p:cSld>
@@ -5818,7 +5818,7 @@
           <p:cNvPr id="1" name="background">
             <a:extLst xmlns:a="http://schemas.openxmlformats.org/drawingml/2006/main">
               <a:ext uri="{FF2B5EF4-FFF2-40B4-BE49-F238E27FC236}">
-                <a16:creationId xmlns:a16="http://schemas.microsoft.com/office/drawing/2014/main" id="{E39BA4BF-A542-416E-B6A5-64F4FF7E00EC}"/>
+                <a16:creationId xmlns:a16="http://schemas.microsoft.com/office/drawing/2014/main" id="{C7511343-61BE-428E-824E-5BFE37B73ACE}"/>
               </a:ext>
             </a:extLst>
           </p:cNvPr>
@@ -5845,7 +5845,7 @@
           <p:cNvPr id="2" name="">
             <a:extLst xmlns:a="http://schemas.openxmlformats.org/drawingml/2006/main">
               <a:ext uri="{FF2B5EF4-FFF2-40B4-BE49-F238E27FC236}">
-                <a16:creationId xmlns:a16="http://schemas.microsoft.com/office/drawing/2014/main" id="{2EBF5375-4A96-41BE-8569-3B06648E610C}"/>
+                <a16:creationId xmlns:a16="http://schemas.microsoft.com/office/drawing/2014/main" id="{7882B6A8-6F8F-4C22-954D-9789749C2730}"/>
               </a:ext>
             </a:extLst>
           </p:cNvPr>
@@ -5872,7 +5872,7 @@
           <p:cNvPr id="3" name="">
             <a:extLst xmlns:a="http://schemas.openxmlformats.org/drawingml/2006/main">
               <a:ext uri="{FF2B5EF4-FFF2-40B4-BE49-F238E27FC236}">
-                <a16:creationId xmlns:a16="http://schemas.microsoft.com/office/drawing/2014/main" id="{545AA36B-81F5-479D-A725-6084416B24C8}"/>
+                <a16:creationId xmlns:a16="http://schemas.microsoft.com/office/drawing/2014/main" id="{AF7D708B-3775-4D76-A29B-D40D1E6B3A76}"/>
               </a:ext>
             </a:extLst>
           </p:cNvPr>
@@ -5917,7 +5917,7 @@
           <p:cNvPr id="4" name="">
             <a:extLst xmlns:a="http://schemas.openxmlformats.org/drawingml/2006/main">
               <a:ext uri="{FF2B5EF4-FFF2-40B4-BE49-F238E27FC236}">
-                <a16:creationId xmlns:a16="http://schemas.microsoft.com/office/drawing/2014/main" id="{6C0A3ED2-E156-4FF2-BFCD-ACEE20BBFC73}"/>
+                <a16:creationId xmlns:a16="http://schemas.microsoft.com/office/drawing/2014/main" id="{1FBF3C4A-6376-4E54-ABFA-462CB2A83ACA}"/>
               </a:ext>
             </a:extLst>
           </p:cNvPr>
@@ -5962,7 +5962,7 @@
           <p:cNvPr id="5" name="">
             <a:extLst xmlns:a="http://schemas.openxmlformats.org/drawingml/2006/main">
               <a:ext uri="{FF2B5EF4-FFF2-40B4-BE49-F238E27FC236}">
-                <a16:creationId xmlns:a16="http://schemas.microsoft.com/office/drawing/2014/main" id="{4B9A9931-D3B1-4245-97E9-6698939C03B7}"/>
+                <a16:creationId xmlns:a16="http://schemas.microsoft.com/office/drawing/2014/main" id="{2D7CE0B9-73EA-404F-A1AD-81388BD33AAA}"/>
               </a:ext>
             </a:extLst>
           </p:cNvPr>
@@ -6007,7 +6007,7 @@
           <p:cNvPr id="6" name="badge-tesla-t4">
             <a:extLst xmlns:a="http://schemas.openxmlformats.org/drawingml/2006/main">
               <a:ext uri="{FF2B5EF4-FFF2-40B4-BE49-F238E27FC236}">
-                <a16:creationId xmlns:a16="http://schemas.microsoft.com/office/drawing/2014/main" id="{FA812B98-EDB6-4029-A1DB-BCE57AFAAD9F}"/>
+                <a16:creationId xmlns:a16="http://schemas.microsoft.com/office/drawing/2014/main" id="{05FC7A06-3BEC-45AA-A33D-90EA270B2203}"/>
               </a:ext>
             </a:extLst>
           </p:cNvPr>
@@ -6036,7 +6036,7 @@
           <p:cNvPr id="7" name="">
             <a:extLst xmlns:a="http://schemas.openxmlformats.org/drawingml/2006/main">
               <a:ext uri="{FF2B5EF4-FFF2-40B4-BE49-F238E27FC236}">
-                <a16:creationId xmlns:a16="http://schemas.microsoft.com/office/drawing/2014/main" id="{0A70F8FF-80E0-4D67-BEFC-86493E643FFB}"/>
+                <a16:creationId xmlns:a16="http://schemas.microsoft.com/office/drawing/2014/main" id="{FF51916C-156B-47E5-8EAE-D18ED872F759}"/>
               </a:ext>
             </a:extLst>
           </p:cNvPr>
@@ -6081,7 +6081,7 @@
           <p:cNvPr id="8" name="badge-160-new-tokens">
             <a:extLst xmlns:a="http://schemas.openxmlformats.org/drawingml/2006/main">
               <a:ext uri="{FF2B5EF4-FFF2-40B4-BE49-F238E27FC236}">
-                <a16:creationId xmlns:a16="http://schemas.microsoft.com/office/drawing/2014/main" id="{54681026-3A2B-4552-83FB-3B89FD091FE6}"/>
+                <a16:creationId xmlns:a16="http://schemas.microsoft.com/office/drawing/2014/main" id="{E977EE89-0837-4E34-B956-68D0284257F3}"/>
               </a:ext>
             </a:extLst>
           </p:cNvPr>
@@ -6110,7 +6110,7 @@
           <p:cNvPr id="9" name="">
             <a:extLst xmlns:a="http://schemas.openxmlformats.org/drawingml/2006/main">
               <a:ext uri="{FF2B5EF4-FFF2-40B4-BE49-F238E27FC236}">
-                <a16:creationId xmlns:a16="http://schemas.microsoft.com/office/drawing/2014/main" id="{167DD897-6209-442F-B17D-716C5FAF401B}"/>
+                <a16:creationId xmlns:a16="http://schemas.microsoft.com/office/drawing/2014/main" id="{5D15CCD2-42EF-4C70-836C-F8A4EE292565}"/>
               </a:ext>
             </a:extLst>
           </p:cNvPr>
@@ -6155,7 +6155,7 @@
           <p:cNvPr id="10" name="badge-18-014s-recorded-latency">
             <a:extLst xmlns:a="http://schemas.openxmlformats.org/drawingml/2006/main">
               <a:ext uri="{FF2B5EF4-FFF2-40B4-BE49-F238E27FC236}">
-                <a16:creationId xmlns:a16="http://schemas.microsoft.com/office/drawing/2014/main" id="{8D550E39-3F4C-424C-9064-FBD93FEC0CC3}"/>
+                <a16:creationId xmlns:a16="http://schemas.microsoft.com/office/drawing/2014/main" id="{5D4E2D87-8BB5-4C2C-B476-24B8CDD5325E}"/>
               </a:ext>
             </a:extLst>
           </p:cNvPr>
@@ -6184,7 +6184,7 @@
           <p:cNvPr id="11" name="">
             <a:extLst xmlns:a="http://schemas.openxmlformats.org/drawingml/2006/main">
               <a:ext uri="{FF2B5EF4-FFF2-40B4-BE49-F238E27FC236}">
-                <a16:creationId xmlns:a16="http://schemas.microsoft.com/office/drawing/2014/main" id="{0FB1C212-54D6-4253-8F89-B058D20108EA}"/>
+                <a16:creationId xmlns:a16="http://schemas.microsoft.com/office/drawing/2014/main" id="{0A96362F-2D61-47B3-BA00-D22692A64850}"/>
               </a:ext>
             </a:extLst>
           </p:cNvPr>
@@ -6229,7 +6229,7 @@
           <p:cNvPr id="12" name="">
             <a:extLst xmlns:a="http://schemas.openxmlformats.org/drawingml/2006/main">
               <a:ext uri="{FF2B5EF4-FFF2-40B4-BE49-F238E27FC236}">
-                <a16:creationId xmlns:a16="http://schemas.microsoft.com/office/drawing/2014/main" id="{23CDD245-1964-4B1D-8553-4843784A4966}"/>
+                <a16:creationId xmlns:a16="http://schemas.microsoft.com/office/drawing/2014/main" id="{8CD3DB13-5956-4E2E-BF6F-873B50869B67}"/>
               </a:ext>
             </a:extLst>
           </p:cNvPr>
@@ -6268,7 +6268,7 @@
           <p:nvPr/>
         </p:nvPicPr>
         <p:blipFill>
-          <a:blip xmlns:r="http://schemas.openxmlformats.org/officeDocument/2006/relationships" xmlns:a="http://schemas.openxmlformats.org/drawingml/2006/main" r:embed="R84dca1ade9054ba0"/>
+          <a:blip xmlns:r="http://schemas.openxmlformats.org/officeDocument/2006/relationships" xmlns:a="http://schemas.openxmlformats.org/drawingml/2006/main" r:embed="R63029c33cd7741e6"/>
           <a:stretch xmlns:a="http://schemas.openxmlformats.org/drawingml/2006/main"/>
         </p:blipFill>
         <p:spPr>
@@ -6284,7 +6284,7 @@
     </p:spTree>
     <p:extLst>
       <p:ext uri="{BB962C8B-B14F-4D97-AF65-F5344CB8AC3E}">
-        <p14:creationId xmlns:p14="http://schemas.microsoft.com/office/powerpoint/2010/main" val="177172480"/>
+        <p14:creationId xmlns:p14="http://schemas.microsoft.com/office/powerpoint/2010/main" val="1275719242"/>
       </p:ext>
     </p:extLst>
   </p:cSld>
@@ -6308,7 +6308,7 @@
           <p:cNvPr id="1" name="background">
             <a:extLst xmlns:a="http://schemas.openxmlformats.org/drawingml/2006/main">
               <a:ext uri="{FF2B5EF4-FFF2-40B4-BE49-F238E27FC236}">
-                <a16:creationId xmlns:a16="http://schemas.microsoft.com/office/drawing/2014/main" id="{E95A5B98-D3D7-4031-A94E-800270AB7076}"/>
+                <a16:creationId xmlns:a16="http://schemas.microsoft.com/office/drawing/2014/main" id="{65AD927D-86C2-4C56-B959-8FDCC794F58F}"/>
               </a:ext>
             </a:extLst>
           </p:cNvPr>
@@ -6335,7 +6335,7 @@
           <p:cNvPr id="2" name="">
             <a:extLst xmlns:a="http://schemas.openxmlformats.org/drawingml/2006/main">
               <a:ext uri="{FF2B5EF4-FFF2-40B4-BE49-F238E27FC236}">
-                <a16:creationId xmlns:a16="http://schemas.microsoft.com/office/drawing/2014/main" id="{8E42E366-71BF-4E5F-8076-63C43D3BE85C}"/>
+                <a16:creationId xmlns:a16="http://schemas.microsoft.com/office/drawing/2014/main" id="{44A9BB0A-D7BD-4C50-ACAF-8A73015425DE}"/>
               </a:ext>
             </a:extLst>
           </p:cNvPr>
@@ -6362,7 +6362,7 @@
           <p:cNvPr id="3" name="">
             <a:extLst xmlns:a="http://schemas.openxmlformats.org/drawingml/2006/main">
               <a:ext uri="{FF2B5EF4-FFF2-40B4-BE49-F238E27FC236}">
-                <a16:creationId xmlns:a16="http://schemas.microsoft.com/office/drawing/2014/main" id="{69B7E12D-E2ED-4B8F-9ED2-3729633CA427}"/>
+                <a16:creationId xmlns:a16="http://schemas.microsoft.com/office/drawing/2014/main" id="{6BB79A20-DED8-4C17-81EA-EAADBD48921E}"/>
               </a:ext>
             </a:extLst>
           </p:cNvPr>
@@ -6407,7 +6407,7 @@
           <p:cNvPr id="4" name="">
             <a:extLst xmlns:a="http://schemas.openxmlformats.org/drawingml/2006/main">
               <a:ext uri="{FF2B5EF4-FFF2-40B4-BE49-F238E27FC236}">
-                <a16:creationId xmlns:a16="http://schemas.microsoft.com/office/drawing/2014/main" id="{37C29637-638C-4D5A-AAC5-4C68636749F7}"/>
+                <a16:creationId xmlns:a16="http://schemas.microsoft.com/office/drawing/2014/main" id="{9D9C118D-62F0-4006-BD44-265CC8A9D38E}"/>
               </a:ext>
             </a:extLst>
           </p:cNvPr>
@@ -6452,7 +6452,7 @@
           <p:cNvPr id="5" name="">
             <a:extLst xmlns:a="http://schemas.openxmlformats.org/drawingml/2006/main">
               <a:ext uri="{FF2B5EF4-FFF2-40B4-BE49-F238E27FC236}">
-                <a16:creationId xmlns:a16="http://schemas.microsoft.com/office/drawing/2014/main" id="{EA35605B-6A98-4D7A-8EA8-DE62B44E2F04}"/>
+                <a16:creationId xmlns:a16="http://schemas.microsoft.com/office/drawing/2014/main" id="{B161BA29-D0D5-4A8B-AE3E-F789052A6A69}"/>
               </a:ext>
             </a:extLst>
           </p:cNvPr>
@@ -6497,7 +6497,7 @@
           <p:cNvPr id="6" name="">
             <a:extLst xmlns:a="http://schemas.openxmlformats.org/drawingml/2006/main">
               <a:ext uri="{FF2B5EF4-FFF2-40B4-BE49-F238E27FC236}">
-                <a16:creationId xmlns:a16="http://schemas.microsoft.com/office/drawing/2014/main" id="{33DDA112-62B9-4CF1-885B-589F06DC021D}"/>
+                <a16:creationId xmlns:a16="http://schemas.microsoft.com/office/drawing/2014/main" id="{44F2DBD8-B848-4AAB-90F5-1212224C3491}"/>
               </a:ext>
             </a:extLst>
           </p:cNvPr>
@@ -6526,7 +6526,7 @@
           <p:cNvPr id="7" name="">
             <a:extLst xmlns:a="http://schemas.openxmlformats.org/drawingml/2006/main">
               <a:ext uri="{FF2B5EF4-FFF2-40B4-BE49-F238E27FC236}">
-                <a16:creationId xmlns:a16="http://schemas.microsoft.com/office/drawing/2014/main" id="{BA8D7780-9035-4B82-88BA-920C755505BB}"/>
+                <a16:creationId xmlns:a16="http://schemas.microsoft.com/office/drawing/2014/main" id="{7AFC54CD-8BA7-40A3-B799-D4D356D9DB2A}"/>
               </a:ext>
             </a:extLst>
           </p:cNvPr>
@@ -6571,7 +6571,7 @@
           <p:cNvPr id="8" name="">
             <a:extLst xmlns:a="http://schemas.openxmlformats.org/drawingml/2006/main">
               <a:ext uri="{FF2B5EF4-FFF2-40B4-BE49-F238E27FC236}">
-                <a16:creationId xmlns:a16="http://schemas.microsoft.com/office/drawing/2014/main" id="{D499C346-0E48-4641-B0DA-7EE4F00D56C7}"/>
+                <a16:creationId xmlns:a16="http://schemas.microsoft.com/office/drawing/2014/main" id="{99B36B39-A834-4E5D-A8DD-5B9757917434}"/>
               </a:ext>
             </a:extLst>
           </p:cNvPr>
@@ -6616,7 +6616,7 @@
           <p:cNvPr id="9" name="">
             <a:extLst xmlns:a="http://schemas.openxmlformats.org/drawingml/2006/main">
               <a:ext uri="{FF2B5EF4-FFF2-40B4-BE49-F238E27FC236}">
-                <a16:creationId xmlns:a16="http://schemas.microsoft.com/office/drawing/2014/main" id="{8D8F9E8C-9C63-4EA3-BBD3-21F64A5F1E50}"/>
+                <a16:creationId xmlns:a16="http://schemas.microsoft.com/office/drawing/2014/main" id="{A0FA3228-773D-4FB2-9A04-CA1B82C4936A}"/>
               </a:ext>
             </a:extLst>
           </p:cNvPr>
@@ -6645,7 +6645,7 @@
           <p:cNvPr id="10" name="">
             <a:extLst xmlns:a="http://schemas.openxmlformats.org/drawingml/2006/main">
               <a:ext uri="{FF2B5EF4-FFF2-40B4-BE49-F238E27FC236}">
-                <a16:creationId xmlns:a16="http://schemas.microsoft.com/office/drawing/2014/main" id="{2E76ECB5-1FA9-4E76-83BA-F003D472ACCC}"/>
+                <a16:creationId xmlns:a16="http://schemas.microsoft.com/office/drawing/2014/main" id="{9A3EC04C-AC5E-4219-82A4-D4A426A18C28}"/>
               </a:ext>
             </a:extLst>
           </p:cNvPr>
@@ -6690,7 +6690,7 @@
           <p:cNvPr id="11" name="">
             <a:extLst xmlns:a="http://schemas.openxmlformats.org/drawingml/2006/main">
               <a:ext uri="{FF2B5EF4-FFF2-40B4-BE49-F238E27FC236}">
-                <a16:creationId xmlns:a16="http://schemas.microsoft.com/office/drawing/2014/main" id="{FAD6E467-1B69-413B-8D8B-91347806B4F1}"/>
+                <a16:creationId xmlns:a16="http://schemas.microsoft.com/office/drawing/2014/main" id="{E5609B85-AB31-4FAB-930B-C6EEA01C42AF}"/>
               </a:ext>
             </a:extLst>
           </p:cNvPr>
@@ -6735,7 +6735,7 @@
           <p:cNvPr id="12" name="">
             <a:extLst xmlns:a="http://schemas.openxmlformats.org/drawingml/2006/main">
               <a:ext uri="{FF2B5EF4-FFF2-40B4-BE49-F238E27FC236}">
-                <a16:creationId xmlns:a16="http://schemas.microsoft.com/office/drawing/2014/main" id="{3823C67B-2C5F-4480-97A3-7A425498CDAC}"/>
+                <a16:creationId xmlns:a16="http://schemas.microsoft.com/office/drawing/2014/main" id="{3E9C1AE2-B066-4C38-8C94-D7130CF9A6DC}"/>
               </a:ext>
             </a:extLst>
           </p:cNvPr>
@@ -6764,7 +6764,7 @@
           <p:cNvPr id="13" name="">
             <a:extLst xmlns:a="http://schemas.openxmlformats.org/drawingml/2006/main">
               <a:ext uri="{FF2B5EF4-FFF2-40B4-BE49-F238E27FC236}">
-                <a16:creationId xmlns:a16="http://schemas.microsoft.com/office/drawing/2014/main" id="{126818B7-628A-4955-907A-8A8CE88E7C69}"/>
+                <a16:creationId xmlns:a16="http://schemas.microsoft.com/office/drawing/2014/main" id="{70EAB026-B352-4A62-9648-A3A77CA3224F}"/>
               </a:ext>
             </a:extLst>
           </p:cNvPr>
@@ -6809,7 +6809,7 @@
           <p:cNvPr id="14" name="">
             <a:extLst xmlns:a="http://schemas.openxmlformats.org/drawingml/2006/main">
               <a:ext uri="{FF2B5EF4-FFF2-40B4-BE49-F238E27FC236}">
-                <a16:creationId xmlns:a16="http://schemas.microsoft.com/office/drawing/2014/main" id="{81CF1F9C-EEBD-438F-8A21-F669247C9CAC}"/>
+                <a16:creationId xmlns:a16="http://schemas.microsoft.com/office/drawing/2014/main" id="{29E6D789-6E0C-4CCE-BC47-95EA30D19865}"/>
               </a:ext>
             </a:extLst>
           </p:cNvPr>
@@ -6854,7 +6854,7 @@
           <p:cNvPr id="15" name="footer">
             <a:extLst xmlns:a="http://schemas.openxmlformats.org/drawingml/2006/main">
               <a:ext uri="{FF2B5EF4-FFF2-40B4-BE49-F238E27FC236}">
-                <a16:creationId xmlns:a16="http://schemas.microsoft.com/office/drawing/2014/main" id="{63CD3288-470D-4437-9683-9688EE97D6AA}"/>
+                <a16:creationId xmlns:a16="http://schemas.microsoft.com/office/drawing/2014/main" id="{3605C099-5D30-435F-8F89-CDF071096EED}"/>
               </a:ext>
             </a:extLst>
           </p:cNvPr>
@@ -6897,7 +6897,7 @@
     </p:spTree>
     <p:extLst>
       <p:ext uri="{BB962C8B-B14F-4D97-AF65-F5344CB8AC3E}">
-        <p14:creationId xmlns:p14="http://schemas.microsoft.com/office/powerpoint/2010/main" val="523853287"/>
+        <p14:creationId xmlns:p14="http://schemas.microsoft.com/office/powerpoint/2010/main" val="1659834039"/>
       </p:ext>
     </p:extLst>
   </p:cSld>

</xml_diff>

<commit_message>
Add official resource routing checks
Refreshes README, static demo, pitch deck, and evidence bundle after the 6/6 official-resource-routing validation pass.
</commit_message>
<xml_diff>
--- a/resilience_copilot_pitch_v2.pptx
+++ b/resilience_copilot_pitch_v2.pptx
@@ -2,20 +2,20 @@
 <file path=ppt/presentation.xml><?xml version="1.0" encoding="utf-8"?>
 <p:presentation xmlns:p="http://schemas.openxmlformats.org/presentationml/2006/main">
   <p:sldMasterIdLst>
-    <p:sldMasterId xmlns:r="http://schemas.openxmlformats.org/officeDocument/2006/relationships" id="2147483648" r:id="Rbc11bd6f84164f8b"/>
+    <p:sldMasterId xmlns:r="http://schemas.openxmlformats.org/officeDocument/2006/relationships" id="2147483648" r:id="R413a699b948c4c0b"/>
   </p:sldMasterIdLst>
   <p:notesMasterIdLst>
-    <p:notesMasterId xmlns:r="http://schemas.openxmlformats.org/officeDocument/2006/relationships" r:id="R57aef327187c4408"/>
+    <p:notesMasterId xmlns:r="http://schemas.openxmlformats.org/officeDocument/2006/relationships" r:id="R059d02a8074141b5"/>
   </p:notesMasterIdLst>
   <p:sldIdLst>
-    <p:sldId xmlns:r="http://schemas.openxmlformats.org/officeDocument/2006/relationships" id="256" r:id="Rdd00103168c343ba"/>
-    <p:sldId xmlns:r="http://schemas.openxmlformats.org/officeDocument/2006/relationships" id="257" r:id="R06886fad992a474a"/>
-    <p:sldId xmlns:r="http://schemas.openxmlformats.org/officeDocument/2006/relationships" id="258" r:id="Ra24b02fd6cfc4a4d"/>
-    <p:sldId xmlns:r="http://schemas.openxmlformats.org/officeDocument/2006/relationships" id="259" r:id="R9ac742180f234fc9"/>
-    <p:sldId xmlns:r="http://schemas.openxmlformats.org/officeDocument/2006/relationships" id="260" r:id="R87b5aa5e7bac4bd7"/>
-    <p:sldId xmlns:r="http://schemas.openxmlformats.org/officeDocument/2006/relationships" id="261" r:id="Rd4ce05ef30a643da"/>
-    <p:sldId xmlns:r="http://schemas.openxmlformats.org/officeDocument/2006/relationships" id="262" r:id="R1c5e654dbc8e43a4"/>
-    <p:sldId xmlns:r="http://schemas.openxmlformats.org/officeDocument/2006/relationships" id="263" r:id="R55fddb203b1945fc"/>
+    <p:sldId xmlns:r="http://schemas.openxmlformats.org/officeDocument/2006/relationships" id="256" r:id="Rac03978c22ab41d6"/>
+    <p:sldId xmlns:r="http://schemas.openxmlformats.org/officeDocument/2006/relationships" id="257" r:id="R5dec164cd17648a0"/>
+    <p:sldId xmlns:r="http://schemas.openxmlformats.org/officeDocument/2006/relationships" id="258" r:id="R73fef34d4c6342b9"/>
+    <p:sldId xmlns:r="http://schemas.openxmlformats.org/officeDocument/2006/relationships" id="259" r:id="Rec6d31c428814424"/>
+    <p:sldId xmlns:r="http://schemas.openxmlformats.org/officeDocument/2006/relationships" id="260" r:id="Re8c6c5d06f564675"/>
+    <p:sldId xmlns:r="http://schemas.openxmlformats.org/officeDocument/2006/relationships" id="261" r:id="R6622a9eb7b084591"/>
+    <p:sldId xmlns:r="http://schemas.openxmlformats.org/officeDocument/2006/relationships" id="262" r:id="Reb17b779b8f441c8"/>
+    <p:sldId xmlns:r="http://schemas.openxmlformats.org/officeDocument/2006/relationships" id="263" r:id="Rbed4335f502c48fd"/>
   </p:sldIdLst>
   <p:sldSz cx="18288000" cy="10287000"/>
   <p:notesSz cx="6858000" cy="9144000"/>
@@ -1024,7 +1024,7 @@
   </p:cSld>
   <p:clrMap bg1="lt1" tx1="dk1" bg2="lt2" tx2="dk2" accent1="accent1" accent2="accent2" accent3="accent3" accent4="accent4" accent5="accent5" accent6="accent6" hlink="hlink" folHlink="folHlink"/>
   <p:sldLayoutIdLst>
-    <p:sldLayoutId xmlns:r="http://schemas.openxmlformats.org/officeDocument/2006/relationships" id="2147483649" r:id="R405d943c95214bc9"/>
+    <p:sldLayoutId xmlns:r="http://schemas.openxmlformats.org/officeDocument/2006/relationships" id="2147483649" r:id="R4fb301c150c04e21"/>
   </p:sldLayoutIdLst>
   <p:txStyles>
     <p:titleStyle>
@@ -1363,7 +1363,7 @@
                 <c:v>2</c:v>
               </c:pt>
               <c:pt idx="2">
-                <c:v>5</c:v>
+                <c:v>6</c:v>
               </c:pt>
             </c:numLit>
           </c:val>
@@ -1399,7 +1399,7 @@
                 <c:v>2</c:v>
               </c:pt>
               <c:pt idx="2">
-                <c:v>5</c:v>
+                <c:v>6</c:v>
               </c:pt>
             </c:numLit>
           </c:val>
@@ -1515,7 +1515,7 @@
           <p:cNvPr id="1" name="background">
             <a:extLst xmlns:a="http://schemas.openxmlformats.org/drawingml/2006/main">
               <a:ext uri="{FF2B5EF4-FFF2-40B4-BE49-F238E27FC236}">
-                <a16:creationId xmlns:a16="http://schemas.microsoft.com/office/drawing/2014/main" id="{CDB85DEC-0B99-48A0-9D12-1B23EFAE5556}"/>
+                <a16:creationId xmlns:a16="http://schemas.microsoft.com/office/drawing/2014/main" id="{BDF78D5A-B8D7-41A8-87E8-1BD9893EC830}"/>
               </a:ext>
             </a:extLst>
           </p:cNvPr>
@@ -1542,7 +1542,7 @@
           <p:cNvPr id="2" name="badge-gemma-4-good">
             <a:extLst xmlns:a="http://schemas.openxmlformats.org/drawingml/2006/main">
               <a:ext uri="{FF2B5EF4-FFF2-40B4-BE49-F238E27FC236}">
-                <a16:creationId xmlns:a16="http://schemas.microsoft.com/office/drawing/2014/main" id="{6CD1382F-382D-4D01-9E2A-9869B62E5040}"/>
+                <a16:creationId xmlns:a16="http://schemas.microsoft.com/office/drawing/2014/main" id="{417CD06F-871B-48F4-884C-403FB37AACC7}"/>
               </a:ext>
             </a:extLst>
           </p:cNvPr>
@@ -1571,7 +1571,7 @@
           <p:cNvPr id="3" name="">
             <a:extLst xmlns:a="http://schemas.openxmlformats.org/drawingml/2006/main">
               <a:ext uri="{FF2B5EF4-FFF2-40B4-BE49-F238E27FC236}">
-                <a16:creationId xmlns:a16="http://schemas.microsoft.com/office/drawing/2014/main" id="{7A4376DA-5B53-476A-AD09-A1DCD9579A7F}"/>
+                <a16:creationId xmlns:a16="http://schemas.microsoft.com/office/drawing/2014/main" id="{56E929E3-4EDB-4521-8389-2E9823B64D61}"/>
               </a:ext>
             </a:extLst>
           </p:cNvPr>
@@ -1616,7 +1616,7 @@
           <p:cNvPr id="4" name="badge-safety-first-crisis-ai">
             <a:extLst xmlns:a="http://schemas.openxmlformats.org/drawingml/2006/main">
               <a:ext uri="{FF2B5EF4-FFF2-40B4-BE49-F238E27FC236}">
-                <a16:creationId xmlns:a16="http://schemas.microsoft.com/office/drawing/2014/main" id="{8B43C3B5-A675-494E-A815-CA7289F3ECCF}"/>
+                <a16:creationId xmlns:a16="http://schemas.microsoft.com/office/drawing/2014/main" id="{8F20C630-27FF-4CB8-B248-E47A04781B12}"/>
               </a:ext>
             </a:extLst>
           </p:cNvPr>
@@ -1645,7 +1645,7 @@
           <p:cNvPr id="5" name="">
             <a:extLst xmlns:a="http://schemas.openxmlformats.org/drawingml/2006/main">
               <a:ext uri="{FF2B5EF4-FFF2-40B4-BE49-F238E27FC236}">
-                <a16:creationId xmlns:a16="http://schemas.microsoft.com/office/drawing/2014/main" id="{F5F59C55-4261-41BF-8DDB-BD59F181EDC2}"/>
+                <a16:creationId xmlns:a16="http://schemas.microsoft.com/office/drawing/2014/main" id="{2D4CEE7F-DEEF-4E6D-8391-3422A2C2784B}"/>
               </a:ext>
             </a:extLst>
           </p:cNvPr>
@@ -1690,7 +1690,7 @@
           <p:cNvPr id="6" name="">
             <a:extLst xmlns:a="http://schemas.openxmlformats.org/drawingml/2006/main">
               <a:ext uri="{FF2B5EF4-FFF2-40B4-BE49-F238E27FC236}">
-                <a16:creationId xmlns:a16="http://schemas.microsoft.com/office/drawing/2014/main" id="{A8063E23-4AB6-48FE-A1D0-28F8506F3806}"/>
+                <a16:creationId xmlns:a16="http://schemas.microsoft.com/office/drawing/2014/main" id="{E4C653AE-0A84-4EC1-8862-36E874A25CAE}"/>
               </a:ext>
             </a:extLst>
           </p:cNvPr>
@@ -1752,7 +1752,7 @@
           <p:cNvPr id="7" name="">
             <a:extLst xmlns:a="http://schemas.openxmlformats.org/drawingml/2006/main">
               <a:ext uri="{FF2B5EF4-FFF2-40B4-BE49-F238E27FC236}">
-                <a16:creationId xmlns:a16="http://schemas.microsoft.com/office/drawing/2014/main" id="{227F7CE9-A81C-4CB5-B536-3A58E998981D}"/>
+                <a16:creationId xmlns:a16="http://schemas.microsoft.com/office/drawing/2014/main" id="{0A3D1095-6438-47C8-831D-AC86E60A3F9B}"/>
               </a:ext>
             </a:extLst>
           </p:cNvPr>
@@ -1787,7 +1787,7 @@
                   <a:srgbClr val="DDE5EE"/>
                 </a:solidFill>
               </a:rPr>
-              <a:t>A field-ready assistant that turns messy disaster notes into safer responder handoffs.</a:t>
+              <a:t>A field-ready assistant that turns messy disaster notes into official checks and safer responder handoffs.</a:t>
             </a:r>
           </a:p>
         </p:txBody>
@@ -1797,7 +1797,7 @@
           <p:cNvPr id="8" name="">
             <a:extLst xmlns:a="http://schemas.openxmlformats.org/drawingml/2006/main">
               <a:ext uri="{FF2B5EF4-FFF2-40B4-BE49-F238E27FC236}">
-                <a16:creationId xmlns:a16="http://schemas.microsoft.com/office/drawing/2014/main" id="{2FA334D5-997B-4126-A689-E20805587643}"/>
+                <a16:creationId xmlns:a16="http://schemas.microsoft.com/office/drawing/2014/main" id="{8F16D7A4-317B-4CAE-B3CE-CF3947461FC2}"/>
               </a:ext>
             </a:extLst>
           </p:cNvPr>
@@ -1826,7 +1826,7 @@
           <p:cNvPr id="9" name="">
             <a:extLst xmlns:a="http://schemas.openxmlformats.org/drawingml/2006/main">
               <a:ext uri="{FF2B5EF4-FFF2-40B4-BE49-F238E27FC236}">
-                <a16:creationId xmlns:a16="http://schemas.microsoft.com/office/drawing/2014/main" id="{3EA8C7B6-C80B-44DB-B1C4-8D7D95921ACF}"/>
+                <a16:creationId xmlns:a16="http://schemas.microsoft.com/office/drawing/2014/main" id="{477D962A-41E6-4A66-AB66-0118C4F5C133}"/>
               </a:ext>
             </a:extLst>
           </p:cNvPr>
@@ -1849,19 +1849,19 @@
           <a:lstStyle xmlns:a="http://schemas.openxmlformats.org/drawingml/2006/main"/>
           <a:p xmlns:a="http://schemas.openxmlformats.org/drawingml/2006/main">
             <a:pPr>
-              <a:defRPr sz="1800" b="1">
+              <a:defRPr sz="1650" b="1">
                 <a:solidFill>
                   <a:srgbClr val="10151F"/>
                 </a:solidFill>
               </a:defRPr>
             </a:pPr>
             <a:r>
-              <a:rPr sz="1800" b="1">
+              <a:rPr sz="1650" b="1">
                 <a:solidFill>
                   <a:srgbClr val="10151F"/>
                 </a:solidFill>
               </a:rPr>
-              <a:t>rough note -&gt; risk sidecar -&gt; Gemma 4 response -&gt; responder handoff</a:t>
+              <a:t>rough note -&gt; risk sidecar -&gt; official checks -&gt; Gemma 4 -&gt; handoff</a:t>
             </a:r>
           </a:p>
         </p:txBody>
@@ -1871,7 +1871,7 @@
           <p:cNvPr id="10" name="">
             <a:extLst xmlns:a="http://schemas.openxmlformats.org/drawingml/2006/main">
               <a:ext uri="{FF2B5EF4-FFF2-40B4-BE49-F238E27FC236}">
-                <a16:creationId xmlns:a16="http://schemas.microsoft.com/office/drawing/2014/main" id="{7E263490-2018-4164-ACC8-7209C042F913}"/>
+                <a16:creationId xmlns:a16="http://schemas.microsoft.com/office/drawing/2014/main" id="{40801D48-15AD-4B4C-8718-A169C92215E4}"/>
               </a:ext>
             </a:extLst>
           </p:cNvPr>
@@ -1910,16 +1910,13 @@
           <p:nvPr/>
         </p:nvPicPr>
         <p:blipFill>
-          <a:blip xmlns:r="http://schemas.openxmlformats.org/officeDocument/2006/relationships" xmlns:a="http://schemas.openxmlformats.org/drawingml/2006/main" r:embed="R5cef95f4ff0041a5"/>
-          <a:srcRect xmlns:a="http://schemas.openxmlformats.org/drawingml/2006/main" l="8504" t="0" r="8504" b="0"/>
-          <a:stretch xmlns:a="http://schemas.openxmlformats.org/drawingml/2006/main">
-            <a:fillRect l="0" t="0" r="0" b="0"/>
-          </a:stretch>
+          <a:blip xmlns:r="http://schemas.openxmlformats.org/officeDocument/2006/relationships" xmlns:a="http://schemas.openxmlformats.org/drawingml/2006/main" r:embed="Rdf53345680eb4dd6"/>
+          <a:stretch xmlns:a="http://schemas.openxmlformats.org/drawingml/2006/main"/>
         </p:blipFill>
         <p:spPr>
           <a:xfrm xmlns:a="http://schemas.openxmlformats.org/drawingml/2006/main">
-            <a:off x="9871710" y="1657350"/>
-            <a:ext cx="7482840" cy="7620000"/>
+            <a:off x="9871710" y="2869142"/>
+            <a:ext cx="7482840" cy="5196417"/>
           </a:xfrm>
           <a:prstGeom xmlns:a="http://schemas.openxmlformats.org/drawingml/2006/main" prst="rect">
             <a:avLst/>
@@ -1929,7 +1926,7 @@
     </p:spTree>
     <p:extLst>
       <p:ext uri="{BB962C8B-B14F-4D97-AF65-F5344CB8AC3E}">
-        <p14:creationId xmlns:p14="http://schemas.microsoft.com/office/powerpoint/2010/main" val="395040374"/>
+        <p14:creationId xmlns:p14="http://schemas.microsoft.com/office/powerpoint/2010/main" val="1503214366"/>
       </p:ext>
     </p:extLst>
   </p:cSld>
@@ -1953,7 +1950,7 @@
           <p:cNvPr id="1" name="background">
             <a:extLst xmlns:a="http://schemas.openxmlformats.org/drawingml/2006/main">
               <a:ext uri="{FF2B5EF4-FFF2-40B4-BE49-F238E27FC236}">
-                <a16:creationId xmlns:a16="http://schemas.microsoft.com/office/drawing/2014/main" id="{A0614F06-9FFB-42EA-A2BD-8B63D75E79D7}"/>
+                <a16:creationId xmlns:a16="http://schemas.microsoft.com/office/drawing/2014/main" id="{038E78A9-E8AC-4CE5-A8DF-6CEC380576F8}"/>
               </a:ext>
             </a:extLst>
           </p:cNvPr>
@@ -1980,7 +1977,7 @@
           <p:cNvPr id="2" name="">
             <a:extLst xmlns:a="http://schemas.openxmlformats.org/drawingml/2006/main">
               <a:ext uri="{FF2B5EF4-FFF2-40B4-BE49-F238E27FC236}">
-                <a16:creationId xmlns:a16="http://schemas.microsoft.com/office/drawing/2014/main" id="{DFA49C8D-B55D-4F95-93FD-F153D2935DFB}"/>
+                <a16:creationId xmlns:a16="http://schemas.microsoft.com/office/drawing/2014/main" id="{A34CBA58-580C-4A8B-BD78-AE90F64CB243}"/>
               </a:ext>
             </a:extLst>
           </p:cNvPr>
@@ -2007,7 +2004,7 @@
           <p:cNvPr id="3" name="">
             <a:extLst xmlns:a="http://schemas.openxmlformats.org/drawingml/2006/main">
               <a:ext uri="{FF2B5EF4-FFF2-40B4-BE49-F238E27FC236}">
-                <a16:creationId xmlns:a16="http://schemas.microsoft.com/office/drawing/2014/main" id="{48F43E79-E4DC-4BEB-9468-A198B4AB1DA9}"/>
+                <a16:creationId xmlns:a16="http://schemas.microsoft.com/office/drawing/2014/main" id="{875AC760-0DB4-4B8E-AB86-F1F4419DB441}"/>
               </a:ext>
             </a:extLst>
           </p:cNvPr>
@@ -2052,7 +2049,7 @@
           <p:cNvPr id="4" name="">
             <a:extLst xmlns:a="http://schemas.openxmlformats.org/drawingml/2006/main">
               <a:ext uri="{FF2B5EF4-FFF2-40B4-BE49-F238E27FC236}">
-                <a16:creationId xmlns:a16="http://schemas.microsoft.com/office/drawing/2014/main" id="{8FBD8109-E5D6-4069-BAAD-AD88CD043EF3}"/>
+                <a16:creationId xmlns:a16="http://schemas.microsoft.com/office/drawing/2014/main" id="{8B7F4571-3D2E-45B5-8E33-9D1819E3D3FA}"/>
               </a:ext>
             </a:extLst>
           </p:cNvPr>
@@ -2097,7 +2094,7 @@
           <p:cNvPr id="5" name="">
             <a:extLst xmlns:a="http://schemas.openxmlformats.org/drawingml/2006/main">
               <a:ext uri="{FF2B5EF4-FFF2-40B4-BE49-F238E27FC236}">
-                <a16:creationId xmlns:a16="http://schemas.microsoft.com/office/drawing/2014/main" id="{828B8C0A-4F7C-4FCE-AB87-6AE4F85F3C77}"/>
+                <a16:creationId xmlns:a16="http://schemas.microsoft.com/office/drawing/2014/main" id="{C4AD25A9-CB11-4076-B423-3654407C59EA}"/>
               </a:ext>
             </a:extLst>
           </p:cNvPr>
@@ -2142,7 +2139,7 @@
           <p:cNvPr id="6" name="footer">
             <a:extLst xmlns:a="http://schemas.openxmlformats.org/drawingml/2006/main">
               <a:ext uri="{FF2B5EF4-FFF2-40B4-BE49-F238E27FC236}">
-                <a16:creationId xmlns:a16="http://schemas.microsoft.com/office/drawing/2014/main" id="{E524297C-9591-4056-A3F2-61B15E71C012}"/>
+                <a16:creationId xmlns:a16="http://schemas.microsoft.com/office/drawing/2014/main" id="{80390FF7-8041-4F21-86C6-9BD6EC99D0D3}"/>
               </a:ext>
             </a:extLst>
           </p:cNvPr>
@@ -2187,7 +2184,7 @@
           <p:cNvPr id="7" name="">
             <a:extLst xmlns:a="http://schemas.openxmlformats.org/drawingml/2006/main">
               <a:ext uri="{FF2B5EF4-FFF2-40B4-BE49-F238E27FC236}">
-                <a16:creationId xmlns:a16="http://schemas.microsoft.com/office/drawing/2014/main" id="{4461E4D9-B82B-46C2-8190-CA302E88ECCF}"/>
+                <a16:creationId xmlns:a16="http://schemas.microsoft.com/office/drawing/2014/main" id="{C0C5ECC9-A418-4316-BEC4-8B16AE2228CE}"/>
               </a:ext>
             </a:extLst>
           </p:cNvPr>
@@ -2222,7 +2219,7 @@
           <p:cNvPr id="8" name="">
             <a:extLst xmlns:a="http://schemas.openxmlformats.org/drawingml/2006/main">
               <a:ext uri="{FF2B5EF4-FFF2-40B4-BE49-F238E27FC236}">
-                <a16:creationId xmlns:a16="http://schemas.microsoft.com/office/drawing/2014/main" id="{7E104DAD-D44D-4349-B738-D5C4679C01CA}"/>
+                <a16:creationId xmlns:a16="http://schemas.microsoft.com/office/drawing/2014/main" id="{B42A1FEA-B1AC-4907-AC49-10DD0C30FBD1}"/>
               </a:ext>
             </a:extLst>
           </p:cNvPr>
@@ -2249,7 +2246,7 @@
           <p:cNvPr id="9" name="">
             <a:extLst xmlns:a="http://schemas.openxmlformats.org/drawingml/2006/main">
               <a:ext uri="{FF2B5EF4-FFF2-40B4-BE49-F238E27FC236}">
-                <a16:creationId xmlns:a16="http://schemas.microsoft.com/office/drawing/2014/main" id="{8B0B4C2C-A20A-4AC9-8ED6-C6C83D1E6AA9}"/>
+                <a16:creationId xmlns:a16="http://schemas.microsoft.com/office/drawing/2014/main" id="{EBA6B967-C33E-4512-B492-EF02521A24F6}"/>
               </a:ext>
             </a:extLst>
           </p:cNvPr>
@@ -2294,7 +2291,7 @@
           <p:cNvPr id="10" name="">
             <a:extLst xmlns:a="http://schemas.openxmlformats.org/drawingml/2006/main">
               <a:ext uri="{FF2B5EF4-FFF2-40B4-BE49-F238E27FC236}">
-                <a16:creationId xmlns:a16="http://schemas.microsoft.com/office/drawing/2014/main" id="{F1613CD6-BBE7-475D-BE38-EA7BBE65F2C8}"/>
+                <a16:creationId xmlns:a16="http://schemas.microsoft.com/office/drawing/2014/main" id="{C04EE216-DA27-48F7-825D-EAEB29B25D03}"/>
               </a:ext>
             </a:extLst>
           </p:cNvPr>
@@ -2339,7 +2336,7 @@
           <p:cNvPr id="11" name="">
             <a:extLst xmlns:a="http://schemas.openxmlformats.org/drawingml/2006/main">
               <a:ext uri="{FF2B5EF4-FFF2-40B4-BE49-F238E27FC236}">
-                <a16:creationId xmlns:a16="http://schemas.microsoft.com/office/drawing/2014/main" id="{48EE42AE-DF94-4950-A153-C6D860D695E8}"/>
+                <a16:creationId xmlns:a16="http://schemas.microsoft.com/office/drawing/2014/main" id="{893B474A-B6C4-4D8A-BA3A-CD576FBF403F}"/>
               </a:ext>
             </a:extLst>
           </p:cNvPr>
@@ -2366,7 +2363,7 @@
           <p:cNvPr id="12" name="">
             <a:extLst xmlns:a="http://schemas.openxmlformats.org/drawingml/2006/main">
               <a:ext uri="{FF2B5EF4-FFF2-40B4-BE49-F238E27FC236}">
-                <a16:creationId xmlns:a16="http://schemas.microsoft.com/office/drawing/2014/main" id="{AFC0ABEF-FA4D-47FE-A137-3D350873AED1}"/>
+                <a16:creationId xmlns:a16="http://schemas.microsoft.com/office/drawing/2014/main" id="{8E507736-411E-4B59-93DB-F2301AE39669}"/>
               </a:ext>
             </a:extLst>
           </p:cNvPr>
@@ -2411,7 +2408,7 @@
           <p:cNvPr id="13" name="">
             <a:extLst xmlns:a="http://schemas.openxmlformats.org/drawingml/2006/main">
               <a:ext uri="{FF2B5EF4-FFF2-40B4-BE49-F238E27FC236}">
-                <a16:creationId xmlns:a16="http://schemas.microsoft.com/office/drawing/2014/main" id="{EB70C86B-C366-4E80-A309-9D63938C2518}"/>
+                <a16:creationId xmlns:a16="http://schemas.microsoft.com/office/drawing/2014/main" id="{1F42C0AF-F76E-44B4-AAE7-A4CAFF60B4DE}"/>
               </a:ext>
             </a:extLst>
           </p:cNvPr>
@@ -2456,7 +2453,7 @@
           <p:cNvPr id="14" name="">
             <a:extLst xmlns:a="http://schemas.openxmlformats.org/drawingml/2006/main">
               <a:ext uri="{FF2B5EF4-FFF2-40B4-BE49-F238E27FC236}">
-                <a16:creationId xmlns:a16="http://schemas.microsoft.com/office/drawing/2014/main" id="{26AE3A30-0595-4CF5-AFB7-C6A984C89B39}"/>
+                <a16:creationId xmlns:a16="http://schemas.microsoft.com/office/drawing/2014/main" id="{9599B378-3AC4-4445-9895-63166D1EC029}"/>
               </a:ext>
             </a:extLst>
           </p:cNvPr>
@@ -2483,7 +2480,7 @@
           <p:cNvPr id="15" name="">
             <a:extLst xmlns:a="http://schemas.openxmlformats.org/drawingml/2006/main">
               <a:ext uri="{FF2B5EF4-FFF2-40B4-BE49-F238E27FC236}">
-                <a16:creationId xmlns:a16="http://schemas.microsoft.com/office/drawing/2014/main" id="{84CA2582-ECBA-4642-9700-F25A4DA8C008}"/>
+                <a16:creationId xmlns:a16="http://schemas.microsoft.com/office/drawing/2014/main" id="{3544F09C-0477-4000-BC32-11D04DF5CEAB}"/>
               </a:ext>
             </a:extLst>
           </p:cNvPr>
@@ -2528,7 +2525,7 @@
           <p:cNvPr id="16" name="">
             <a:extLst xmlns:a="http://schemas.openxmlformats.org/drawingml/2006/main">
               <a:ext uri="{FF2B5EF4-FFF2-40B4-BE49-F238E27FC236}">
-                <a16:creationId xmlns:a16="http://schemas.microsoft.com/office/drawing/2014/main" id="{E7DEE004-89F6-4980-AD01-23548AB5B594}"/>
+                <a16:creationId xmlns:a16="http://schemas.microsoft.com/office/drawing/2014/main" id="{AB4BF60A-EAEC-4903-A665-F5BE10A2AA24}"/>
               </a:ext>
             </a:extLst>
           </p:cNvPr>
@@ -2573,7 +2570,7 @@
           <p:cNvPr id="17" name="">
             <a:extLst xmlns:a="http://schemas.openxmlformats.org/drawingml/2006/main">
               <a:ext uri="{FF2B5EF4-FFF2-40B4-BE49-F238E27FC236}">
-                <a16:creationId xmlns:a16="http://schemas.microsoft.com/office/drawing/2014/main" id="{78FA254B-1C8E-4459-AEB2-25401E634655}"/>
+                <a16:creationId xmlns:a16="http://schemas.microsoft.com/office/drawing/2014/main" id="{E44BE4DC-B8E5-4BFF-B7E8-3B3D84ED9834}"/>
               </a:ext>
             </a:extLst>
           </p:cNvPr>
@@ -2608,7 +2605,7 @@
                   <a:srgbClr val="FF5A66"/>
                 </a:solidFill>
               </a:rPr>
-              <a:t>7</a:t>
+              <a:t>8</a:t>
             </a:r>
           </a:p>
         </p:txBody>
@@ -2618,7 +2615,7 @@
           <p:cNvPr id="18" name="">
             <a:extLst xmlns:a="http://schemas.openxmlformats.org/drawingml/2006/main">
               <a:ext uri="{FF2B5EF4-FFF2-40B4-BE49-F238E27FC236}">
-                <a16:creationId xmlns:a16="http://schemas.microsoft.com/office/drawing/2014/main" id="{45EEA05B-5F8D-4097-B6DA-90FDD4D46513}"/>
+                <a16:creationId xmlns:a16="http://schemas.microsoft.com/office/drawing/2014/main" id="{4D4C72D4-E929-43E9-AB8D-C5DF772ECB61}"/>
               </a:ext>
             </a:extLst>
           </p:cNvPr>
@@ -2663,7 +2660,7 @@
           <p:cNvPr id="19" name="">
             <a:extLst xmlns:a="http://schemas.openxmlformats.org/drawingml/2006/main">
               <a:ext uri="{FF2B5EF4-FFF2-40B4-BE49-F238E27FC236}">
-                <a16:creationId xmlns:a16="http://schemas.microsoft.com/office/drawing/2014/main" id="{5DFD4242-B478-4502-9F92-17B04CB5F46B}"/>
+                <a16:creationId xmlns:a16="http://schemas.microsoft.com/office/drawing/2014/main" id="{20615F11-5501-40BA-8FCF-8AA6B8BF90BA}"/>
               </a:ext>
             </a:extLst>
           </p:cNvPr>
@@ -2698,7 +2695,7 @@
                   <a:srgbClr val="4EA5FF"/>
                 </a:solidFill>
               </a:rPr>
-              <a:t>9</a:t>
+              <a:t>10</a:t>
             </a:r>
           </a:p>
         </p:txBody>
@@ -2708,7 +2705,7 @@
           <p:cNvPr id="20" name="">
             <a:extLst xmlns:a="http://schemas.openxmlformats.org/drawingml/2006/main">
               <a:ext uri="{FF2B5EF4-FFF2-40B4-BE49-F238E27FC236}">
-                <a16:creationId xmlns:a16="http://schemas.microsoft.com/office/drawing/2014/main" id="{395C22FA-E269-4261-AAD7-6F743B4E4690}"/>
+                <a16:creationId xmlns:a16="http://schemas.microsoft.com/office/drawing/2014/main" id="{CAC4767B-9E2E-43C9-BB27-340C624BB86D}"/>
               </a:ext>
             </a:extLst>
           </p:cNvPr>
@@ -2753,7 +2750,7 @@
           <p:cNvPr id="21" name="">
             <a:extLst xmlns:a="http://schemas.openxmlformats.org/drawingml/2006/main">
               <a:ext uri="{FF2B5EF4-FFF2-40B4-BE49-F238E27FC236}">
-                <a16:creationId xmlns:a16="http://schemas.microsoft.com/office/drawing/2014/main" id="{C3C1DA6A-8582-4264-B385-9D52D7D99CF7}"/>
+                <a16:creationId xmlns:a16="http://schemas.microsoft.com/office/drawing/2014/main" id="{28A7C28C-2DA4-4230-9282-95A1A4C87F35}"/>
               </a:ext>
             </a:extLst>
           </p:cNvPr>
@@ -2798,7 +2795,7 @@
           <p:cNvPr id="22" name="">
             <a:extLst xmlns:a="http://schemas.openxmlformats.org/drawingml/2006/main">
               <a:ext uri="{FF2B5EF4-FFF2-40B4-BE49-F238E27FC236}">
-                <a16:creationId xmlns:a16="http://schemas.microsoft.com/office/drawing/2014/main" id="{EBB34678-3A51-4F8A-A812-012EA86913C0}"/>
+                <a16:creationId xmlns:a16="http://schemas.microsoft.com/office/drawing/2014/main" id="{AFFF5AA0-12C0-4B84-ABA7-01CEBE08D4D4}"/>
               </a:ext>
             </a:extLst>
           </p:cNvPr>
@@ -2841,7 +2838,7 @@
     </p:spTree>
     <p:extLst>
       <p:ext uri="{BB962C8B-B14F-4D97-AF65-F5344CB8AC3E}">
-        <p14:creationId xmlns:p14="http://schemas.microsoft.com/office/powerpoint/2010/main" val="840705894"/>
+        <p14:creationId xmlns:p14="http://schemas.microsoft.com/office/powerpoint/2010/main" val="231050306"/>
       </p:ext>
     </p:extLst>
   </p:cSld>
@@ -2865,7 +2862,7 @@
           <p:cNvPr id="1" name="background">
             <a:extLst xmlns:a="http://schemas.openxmlformats.org/drawingml/2006/main">
               <a:ext uri="{FF2B5EF4-FFF2-40B4-BE49-F238E27FC236}">
-                <a16:creationId xmlns:a16="http://schemas.microsoft.com/office/drawing/2014/main" id="{F27AC55D-1378-4A8B-B871-0F75FBC661D6}"/>
+                <a16:creationId xmlns:a16="http://schemas.microsoft.com/office/drawing/2014/main" id="{2C76C84A-2DD7-4CF7-838A-B85438FAEDAF}"/>
               </a:ext>
             </a:extLst>
           </p:cNvPr>
@@ -2892,7 +2889,7 @@
           <p:cNvPr id="2" name="">
             <a:extLst xmlns:a="http://schemas.openxmlformats.org/drawingml/2006/main">
               <a:ext uri="{FF2B5EF4-FFF2-40B4-BE49-F238E27FC236}">
-                <a16:creationId xmlns:a16="http://schemas.microsoft.com/office/drawing/2014/main" id="{4A2A05CC-C3B6-4DFE-8EF2-DBEACE867510}"/>
+                <a16:creationId xmlns:a16="http://schemas.microsoft.com/office/drawing/2014/main" id="{8915FF88-C1E8-42E2-BF83-8C6E8E760FA7}"/>
               </a:ext>
             </a:extLst>
           </p:cNvPr>
@@ -2919,7 +2916,7 @@
           <p:cNvPr id="3" name="">
             <a:extLst xmlns:a="http://schemas.openxmlformats.org/drawingml/2006/main">
               <a:ext uri="{FF2B5EF4-FFF2-40B4-BE49-F238E27FC236}">
-                <a16:creationId xmlns:a16="http://schemas.microsoft.com/office/drawing/2014/main" id="{44734F81-4D57-42E9-9750-CAA605FBF988}"/>
+                <a16:creationId xmlns:a16="http://schemas.microsoft.com/office/drawing/2014/main" id="{C15D51AA-5DF9-4A99-A1B3-AAFA6EA01A59}"/>
               </a:ext>
             </a:extLst>
           </p:cNvPr>
@@ -2964,7 +2961,7 @@
           <p:cNvPr id="4" name="">
             <a:extLst xmlns:a="http://schemas.openxmlformats.org/drawingml/2006/main">
               <a:ext uri="{FF2B5EF4-FFF2-40B4-BE49-F238E27FC236}">
-                <a16:creationId xmlns:a16="http://schemas.microsoft.com/office/drawing/2014/main" id="{F34DB1E1-2CD1-4217-BA5D-B84DBBA2AF30}"/>
+                <a16:creationId xmlns:a16="http://schemas.microsoft.com/office/drawing/2014/main" id="{4F456776-7A1D-47D1-AECC-588BACC5E6B8}"/>
               </a:ext>
             </a:extLst>
           </p:cNvPr>
@@ -3009,7 +3006,7 @@
           <p:cNvPr id="5" name="">
             <a:extLst xmlns:a="http://schemas.openxmlformats.org/drawingml/2006/main">
               <a:ext uri="{FF2B5EF4-FFF2-40B4-BE49-F238E27FC236}">
-                <a16:creationId xmlns:a16="http://schemas.microsoft.com/office/drawing/2014/main" id="{8145DE71-88AF-4099-9B73-997CAA397E81}"/>
+                <a16:creationId xmlns:a16="http://schemas.microsoft.com/office/drawing/2014/main" id="{5B4CAEE6-5DC9-431F-82AF-3E7D428C29D3}"/>
               </a:ext>
             </a:extLst>
           </p:cNvPr>
@@ -3038,7 +3035,7 @@
           <p:cNvPr id="6" name="badge-1">
             <a:extLst xmlns:a="http://schemas.openxmlformats.org/drawingml/2006/main">
               <a:ext uri="{FF2B5EF4-FFF2-40B4-BE49-F238E27FC236}">
-                <a16:creationId xmlns:a16="http://schemas.microsoft.com/office/drawing/2014/main" id="{F3145B90-6A60-42C0-8A6C-0E7A85B74936}"/>
+                <a16:creationId xmlns:a16="http://schemas.microsoft.com/office/drawing/2014/main" id="{CB3C7322-A929-4D82-8CA4-F1DBB4E0461B}"/>
               </a:ext>
             </a:extLst>
           </p:cNvPr>
@@ -3067,7 +3064,7 @@
           <p:cNvPr id="7" name="">
             <a:extLst xmlns:a="http://schemas.openxmlformats.org/drawingml/2006/main">
               <a:ext uri="{FF2B5EF4-FFF2-40B4-BE49-F238E27FC236}">
-                <a16:creationId xmlns:a16="http://schemas.microsoft.com/office/drawing/2014/main" id="{0DE05020-4724-48E5-BDF8-5F53898B2387}"/>
+                <a16:creationId xmlns:a16="http://schemas.microsoft.com/office/drawing/2014/main" id="{27663E33-B132-41A5-8508-E02988C305D6}"/>
               </a:ext>
             </a:extLst>
           </p:cNvPr>
@@ -3112,7 +3109,7 @@
           <p:cNvPr id="8" name="">
             <a:extLst xmlns:a="http://schemas.openxmlformats.org/drawingml/2006/main">
               <a:ext uri="{FF2B5EF4-FFF2-40B4-BE49-F238E27FC236}">
-                <a16:creationId xmlns:a16="http://schemas.microsoft.com/office/drawing/2014/main" id="{B87A058B-8B3D-4A40-8F78-2CC2E421DBC9}"/>
+                <a16:creationId xmlns:a16="http://schemas.microsoft.com/office/drawing/2014/main" id="{D93C7ECF-F464-46D3-837A-627C61B2EFE4}"/>
               </a:ext>
             </a:extLst>
           </p:cNvPr>
@@ -3157,7 +3154,7 @@
           <p:cNvPr id="9" name="">
             <a:extLst xmlns:a="http://schemas.openxmlformats.org/drawingml/2006/main">
               <a:ext uri="{FF2B5EF4-FFF2-40B4-BE49-F238E27FC236}">
-                <a16:creationId xmlns:a16="http://schemas.microsoft.com/office/drawing/2014/main" id="{1A53FCC3-41A1-46F9-9E66-E009DE60B6CF}"/>
+                <a16:creationId xmlns:a16="http://schemas.microsoft.com/office/drawing/2014/main" id="{BE5F5A4B-2286-4E1B-877C-3F8C3D33CD0C}"/>
               </a:ext>
             </a:extLst>
           </p:cNvPr>
@@ -3202,7 +3199,7 @@
           <p:cNvPr id="10" name="">
             <a:extLst xmlns:a="http://schemas.openxmlformats.org/drawingml/2006/main">
               <a:ext uri="{FF2B5EF4-FFF2-40B4-BE49-F238E27FC236}">
-                <a16:creationId xmlns:a16="http://schemas.microsoft.com/office/drawing/2014/main" id="{515EB9C0-E988-4CB6-82CE-B70DE999B4BC}"/>
+                <a16:creationId xmlns:a16="http://schemas.microsoft.com/office/drawing/2014/main" id="{FA083E9E-535D-4AFC-9C25-3AC63096A100}"/>
               </a:ext>
             </a:extLst>
           </p:cNvPr>
@@ -3247,7 +3244,7 @@
           <p:cNvPr id="11" name="">
             <a:extLst xmlns:a="http://schemas.openxmlformats.org/drawingml/2006/main">
               <a:ext uri="{FF2B5EF4-FFF2-40B4-BE49-F238E27FC236}">
-                <a16:creationId xmlns:a16="http://schemas.microsoft.com/office/drawing/2014/main" id="{3DF2DAF4-5B7C-4A86-B358-782EDE40AD4A}"/>
+                <a16:creationId xmlns:a16="http://schemas.microsoft.com/office/drawing/2014/main" id="{15EFBAA2-E2E6-4913-BCB6-45E7B9BBC11D}"/>
               </a:ext>
             </a:extLst>
           </p:cNvPr>
@@ -3276,18 +3273,18 @@
           <p:cNvPr id="12" name="badge-2">
             <a:extLst xmlns:a="http://schemas.openxmlformats.org/drawingml/2006/main">
               <a:ext uri="{FF2B5EF4-FFF2-40B4-BE49-F238E27FC236}">
-                <a16:creationId xmlns:a16="http://schemas.microsoft.com/office/drawing/2014/main" id="{13C97689-9640-46FC-868A-8B1317EAC151}"/>
-              </a:ext>
-            </a:extLst>
-          </p:cNvPr>
-          <p:cNvSpPr>
-            <a:spLocks xmlns:a="http://schemas.openxmlformats.org/drawingml/2006/main" noGrp="1"/>
-          </p:cNvSpPr>
-          <p:nvPr/>
-        </p:nvSpPr>
-        <p:spPr>
-          <a:xfrm xmlns:a="http://schemas.openxmlformats.org/drawingml/2006/main">
-            <a:off x="5264664" y="5293995"/>
+                <a16:creationId xmlns:a16="http://schemas.microsoft.com/office/drawing/2014/main" id="{1044BE57-7110-4FAD-955A-FC3F5D0FC9A7}"/>
+              </a:ext>
+            </a:extLst>
+          </p:cNvPr>
+          <p:cNvSpPr>
+            <a:spLocks xmlns:a="http://schemas.openxmlformats.org/drawingml/2006/main" noGrp="1"/>
+          </p:cNvSpPr>
+          <p:nvPr/>
+        </p:nvSpPr>
+        <p:spPr>
+          <a:xfrm xmlns:a="http://schemas.openxmlformats.org/drawingml/2006/main">
+            <a:off x="5264664" y="5156835"/>
             <a:ext cx="429768" cy="377190"/>
           </a:xfrm>
           <a:prstGeom xmlns:a="http://schemas.openxmlformats.org/drawingml/2006/main" prst="roundRect">
@@ -3305,18 +3302,18 @@
           <p:cNvPr id="13" name="">
             <a:extLst xmlns:a="http://schemas.openxmlformats.org/drawingml/2006/main">
               <a:ext uri="{FF2B5EF4-FFF2-40B4-BE49-F238E27FC236}">
-                <a16:creationId xmlns:a16="http://schemas.microsoft.com/office/drawing/2014/main" id="{D7E8B24D-DE45-4C21-A3DB-A89C5352E254}"/>
-              </a:ext>
-            </a:extLst>
-          </p:cNvPr>
-          <p:cNvSpPr>
-            <a:spLocks xmlns:a="http://schemas.openxmlformats.org/drawingml/2006/main" noGrp="1"/>
-          </p:cNvSpPr>
-          <p:nvPr/>
-        </p:nvSpPr>
-        <p:spPr>
-          <a:xfrm xmlns:a="http://schemas.openxmlformats.org/drawingml/2006/main">
-            <a:off x="5448300" y="5391150"/>
+                <a16:creationId xmlns:a16="http://schemas.microsoft.com/office/drawing/2014/main" id="{5DE8A83F-2170-41C7-A4E5-957F3C4BDE54}"/>
+              </a:ext>
+            </a:extLst>
+          </p:cNvPr>
+          <p:cNvSpPr>
+            <a:spLocks xmlns:a="http://schemas.openxmlformats.org/drawingml/2006/main" noGrp="1"/>
+          </p:cNvSpPr>
+          <p:nvPr/>
+        </p:nvSpPr>
+        <p:spPr>
+          <a:xfrm xmlns:a="http://schemas.openxmlformats.org/drawingml/2006/main">
+            <a:off x="5448300" y="5257800"/>
             <a:ext cx="76200" cy="190500"/>
           </a:xfrm>
           <a:prstGeom xmlns:a="http://schemas.openxmlformats.org/drawingml/2006/main" prst="rect">
@@ -3350,18 +3347,18 @@
           <p:cNvPr id="14" name="">
             <a:extLst xmlns:a="http://schemas.openxmlformats.org/drawingml/2006/main">
               <a:ext uri="{FF2B5EF4-FFF2-40B4-BE49-F238E27FC236}">
-                <a16:creationId xmlns:a16="http://schemas.microsoft.com/office/drawing/2014/main" id="{222A9A0C-09AA-482D-8DFC-149EBE4813A6}"/>
-              </a:ext>
-            </a:extLst>
-          </p:cNvPr>
-          <p:cNvSpPr>
-            <a:spLocks xmlns:a="http://schemas.openxmlformats.org/drawingml/2006/main" noGrp="1"/>
-          </p:cNvSpPr>
-          <p:nvPr/>
-        </p:nvSpPr>
-        <p:spPr>
-          <a:xfrm xmlns:a="http://schemas.openxmlformats.org/drawingml/2006/main">
-            <a:off x="5257800" y="5848350"/>
+                <a16:creationId xmlns:a16="http://schemas.microsoft.com/office/drawing/2014/main" id="{779F1585-3391-4302-AC1A-1DD9C4435BCF}"/>
+              </a:ext>
+            </a:extLst>
+          </p:cNvPr>
+          <p:cNvSpPr>
+            <a:spLocks xmlns:a="http://schemas.openxmlformats.org/drawingml/2006/main" noGrp="1"/>
+          </p:cNvSpPr>
+          <p:nvPr/>
+        </p:nvSpPr>
+        <p:spPr>
+          <a:xfrm xmlns:a="http://schemas.openxmlformats.org/drawingml/2006/main">
+            <a:off x="5257800" y="5715000"/>
             <a:ext cx="2933700" cy="381000"/>
           </a:xfrm>
           <a:prstGeom xmlns:a="http://schemas.openxmlformats.org/drawingml/2006/main" prst="rect">
@@ -3395,19 +3392,19 @@
           <p:cNvPr id="15" name="">
             <a:extLst xmlns:a="http://schemas.openxmlformats.org/drawingml/2006/main">
               <a:ext uri="{FF2B5EF4-FFF2-40B4-BE49-F238E27FC236}">
-                <a16:creationId xmlns:a16="http://schemas.microsoft.com/office/drawing/2014/main" id="{6C9383B5-044B-449D-80CE-1EE8A88F9D39}"/>
-              </a:ext>
-            </a:extLst>
-          </p:cNvPr>
-          <p:cNvSpPr>
-            <a:spLocks xmlns:a="http://schemas.openxmlformats.org/drawingml/2006/main" noGrp="1"/>
-          </p:cNvSpPr>
-          <p:nvPr/>
-        </p:nvSpPr>
-        <p:spPr>
-          <a:xfrm xmlns:a="http://schemas.openxmlformats.org/drawingml/2006/main">
-            <a:off x="5257800" y="6381750"/>
-            <a:ext cx="2933700" cy="838200"/>
+                <a16:creationId xmlns:a16="http://schemas.microsoft.com/office/drawing/2014/main" id="{EAF4D847-1BE7-4BB7-B9F1-85550EC03A17}"/>
+              </a:ext>
+            </a:extLst>
+          </p:cNvPr>
+          <p:cNvSpPr>
+            <a:spLocks xmlns:a="http://schemas.openxmlformats.org/drawingml/2006/main" noGrp="1"/>
+          </p:cNvSpPr>
+          <p:nvPr/>
+        </p:nvSpPr>
+        <p:spPr>
+          <a:xfrm xmlns:a="http://schemas.openxmlformats.org/drawingml/2006/main">
+            <a:off x="5257800" y="6248400"/>
+            <a:ext cx="2933700" cy="1104900"/>
           </a:xfrm>
           <a:prstGeom xmlns:a="http://schemas.openxmlformats.org/drawingml/2006/main" prst="rect">
             <a:avLst/>
@@ -3430,7 +3427,7 @@
                   <a:srgbClr val="C6F7EE"/>
                 </a:solidFill>
               </a:rPr>
-              <a:t>Flags insulin, oxygen, pregnancy, floodwater, rumors, language access.</a:t>
+              <a:t>Flags insulin, oxygen, pregnancy, floodwater, rumors, language access, and official resource checks.</a:t>
             </a:r>
           </a:p>
         </p:txBody>
@@ -3440,7 +3437,7 @@
           <p:cNvPr id="16" name="">
             <a:extLst xmlns:a="http://schemas.openxmlformats.org/drawingml/2006/main">
               <a:ext uri="{FF2B5EF4-FFF2-40B4-BE49-F238E27FC236}">
-                <a16:creationId xmlns:a16="http://schemas.microsoft.com/office/drawing/2014/main" id="{081B59CF-D5D3-44A4-9640-58576603E3FB}"/>
+                <a16:creationId xmlns:a16="http://schemas.microsoft.com/office/drawing/2014/main" id="{8C4F2B76-4B49-4DB4-A5AF-1FED74BEAE96}"/>
               </a:ext>
             </a:extLst>
           </p:cNvPr>
@@ -3485,7 +3482,7 @@
           <p:cNvPr id="17" name="">
             <a:extLst xmlns:a="http://schemas.openxmlformats.org/drawingml/2006/main">
               <a:ext uri="{FF2B5EF4-FFF2-40B4-BE49-F238E27FC236}">
-                <a16:creationId xmlns:a16="http://schemas.microsoft.com/office/drawing/2014/main" id="{038554B6-C64A-43BE-B3FF-7F9FFBF1970D}"/>
+                <a16:creationId xmlns:a16="http://schemas.microsoft.com/office/drawing/2014/main" id="{E19F3E7B-E8CB-4586-BCAB-657717BC87C3}"/>
               </a:ext>
             </a:extLst>
           </p:cNvPr>
@@ -3514,7 +3511,7 @@
           <p:cNvPr id="18" name="badge-3">
             <a:extLst xmlns:a="http://schemas.openxmlformats.org/drawingml/2006/main">
               <a:ext uri="{FF2B5EF4-FFF2-40B4-BE49-F238E27FC236}">
-                <a16:creationId xmlns:a16="http://schemas.microsoft.com/office/drawing/2014/main" id="{098743DC-294E-4171-8FF2-C15AC59D8A37}"/>
+                <a16:creationId xmlns:a16="http://schemas.microsoft.com/office/drawing/2014/main" id="{D910E94F-5EA7-4406-B531-1A53488A4036}"/>
               </a:ext>
             </a:extLst>
           </p:cNvPr>
@@ -3543,7 +3540,7 @@
           <p:cNvPr id="19" name="">
             <a:extLst xmlns:a="http://schemas.openxmlformats.org/drawingml/2006/main">
               <a:ext uri="{FF2B5EF4-FFF2-40B4-BE49-F238E27FC236}">
-                <a16:creationId xmlns:a16="http://schemas.microsoft.com/office/drawing/2014/main" id="{6956D98D-06B9-4436-8261-647F40947C46}"/>
+                <a16:creationId xmlns:a16="http://schemas.microsoft.com/office/drawing/2014/main" id="{230A88E2-6A3E-43F2-AB89-1A389F286E12}"/>
               </a:ext>
             </a:extLst>
           </p:cNvPr>
@@ -3588,7 +3585,7 @@
           <p:cNvPr id="20" name="">
             <a:extLst xmlns:a="http://schemas.openxmlformats.org/drawingml/2006/main">
               <a:ext uri="{FF2B5EF4-FFF2-40B4-BE49-F238E27FC236}">
-                <a16:creationId xmlns:a16="http://schemas.microsoft.com/office/drawing/2014/main" id="{5691A0CB-6D14-489F-B328-31040C8749C8}"/>
+                <a16:creationId xmlns:a16="http://schemas.microsoft.com/office/drawing/2014/main" id="{CEBF373C-8722-431B-B8BB-46EB2EEE6D21}"/>
               </a:ext>
             </a:extLst>
           </p:cNvPr>
@@ -3633,7 +3630,7 @@
           <p:cNvPr id="21" name="">
             <a:extLst xmlns:a="http://schemas.openxmlformats.org/drawingml/2006/main">
               <a:ext uri="{FF2B5EF4-FFF2-40B4-BE49-F238E27FC236}">
-                <a16:creationId xmlns:a16="http://schemas.microsoft.com/office/drawing/2014/main" id="{E28E3E0B-EAF1-4A91-9E2C-B828E1FA45B0}"/>
+                <a16:creationId xmlns:a16="http://schemas.microsoft.com/office/drawing/2014/main" id="{B579773A-CA91-408C-AA9B-F879C6AF8A43}"/>
               </a:ext>
             </a:extLst>
           </p:cNvPr>
@@ -3678,7 +3675,7 @@
           <p:cNvPr id="22" name="">
             <a:extLst xmlns:a="http://schemas.openxmlformats.org/drawingml/2006/main">
               <a:ext uri="{FF2B5EF4-FFF2-40B4-BE49-F238E27FC236}">
-                <a16:creationId xmlns:a16="http://schemas.microsoft.com/office/drawing/2014/main" id="{DAE80CDC-7BCA-46D1-8A5F-5059F7067301}"/>
+                <a16:creationId xmlns:a16="http://schemas.microsoft.com/office/drawing/2014/main" id="{3CB3CEBE-3524-460A-B180-17BF4BB24B2E}"/>
               </a:ext>
             </a:extLst>
           </p:cNvPr>
@@ -3723,7 +3720,7 @@
           <p:cNvPr id="23" name="">
             <a:extLst xmlns:a="http://schemas.openxmlformats.org/drawingml/2006/main">
               <a:ext uri="{FF2B5EF4-FFF2-40B4-BE49-F238E27FC236}">
-                <a16:creationId xmlns:a16="http://schemas.microsoft.com/office/drawing/2014/main" id="{612F770E-DACD-406B-ACF4-BCA63BD6F391}"/>
+                <a16:creationId xmlns:a16="http://schemas.microsoft.com/office/drawing/2014/main" id="{202729A0-03B9-404D-A4DA-213DE33CA0F2}"/>
               </a:ext>
             </a:extLst>
           </p:cNvPr>
@@ -3752,7 +3749,7 @@
           <p:cNvPr id="24" name="badge-4">
             <a:extLst xmlns:a="http://schemas.openxmlformats.org/drawingml/2006/main">
               <a:ext uri="{FF2B5EF4-FFF2-40B4-BE49-F238E27FC236}">
-                <a16:creationId xmlns:a16="http://schemas.microsoft.com/office/drawing/2014/main" id="{4833D977-E3AF-4655-9E3E-E6B629842B6B}"/>
+                <a16:creationId xmlns:a16="http://schemas.microsoft.com/office/drawing/2014/main" id="{CBCF7407-3E78-42B5-8F23-9D9E41660030}"/>
               </a:ext>
             </a:extLst>
           </p:cNvPr>
@@ -3781,7 +3778,7 @@
           <p:cNvPr id="25" name="">
             <a:extLst xmlns:a="http://schemas.openxmlformats.org/drawingml/2006/main">
               <a:ext uri="{FF2B5EF4-FFF2-40B4-BE49-F238E27FC236}">
-                <a16:creationId xmlns:a16="http://schemas.microsoft.com/office/drawing/2014/main" id="{A8D9F9F0-FA9E-4110-A4BA-AF9CFB446706}"/>
+                <a16:creationId xmlns:a16="http://schemas.microsoft.com/office/drawing/2014/main" id="{F14F745A-D7A6-46BC-8FBE-DD2EAD494450}"/>
               </a:ext>
             </a:extLst>
           </p:cNvPr>
@@ -3826,7 +3823,7 @@
           <p:cNvPr id="26" name="">
             <a:extLst xmlns:a="http://schemas.openxmlformats.org/drawingml/2006/main">
               <a:ext uri="{FF2B5EF4-FFF2-40B4-BE49-F238E27FC236}">
-                <a16:creationId xmlns:a16="http://schemas.microsoft.com/office/drawing/2014/main" id="{813D38AC-581D-4F41-BD59-897E54038513}"/>
+                <a16:creationId xmlns:a16="http://schemas.microsoft.com/office/drawing/2014/main" id="{D452B45F-41E2-4975-9F1D-11D112DDD022}"/>
               </a:ext>
             </a:extLst>
           </p:cNvPr>
@@ -3871,7 +3868,7 @@
           <p:cNvPr id="27" name="">
             <a:extLst xmlns:a="http://schemas.openxmlformats.org/drawingml/2006/main">
               <a:ext uri="{FF2B5EF4-FFF2-40B4-BE49-F238E27FC236}">
-                <a16:creationId xmlns:a16="http://schemas.microsoft.com/office/drawing/2014/main" id="{10D9A4DF-5B89-451D-897F-F0B891A23064}"/>
+                <a16:creationId xmlns:a16="http://schemas.microsoft.com/office/drawing/2014/main" id="{3BFE7D77-C796-4B0A-B5CA-D689D2B39843}"/>
               </a:ext>
             </a:extLst>
           </p:cNvPr>
@@ -3914,7 +3911,7 @@
     </p:spTree>
     <p:extLst>
       <p:ext uri="{BB962C8B-B14F-4D97-AF65-F5344CB8AC3E}">
-        <p14:creationId xmlns:p14="http://schemas.microsoft.com/office/powerpoint/2010/main" val="1944253356"/>
+        <p14:creationId xmlns:p14="http://schemas.microsoft.com/office/powerpoint/2010/main" val="753152497"/>
       </p:ext>
     </p:extLst>
   </p:cSld>
@@ -3938,7 +3935,7 @@
           <p:cNvPr id="1" name="background">
             <a:extLst xmlns:a="http://schemas.openxmlformats.org/drawingml/2006/main">
               <a:ext uri="{FF2B5EF4-FFF2-40B4-BE49-F238E27FC236}">
-                <a16:creationId xmlns:a16="http://schemas.microsoft.com/office/drawing/2014/main" id="{D12B4F31-F0F3-4B4E-89B8-846CFCF7EB42}"/>
+                <a16:creationId xmlns:a16="http://schemas.microsoft.com/office/drawing/2014/main" id="{3259C9FA-6FD1-4113-A3D0-ABD17BE3FFA0}"/>
               </a:ext>
             </a:extLst>
           </p:cNvPr>
@@ -3965,7 +3962,7 @@
           <p:cNvPr id="2" name="">
             <a:extLst xmlns:a="http://schemas.openxmlformats.org/drawingml/2006/main">
               <a:ext uri="{FF2B5EF4-FFF2-40B4-BE49-F238E27FC236}">
-                <a16:creationId xmlns:a16="http://schemas.microsoft.com/office/drawing/2014/main" id="{3FAFEC23-00E9-4506-9E59-7E16FB9A97F7}"/>
+                <a16:creationId xmlns:a16="http://schemas.microsoft.com/office/drawing/2014/main" id="{CCD24DD8-C001-4E0E-AE4B-2E33A110552A}"/>
               </a:ext>
             </a:extLst>
           </p:cNvPr>
@@ -3992,7 +3989,7 @@
           <p:cNvPr id="3" name="">
             <a:extLst xmlns:a="http://schemas.openxmlformats.org/drawingml/2006/main">
               <a:ext uri="{FF2B5EF4-FFF2-40B4-BE49-F238E27FC236}">
-                <a16:creationId xmlns:a16="http://schemas.microsoft.com/office/drawing/2014/main" id="{56F788BE-EE3F-4429-87AA-AEFB4C48A5E7}"/>
+                <a16:creationId xmlns:a16="http://schemas.microsoft.com/office/drawing/2014/main" id="{952EF349-3166-411D-B8BD-83D54A1CDDEE}"/>
               </a:ext>
             </a:extLst>
           </p:cNvPr>
@@ -4037,7 +4034,7 @@
           <p:cNvPr id="4" name="">
             <a:extLst xmlns:a="http://schemas.openxmlformats.org/drawingml/2006/main">
               <a:ext uri="{FF2B5EF4-FFF2-40B4-BE49-F238E27FC236}">
-                <a16:creationId xmlns:a16="http://schemas.microsoft.com/office/drawing/2014/main" id="{C791BDD3-0A5C-4D86-896C-7DF3B2744FC3}"/>
+                <a16:creationId xmlns:a16="http://schemas.microsoft.com/office/drawing/2014/main" id="{5B76CFFC-447D-4900-A741-DCA4A0DF389C}"/>
               </a:ext>
             </a:extLst>
           </p:cNvPr>
@@ -4082,7 +4079,7 @@
           <p:cNvPr id="5" name="">
             <a:extLst xmlns:a="http://schemas.openxmlformats.org/drawingml/2006/main">
               <a:ext uri="{FF2B5EF4-FFF2-40B4-BE49-F238E27FC236}">
-                <a16:creationId xmlns:a16="http://schemas.microsoft.com/office/drawing/2014/main" id="{0FDA8E57-8E18-4360-A1E9-525B133F984B}"/>
+                <a16:creationId xmlns:a16="http://schemas.microsoft.com/office/drawing/2014/main" id="{5C59ACDB-E004-465A-BD1E-DB55349E4B70}"/>
               </a:ext>
             </a:extLst>
           </p:cNvPr>
@@ -4094,7 +4091,7 @@
         <p:spPr>
           <a:xfrm xmlns:a="http://schemas.openxmlformats.org/drawingml/2006/main">
             <a:off x="857250" y="3752850"/>
-            <a:ext cx="6477000" cy="628650"/>
+            <a:ext cx="6419850" cy="933450"/>
           </a:xfrm>
           <a:prstGeom xmlns:a="http://schemas.openxmlformats.org/drawingml/2006/main" prst="rect">
             <a:avLst/>
@@ -4117,7 +4114,7 @@
                   <a:srgbClr val="5D6470"/>
                 </a:solidFill>
               </a:rPr>
-              <a:t>The public demo exposes the same seven-section output used in local validation, including language support and handoff.</a:t>
+              <a:t>The public demo exposes the same eight-section output used in local validation, including official resource checks, language support, and handoff.</a:t>
             </a:r>
           </a:p>
         </p:txBody>
@@ -4127,18 +4124,18 @@
           <p:cNvPr id="6" name="badge-public-demo">
             <a:extLst xmlns:a="http://schemas.openxmlformats.org/drawingml/2006/main">
               <a:ext uri="{FF2B5EF4-FFF2-40B4-BE49-F238E27FC236}">
-                <a16:creationId xmlns:a16="http://schemas.microsoft.com/office/drawing/2014/main" id="{46C94D3E-57D7-45EB-9321-EE836EA07336}"/>
-              </a:ext>
-            </a:extLst>
-          </p:cNvPr>
-          <p:cNvSpPr>
-            <a:spLocks xmlns:a="http://schemas.openxmlformats.org/drawingml/2006/main" noGrp="1"/>
-          </p:cNvSpPr>
-          <p:nvPr/>
-        </p:nvSpPr>
-        <p:spPr>
-          <a:xfrm xmlns:a="http://schemas.openxmlformats.org/drawingml/2006/main">
-            <a:off x="857250" y="4552950"/>
+                <a16:creationId xmlns:a16="http://schemas.microsoft.com/office/drawing/2014/main" id="{3238E0BD-8E33-410F-865A-FD22D9DFE358}"/>
+              </a:ext>
+            </a:extLst>
+          </p:cNvPr>
+          <p:cNvSpPr>
+            <a:spLocks xmlns:a="http://schemas.openxmlformats.org/drawingml/2006/main" noGrp="1"/>
+          </p:cNvSpPr>
+          <p:nvPr/>
+        </p:nvSpPr>
+        <p:spPr>
+          <a:xfrm xmlns:a="http://schemas.openxmlformats.org/drawingml/2006/main">
+            <a:off x="857250" y="4861560"/>
             <a:ext cx="1223581" cy="582930"/>
           </a:xfrm>
           <a:prstGeom xmlns:a="http://schemas.openxmlformats.org/drawingml/2006/main" prst="roundRect">
@@ -4156,18 +4153,18 @@
           <p:cNvPr id="7" name="">
             <a:extLst xmlns:a="http://schemas.openxmlformats.org/drawingml/2006/main">
               <a:ext uri="{FF2B5EF4-FFF2-40B4-BE49-F238E27FC236}">
-                <a16:creationId xmlns:a16="http://schemas.microsoft.com/office/drawing/2014/main" id="{4FAD6ADA-B6E0-4BE0-8E91-E68564D53271}"/>
-              </a:ext>
-            </a:extLst>
-          </p:cNvPr>
-          <p:cNvSpPr>
-            <a:spLocks xmlns:a="http://schemas.openxmlformats.org/drawingml/2006/main" noGrp="1"/>
-          </p:cNvSpPr>
-          <p:nvPr/>
-        </p:nvSpPr>
-        <p:spPr>
-          <a:xfrm xmlns:a="http://schemas.openxmlformats.org/drawingml/2006/main">
-            <a:off x="1028700" y="4629150"/>
+                <a16:creationId xmlns:a16="http://schemas.microsoft.com/office/drawing/2014/main" id="{C1F47154-8133-4A4A-BB50-5F1AAE190E6D}"/>
+              </a:ext>
+            </a:extLst>
+          </p:cNvPr>
+          <p:cNvSpPr>
+            <a:spLocks xmlns:a="http://schemas.openxmlformats.org/drawingml/2006/main" noGrp="1"/>
+          </p:cNvSpPr>
+          <p:nvPr/>
+        </p:nvSpPr>
+        <p:spPr>
+          <a:xfrm xmlns:a="http://schemas.openxmlformats.org/drawingml/2006/main">
+            <a:off x="1028700" y="4933950"/>
             <a:ext cx="876300" cy="419100"/>
           </a:xfrm>
           <a:prstGeom xmlns:a="http://schemas.openxmlformats.org/drawingml/2006/main" prst="rect">
@@ -4201,18 +4198,18 @@
           <p:cNvPr id="8" name="badge-public-code">
             <a:extLst xmlns:a="http://schemas.openxmlformats.org/drawingml/2006/main">
               <a:ext uri="{FF2B5EF4-FFF2-40B4-BE49-F238E27FC236}">
-                <a16:creationId xmlns:a16="http://schemas.microsoft.com/office/drawing/2014/main" id="{1B449D45-5359-4636-94A7-A50F9DA8EC90}"/>
-              </a:ext>
-            </a:extLst>
-          </p:cNvPr>
-          <p:cNvSpPr>
-            <a:spLocks xmlns:a="http://schemas.openxmlformats.org/drawingml/2006/main" noGrp="1"/>
-          </p:cNvSpPr>
-          <p:nvPr/>
-        </p:nvSpPr>
-        <p:spPr>
-          <a:xfrm xmlns:a="http://schemas.openxmlformats.org/drawingml/2006/main">
-            <a:off x="2195131" y="4552950"/>
+                <a16:creationId xmlns:a16="http://schemas.microsoft.com/office/drawing/2014/main" id="{E7278EEA-CECA-4317-A784-3321B027E335}"/>
+              </a:ext>
+            </a:extLst>
+          </p:cNvPr>
+          <p:cNvSpPr>
+            <a:spLocks xmlns:a="http://schemas.openxmlformats.org/drawingml/2006/main" noGrp="1"/>
+          </p:cNvSpPr>
+          <p:nvPr/>
+        </p:nvSpPr>
+        <p:spPr>
+          <a:xfrm xmlns:a="http://schemas.openxmlformats.org/drawingml/2006/main">
+            <a:off x="2195131" y="4861560"/>
             <a:ext cx="1155001" cy="582930"/>
           </a:xfrm>
           <a:prstGeom xmlns:a="http://schemas.openxmlformats.org/drawingml/2006/main" prst="roundRect">
@@ -4230,18 +4227,18 @@
           <p:cNvPr id="9" name="">
             <a:extLst xmlns:a="http://schemas.openxmlformats.org/drawingml/2006/main">
               <a:ext uri="{FF2B5EF4-FFF2-40B4-BE49-F238E27FC236}">
-                <a16:creationId xmlns:a16="http://schemas.microsoft.com/office/drawing/2014/main" id="{B7E4B11A-2C7A-4C96-BD45-DB0C0EBB18E8}"/>
-              </a:ext>
-            </a:extLst>
-          </p:cNvPr>
-          <p:cNvSpPr>
-            <a:spLocks xmlns:a="http://schemas.openxmlformats.org/drawingml/2006/main" noGrp="1"/>
-          </p:cNvSpPr>
-          <p:nvPr/>
-        </p:nvSpPr>
-        <p:spPr>
-          <a:xfrm xmlns:a="http://schemas.openxmlformats.org/drawingml/2006/main">
-            <a:off x="2381250" y="4629150"/>
+                <a16:creationId xmlns:a16="http://schemas.microsoft.com/office/drawing/2014/main" id="{F6F6421D-293D-411C-9A65-FD9A2CCB7F76}"/>
+              </a:ext>
+            </a:extLst>
+          </p:cNvPr>
+          <p:cNvSpPr>
+            <a:spLocks xmlns:a="http://schemas.openxmlformats.org/drawingml/2006/main" noGrp="1"/>
+          </p:cNvSpPr>
+          <p:nvPr/>
+        </p:nvSpPr>
+        <p:spPr>
+          <a:xfrm xmlns:a="http://schemas.openxmlformats.org/drawingml/2006/main">
+            <a:off x="2381250" y="4933950"/>
             <a:ext cx="800100" cy="419100"/>
           </a:xfrm>
           <a:prstGeom xmlns:a="http://schemas.openxmlformats.org/drawingml/2006/main" prst="rect">
@@ -4275,18 +4272,18 @@
           <p:cNvPr id="10" name="badge-video-pitch">
             <a:extLst xmlns:a="http://schemas.openxmlformats.org/drawingml/2006/main">
               <a:ext uri="{FF2B5EF4-FFF2-40B4-BE49-F238E27FC236}">
-                <a16:creationId xmlns:a16="http://schemas.microsoft.com/office/drawing/2014/main" id="{9C0C0E55-CBE3-4A56-B641-D58B93CC0E61}"/>
-              </a:ext>
-            </a:extLst>
-          </p:cNvPr>
-          <p:cNvSpPr>
-            <a:spLocks xmlns:a="http://schemas.openxmlformats.org/drawingml/2006/main" noGrp="1"/>
-          </p:cNvSpPr>
-          <p:nvPr/>
-        </p:nvSpPr>
-        <p:spPr>
-          <a:xfrm xmlns:a="http://schemas.openxmlformats.org/drawingml/2006/main">
-            <a:off x="3464433" y="4552950"/>
+                <a16:creationId xmlns:a16="http://schemas.microsoft.com/office/drawing/2014/main" id="{3D308539-A05E-4EA6-9961-221D82E4D203}"/>
+              </a:ext>
+            </a:extLst>
+          </p:cNvPr>
+          <p:cNvSpPr>
+            <a:spLocks xmlns:a="http://schemas.openxmlformats.org/drawingml/2006/main" noGrp="1"/>
+          </p:cNvSpPr>
+          <p:nvPr/>
+        </p:nvSpPr>
+        <p:spPr>
+          <a:xfrm xmlns:a="http://schemas.openxmlformats.org/drawingml/2006/main">
+            <a:off x="3464433" y="4861560"/>
             <a:ext cx="1130522" cy="582930"/>
           </a:xfrm>
           <a:prstGeom xmlns:a="http://schemas.openxmlformats.org/drawingml/2006/main" prst="roundRect">
@@ -4304,18 +4301,18 @@
           <p:cNvPr id="11" name="">
             <a:extLst xmlns:a="http://schemas.openxmlformats.org/drawingml/2006/main">
               <a:ext uri="{FF2B5EF4-FFF2-40B4-BE49-F238E27FC236}">
-                <a16:creationId xmlns:a16="http://schemas.microsoft.com/office/drawing/2014/main" id="{B79C4783-14EB-418C-89A7-E891A8F2DBC6}"/>
-              </a:ext>
-            </a:extLst>
-          </p:cNvPr>
-          <p:cNvSpPr>
-            <a:spLocks xmlns:a="http://schemas.openxmlformats.org/drawingml/2006/main" noGrp="1"/>
-          </p:cNvSpPr>
-          <p:nvPr/>
-        </p:nvSpPr>
-        <p:spPr>
-          <a:xfrm xmlns:a="http://schemas.openxmlformats.org/drawingml/2006/main">
-            <a:off x="3638550" y="4629150"/>
+                <a16:creationId xmlns:a16="http://schemas.microsoft.com/office/drawing/2014/main" id="{EF7198E8-0820-48BE-94DB-A8D6665AB3C8}"/>
+              </a:ext>
+            </a:extLst>
+          </p:cNvPr>
+          <p:cNvSpPr>
+            <a:spLocks xmlns:a="http://schemas.openxmlformats.org/drawingml/2006/main" noGrp="1"/>
+          </p:cNvSpPr>
+          <p:nvPr/>
+        </p:nvSpPr>
+        <p:spPr>
+          <a:xfrm xmlns:a="http://schemas.openxmlformats.org/drawingml/2006/main">
+            <a:off x="3638550" y="4933950"/>
             <a:ext cx="800100" cy="419100"/>
           </a:xfrm>
           <a:prstGeom xmlns:a="http://schemas.openxmlformats.org/drawingml/2006/main" prst="rect">
@@ -4349,7 +4346,7 @@
           <p:cNvPr id="12" name="footer">
             <a:extLst xmlns:a="http://schemas.openxmlformats.org/drawingml/2006/main">
               <a:ext uri="{FF2B5EF4-FFF2-40B4-BE49-F238E27FC236}">
-                <a16:creationId xmlns:a16="http://schemas.microsoft.com/office/drawing/2014/main" id="{E534D0E1-682F-4EDA-A8AE-83A10E5D2274}"/>
+                <a16:creationId xmlns:a16="http://schemas.microsoft.com/office/drawing/2014/main" id="{6B66C870-3A93-4597-92A7-B7CD179D0091}"/>
               </a:ext>
             </a:extLst>
           </p:cNvPr>
@@ -4394,7 +4391,7 @@
           <p:cNvPr id="13" name="">
             <a:extLst xmlns:a="http://schemas.openxmlformats.org/drawingml/2006/main">
               <a:ext uri="{FF2B5EF4-FFF2-40B4-BE49-F238E27FC236}">
-                <a16:creationId xmlns:a16="http://schemas.microsoft.com/office/drawing/2014/main" id="{E0310317-E98A-46B7-A58D-4B59E6E806AC}"/>
+                <a16:creationId xmlns:a16="http://schemas.microsoft.com/office/drawing/2014/main" id="{6C35F177-E249-43D6-9C3B-A16CE0ACE799}"/>
               </a:ext>
             </a:extLst>
           </p:cNvPr>
@@ -4433,13 +4430,13 @@
           <p:nvPr/>
         </p:nvPicPr>
         <p:blipFill>
-          <a:blip xmlns:r="http://schemas.openxmlformats.org/officeDocument/2006/relationships" xmlns:a="http://schemas.openxmlformats.org/drawingml/2006/main" r:embed="Re2da131b43ea421a"/>
+          <a:blip xmlns:r="http://schemas.openxmlformats.org/officeDocument/2006/relationships" xmlns:a="http://schemas.openxmlformats.org/drawingml/2006/main" r:embed="Rb1944854de3a4929"/>
           <a:stretch xmlns:a="http://schemas.openxmlformats.org/drawingml/2006/main"/>
         </p:blipFill>
         <p:spPr>
           <a:xfrm xmlns:a="http://schemas.openxmlformats.org/drawingml/2006/main">
-            <a:off x="8994174" y="2143125"/>
-            <a:ext cx="7100312" cy="6000750"/>
+            <a:off x="8223790" y="2143125"/>
+            <a:ext cx="8641080" cy="6000750"/>
           </a:xfrm>
           <a:prstGeom xmlns:a="http://schemas.openxmlformats.org/drawingml/2006/main" prst="rect">
             <a:avLst/>
@@ -4449,7 +4446,7 @@
     </p:spTree>
     <p:extLst>
       <p:ext uri="{BB962C8B-B14F-4D97-AF65-F5344CB8AC3E}">
-        <p14:creationId xmlns:p14="http://schemas.microsoft.com/office/powerpoint/2010/main" val="1303754007"/>
+        <p14:creationId xmlns:p14="http://schemas.microsoft.com/office/powerpoint/2010/main" val="1934426531"/>
       </p:ext>
     </p:extLst>
   </p:cSld>
@@ -4473,7 +4470,7 @@
           <p:cNvPr id="1" name="background">
             <a:extLst xmlns:a="http://schemas.openxmlformats.org/drawingml/2006/main">
               <a:ext uri="{FF2B5EF4-FFF2-40B4-BE49-F238E27FC236}">
-                <a16:creationId xmlns:a16="http://schemas.microsoft.com/office/drawing/2014/main" id="{AB61F127-2FD0-45EE-9E64-F7577F9846F9}"/>
+                <a16:creationId xmlns:a16="http://schemas.microsoft.com/office/drawing/2014/main" id="{0CBB6525-96B2-40CA-AEC0-2D513C80074F}"/>
               </a:ext>
             </a:extLst>
           </p:cNvPr>
@@ -4500,7 +4497,7 @@
           <p:cNvPr id="2" name="">
             <a:extLst xmlns:a="http://schemas.openxmlformats.org/drawingml/2006/main">
               <a:ext uri="{FF2B5EF4-FFF2-40B4-BE49-F238E27FC236}">
-                <a16:creationId xmlns:a16="http://schemas.microsoft.com/office/drawing/2014/main" id="{95DD73B8-B637-4D82-BABE-DAB5370C9BE2}"/>
+                <a16:creationId xmlns:a16="http://schemas.microsoft.com/office/drawing/2014/main" id="{43AD78AA-B56B-4A67-89E3-F5BE00638DAB}"/>
               </a:ext>
             </a:extLst>
           </p:cNvPr>
@@ -4527,7 +4524,7 @@
           <p:cNvPr id="3" name="">
             <a:extLst xmlns:a="http://schemas.openxmlformats.org/drawingml/2006/main">
               <a:ext uri="{FF2B5EF4-FFF2-40B4-BE49-F238E27FC236}">
-                <a16:creationId xmlns:a16="http://schemas.microsoft.com/office/drawing/2014/main" id="{6CD1BE14-D957-42E0-B117-8645B1FC5C4A}"/>
+                <a16:creationId xmlns:a16="http://schemas.microsoft.com/office/drawing/2014/main" id="{A248FD19-CD82-41B7-9A28-90140B47FD6A}"/>
               </a:ext>
             </a:extLst>
           </p:cNvPr>
@@ -4572,7 +4569,7 @@
           <p:cNvPr id="4" name="">
             <a:extLst xmlns:a="http://schemas.openxmlformats.org/drawingml/2006/main">
               <a:ext uri="{FF2B5EF4-FFF2-40B4-BE49-F238E27FC236}">
-                <a16:creationId xmlns:a16="http://schemas.microsoft.com/office/drawing/2014/main" id="{89B3B61F-DD5A-482F-B755-B00C86D27FA6}"/>
+                <a16:creationId xmlns:a16="http://schemas.microsoft.com/office/drawing/2014/main" id="{C109FAF3-034E-4F26-958B-6C0542467176}"/>
               </a:ext>
             </a:extLst>
           </p:cNvPr>
@@ -4607,7 +4604,7 @@
                   <a:srgbClr val="FFFFFF"/>
                 </a:solidFill>
               </a:rPr>
-              <a:t>Small detector, big behavioral change.</a:t>
+              <a:t>Small detector, bigger field discipline.</a:t>
             </a:r>
           </a:p>
         </p:txBody>
@@ -4617,7 +4614,7 @@
           <p:cNvPr id="5" name="">
             <a:extLst xmlns:a="http://schemas.openxmlformats.org/drawingml/2006/main">
               <a:ext uri="{FF2B5EF4-FFF2-40B4-BE49-F238E27FC236}">
-                <a16:creationId xmlns:a16="http://schemas.microsoft.com/office/drawing/2014/main" id="{19C75169-1CA0-460C-B000-8F854E9AC228}"/>
+                <a16:creationId xmlns:a16="http://schemas.microsoft.com/office/drawing/2014/main" id="{DEEFCDAA-8238-4B7C-8FC0-FA9E4A4E054A}"/>
               </a:ext>
             </a:extLst>
           </p:cNvPr>
@@ -4652,7 +4649,7 @@
                   <a:srgbClr val="CBD5E1"/>
                 </a:solidFill>
               </a:rPr>
-              <a:t>Original branch: expand the sidecar beyond demo cases into edge cases that generic assistants often flatten.</a:t>
+              <a:t>Original branch: expand the sidecar beyond demo cases into official-channel checks that generic assistants often flatten.</a:t>
             </a:r>
           </a:p>
         </p:txBody>
@@ -4662,7 +4659,7 @@
           <p:cNvPr id="6" name="badge-children-cold-exposure">
             <a:extLst xmlns:a="http://schemas.openxmlformats.org/drawingml/2006/main">
               <a:ext uri="{FF2B5EF4-FFF2-40B4-BE49-F238E27FC236}">
-                <a16:creationId xmlns:a16="http://schemas.microsoft.com/office/drawing/2014/main" id="{E98239F8-4F45-4B01-A85C-33E06F8A4D4B}"/>
+                <a16:creationId xmlns:a16="http://schemas.microsoft.com/office/drawing/2014/main" id="{D31A5C6B-0085-4770-B226-51447651329C}"/>
               </a:ext>
             </a:extLst>
           </p:cNvPr>
@@ -4691,7 +4688,7 @@
           <p:cNvPr id="7" name="">
             <a:extLst xmlns:a="http://schemas.openxmlformats.org/drawingml/2006/main">
               <a:ext uri="{FF2B5EF4-FFF2-40B4-BE49-F238E27FC236}">
-                <a16:creationId xmlns:a16="http://schemas.microsoft.com/office/drawing/2014/main" id="{85031FED-6EF5-40BA-B05E-CD0A5DB89DB9}"/>
+                <a16:creationId xmlns:a16="http://schemas.microsoft.com/office/drawing/2014/main" id="{20AB6215-8397-407B-B5FD-F5E6CC5FA1A9}"/>
               </a:ext>
             </a:extLst>
           </p:cNvPr>
@@ -4736,7 +4733,7 @@
           <p:cNvPr id="8" name="badge-medication-interruption">
             <a:extLst xmlns:a="http://schemas.openxmlformats.org/drawingml/2006/main">
               <a:ext uri="{FF2B5EF4-FFF2-40B4-BE49-F238E27FC236}">
-                <a16:creationId xmlns:a16="http://schemas.microsoft.com/office/drawing/2014/main" id="{227922DD-DC49-4A11-9F91-B8ACD4C22C9C}"/>
+                <a16:creationId xmlns:a16="http://schemas.microsoft.com/office/drawing/2014/main" id="{9787FC15-A95B-42D9-8FE8-CB4B16BE9BA8}"/>
               </a:ext>
             </a:extLst>
           </p:cNvPr>
@@ -4765,7 +4762,7 @@
           <p:cNvPr id="9" name="">
             <a:extLst xmlns:a="http://schemas.openxmlformats.org/drawingml/2006/main">
               <a:ext uri="{FF2B5EF4-FFF2-40B4-BE49-F238E27FC236}">
-                <a16:creationId xmlns:a16="http://schemas.microsoft.com/office/drawing/2014/main" id="{800B39FD-8610-4BD1-9DFE-BDC4B5B9706A}"/>
+                <a16:creationId xmlns:a16="http://schemas.microsoft.com/office/drawing/2014/main" id="{841D659D-4EBA-4871-93E9-A0CC7E031859}"/>
               </a:ext>
             </a:extLst>
           </p:cNvPr>
@@ -4810,7 +4807,7 @@
           <p:cNvPr id="10" name="badge-pregnancy-insulin">
             <a:extLst xmlns:a="http://schemas.openxmlformats.org/drawingml/2006/main">
               <a:ext uri="{FF2B5EF4-FFF2-40B4-BE49-F238E27FC236}">
-                <a16:creationId xmlns:a16="http://schemas.microsoft.com/office/drawing/2014/main" id="{7C7F3941-522A-43D3-BAC9-C91F990A1468}"/>
+                <a16:creationId xmlns:a16="http://schemas.microsoft.com/office/drawing/2014/main" id="{C6B2344D-E431-48F1-A0E7-EA858EFF3FB9}"/>
               </a:ext>
             </a:extLst>
           </p:cNvPr>
@@ -4839,7 +4836,7 @@
           <p:cNvPr id="11" name="">
             <a:extLst xmlns:a="http://schemas.openxmlformats.org/drawingml/2006/main">
               <a:ext uri="{FF2B5EF4-FFF2-40B4-BE49-F238E27FC236}">
-                <a16:creationId xmlns:a16="http://schemas.microsoft.com/office/drawing/2014/main" id="{581E7F01-E587-4DBC-BFD2-9BAD4CF423B5}"/>
+                <a16:creationId xmlns:a16="http://schemas.microsoft.com/office/drawing/2014/main" id="{ADFFA5C3-CDE0-43D2-8B40-A531C05398B9}"/>
               </a:ext>
             </a:extLst>
           </p:cNvPr>
@@ -4884,7 +4881,7 @@
           <p:cNvPr id="12" name="badge-oxygen-power-loss">
             <a:extLst xmlns:a="http://schemas.openxmlformats.org/drawingml/2006/main">
               <a:ext uri="{FF2B5EF4-FFF2-40B4-BE49-F238E27FC236}">
-                <a16:creationId xmlns:a16="http://schemas.microsoft.com/office/drawing/2014/main" id="{235E1DF7-D0C4-4351-9D3F-0E8741451A6D}"/>
+                <a16:creationId xmlns:a16="http://schemas.microsoft.com/office/drawing/2014/main" id="{BD0C2C4F-EA64-4D84-AE32-59F907E892D7}"/>
               </a:ext>
             </a:extLst>
           </p:cNvPr>
@@ -4913,7 +4910,7 @@
           <p:cNvPr id="13" name="">
             <a:extLst xmlns:a="http://schemas.openxmlformats.org/drawingml/2006/main">
               <a:ext uri="{FF2B5EF4-FFF2-40B4-BE49-F238E27FC236}">
-                <a16:creationId xmlns:a16="http://schemas.microsoft.com/office/drawing/2014/main" id="{ACB26979-D4E2-40C7-ABF7-B2B7E1838AE8}"/>
+                <a16:creationId xmlns:a16="http://schemas.microsoft.com/office/drawing/2014/main" id="{210812F9-8DAA-4D5D-A0FB-41FE92C97983}"/>
               </a:ext>
             </a:extLst>
           </p:cNvPr>
@@ -4958,7 +4955,7 @@
           <p:cNvPr id="14" name="badge-language-access-barrier">
             <a:extLst xmlns:a="http://schemas.openxmlformats.org/drawingml/2006/main">
               <a:ext uri="{FF2B5EF4-FFF2-40B4-BE49-F238E27FC236}">
-                <a16:creationId xmlns:a16="http://schemas.microsoft.com/office/drawing/2014/main" id="{9BA6AA05-E0F4-4DDC-B747-2ECA234123D2}"/>
+                <a16:creationId xmlns:a16="http://schemas.microsoft.com/office/drawing/2014/main" id="{23C23F53-DE60-4602-AA5F-EFE5DFFBEA9C}"/>
               </a:ext>
             </a:extLst>
           </p:cNvPr>
@@ -4987,7 +4984,7 @@
           <p:cNvPr id="15" name="">
             <a:extLst xmlns:a="http://schemas.openxmlformats.org/drawingml/2006/main">
               <a:ext uri="{FF2B5EF4-FFF2-40B4-BE49-F238E27FC236}">
-                <a16:creationId xmlns:a16="http://schemas.microsoft.com/office/drawing/2014/main" id="{9A1162E7-BAEB-4E1F-B85D-8D6AABD9B001}"/>
+                <a16:creationId xmlns:a16="http://schemas.microsoft.com/office/drawing/2014/main" id="{D7FE1E32-E83B-4360-A7EE-0F9796461A65}"/>
               </a:ext>
             </a:extLst>
           </p:cNvPr>
@@ -5032,7 +5029,7 @@
           <p:cNvPr id="16" name="badge-unverified-shelter-rumor">
             <a:extLst xmlns:a="http://schemas.openxmlformats.org/drawingml/2006/main">
               <a:ext uri="{FF2B5EF4-FFF2-40B4-BE49-F238E27FC236}">
-                <a16:creationId xmlns:a16="http://schemas.microsoft.com/office/drawing/2014/main" id="{DC93771D-EA0B-4E3B-B1E8-76528F92CF02}"/>
+                <a16:creationId xmlns:a16="http://schemas.microsoft.com/office/drawing/2014/main" id="{3F29BB98-ED28-4479-9F56-62324E60462A}"/>
               </a:ext>
             </a:extLst>
           </p:cNvPr>
@@ -5061,7 +5058,7 @@
           <p:cNvPr id="17" name="">
             <a:extLst xmlns:a="http://schemas.openxmlformats.org/drawingml/2006/main">
               <a:ext uri="{FF2B5EF4-FFF2-40B4-BE49-F238E27FC236}">
-                <a16:creationId xmlns:a16="http://schemas.microsoft.com/office/drawing/2014/main" id="{80B8AE17-445B-42F3-9084-9B9519C988D0}"/>
+                <a16:creationId xmlns:a16="http://schemas.microsoft.com/office/drawing/2014/main" id="{727D6E01-641E-4D0A-8157-3C8D871506CA}"/>
               </a:ext>
             </a:extLst>
           </p:cNvPr>
@@ -5103,10 +5100,10 @@
       </p:sp>
       <p:sp>
         <p:nvSpPr>
-          <p:cNvPr id="18" name="badge-floodwater-hazard">
-            <a:extLst xmlns:a="http://schemas.openxmlformats.org/drawingml/2006/main">
-              <a:ext uri="{FF2B5EF4-FFF2-40B4-BE49-F238E27FC236}">
-                <a16:creationId xmlns:a16="http://schemas.microsoft.com/office/drawing/2014/main" id="{AC81040C-5A96-4DA8-B6FA-324678420F40}"/>
+          <p:cNvPr id="18" name="badge-official-resource-routing">
+            <a:extLst xmlns:a="http://schemas.openxmlformats.org/drawingml/2006/main">
+              <a:ext uri="{FF2B5EF4-FFF2-40B4-BE49-F238E27FC236}">
+                <a16:creationId xmlns:a16="http://schemas.microsoft.com/office/drawing/2014/main" id="{73ECEBAE-3799-4BFE-812B-B485767EDE5E}"/>
               </a:ext>
             </a:extLst>
           </p:cNvPr>
@@ -5135,19 +5132,19 @@
           <p:cNvPr id="19" name="">
             <a:extLst xmlns:a="http://schemas.openxmlformats.org/drawingml/2006/main">
               <a:ext uri="{FF2B5EF4-FFF2-40B4-BE49-F238E27FC236}">
-                <a16:creationId xmlns:a16="http://schemas.microsoft.com/office/drawing/2014/main" id="{F28D7CAC-AD17-43B9-B2F7-3982FBBEA578}"/>
-              </a:ext>
-            </a:extLst>
-          </p:cNvPr>
-          <p:cNvSpPr>
-            <a:spLocks xmlns:a="http://schemas.openxmlformats.org/drawingml/2006/main" noGrp="1"/>
-          </p:cNvSpPr>
-          <p:nvPr/>
-        </p:nvSpPr>
-        <p:spPr>
-          <a:xfrm xmlns:a="http://schemas.openxmlformats.org/drawingml/2006/main">
-            <a:off x="9886950" y="8477250"/>
-            <a:ext cx="1295400" cy="190500"/>
+                <a16:creationId xmlns:a16="http://schemas.microsoft.com/office/drawing/2014/main" id="{6B59F97F-F9E9-414E-B8B5-844F17C6607D}"/>
+              </a:ext>
+            </a:extLst>
+          </p:cNvPr>
+          <p:cNvSpPr>
+            <a:spLocks xmlns:a="http://schemas.openxmlformats.org/drawingml/2006/main" noGrp="1"/>
+          </p:cNvSpPr>
+          <p:nvPr/>
+        </p:nvSpPr>
+        <p:spPr>
+          <a:xfrm xmlns:a="http://schemas.openxmlformats.org/drawingml/2006/main">
+            <a:off x="9696450" y="8362950"/>
+            <a:ext cx="1676400" cy="419100"/>
           </a:xfrm>
           <a:prstGeom xmlns:a="http://schemas.openxmlformats.org/drawingml/2006/main" prst="rect">
             <a:avLst/>
@@ -5170,17 +5167,17 @@
                   <a:srgbClr val="10151F"/>
                 </a:solidFill>
               </a:rPr>
-              <a:t>floodwater hazard</a:t>
-            </a:r>
-          </a:p>
-        </p:txBody>
-      </p:sp>
-      <p:sp>
-        <p:nvSpPr>
-          <p:cNvPr id="20" name="badge-responder-escalation">
-            <a:extLst xmlns:a="http://schemas.openxmlformats.org/drawingml/2006/main">
-              <a:ext uri="{FF2B5EF4-FFF2-40B4-BE49-F238E27FC236}">
-                <a16:creationId xmlns:a16="http://schemas.microsoft.com/office/drawing/2014/main" id="{B6078D25-9C14-4976-B8B4-04E12DFB28F0}"/>
+              <a:t>official resource routing</a:t>
+            </a:r>
+          </a:p>
+        </p:txBody>
+      </p:sp>
+      <p:sp>
+        <p:nvSpPr>
+          <p:cNvPr id="20" name="badge-responder-handoff">
+            <a:extLst xmlns:a="http://schemas.openxmlformats.org/drawingml/2006/main">
+              <a:ext uri="{FF2B5EF4-FFF2-40B4-BE49-F238E27FC236}">
+                <a16:creationId xmlns:a16="http://schemas.microsoft.com/office/drawing/2014/main" id="{AD60F445-FDBF-411D-983D-61B2671D24A8}"/>
               </a:ext>
             </a:extLst>
           </p:cNvPr>
@@ -5209,19 +5206,19 @@
           <p:cNvPr id="21" name="">
             <a:extLst xmlns:a="http://schemas.openxmlformats.org/drawingml/2006/main">
               <a:ext uri="{FF2B5EF4-FFF2-40B4-BE49-F238E27FC236}">
-                <a16:creationId xmlns:a16="http://schemas.microsoft.com/office/drawing/2014/main" id="{9FAF0F34-8725-4BDB-A3C4-C3BA22DCCDA0}"/>
-              </a:ext>
-            </a:extLst>
-          </p:cNvPr>
-          <p:cNvSpPr>
-            <a:spLocks xmlns:a="http://schemas.openxmlformats.org/drawingml/2006/main" noGrp="1"/>
-          </p:cNvSpPr>
-          <p:nvPr/>
-        </p:nvSpPr>
-        <p:spPr>
-          <a:xfrm xmlns:a="http://schemas.openxmlformats.org/drawingml/2006/main">
-            <a:off x="14478000" y="8477250"/>
-            <a:ext cx="1485900" cy="190500"/>
+                <a16:creationId xmlns:a16="http://schemas.microsoft.com/office/drawing/2014/main" id="{34C77C42-671E-4833-87D3-2EC06A6BAE83}"/>
+              </a:ext>
+            </a:extLst>
+          </p:cNvPr>
+          <p:cNvSpPr>
+            <a:spLocks xmlns:a="http://schemas.openxmlformats.org/drawingml/2006/main" noGrp="1"/>
+          </p:cNvSpPr>
+          <p:nvPr/>
+        </p:nvSpPr>
+        <p:spPr>
+          <a:xfrm xmlns:a="http://schemas.openxmlformats.org/drawingml/2006/main">
+            <a:off x="14554200" y="8362950"/>
+            <a:ext cx="1333500" cy="419100"/>
           </a:xfrm>
           <a:prstGeom xmlns:a="http://schemas.openxmlformats.org/drawingml/2006/main" prst="rect">
             <a:avLst/>
@@ -5244,7 +5241,7 @@
                   <a:srgbClr val="10151F"/>
                 </a:solidFill>
               </a:rPr>
-              <a:t>responder escalation</a:t>
+              <a:t>responder handoff</a:t>
             </a:r>
           </a:p>
         </p:txBody>
@@ -5252,7 +5249,7 @@
     </p:spTree>
     <p:extLst>
       <p:ext uri="{BB962C8B-B14F-4D97-AF65-F5344CB8AC3E}">
-        <p14:creationId xmlns:p14="http://schemas.microsoft.com/office/powerpoint/2010/main" val="455392586"/>
+        <p14:creationId xmlns:p14="http://schemas.microsoft.com/office/powerpoint/2010/main" val="872388824"/>
       </p:ext>
     </p:extLst>
   </p:cSld>
@@ -5276,7 +5273,7 @@
           <p:cNvPr id="1" name="background">
             <a:extLst xmlns:a="http://schemas.openxmlformats.org/drawingml/2006/main">
               <a:ext uri="{FF2B5EF4-FFF2-40B4-BE49-F238E27FC236}">
-                <a16:creationId xmlns:a16="http://schemas.microsoft.com/office/drawing/2014/main" id="{F1DAB8DE-1346-4DCE-8E65-997CE9C44C62}"/>
+                <a16:creationId xmlns:a16="http://schemas.microsoft.com/office/drawing/2014/main" id="{A785B97E-8450-4E50-85FF-C4FFD2AADFC7}"/>
               </a:ext>
             </a:extLst>
           </p:cNvPr>
@@ -5303,7 +5300,7 @@
           <p:cNvPr id="2" name="">
             <a:extLst xmlns:a="http://schemas.openxmlformats.org/drawingml/2006/main">
               <a:ext uri="{FF2B5EF4-FFF2-40B4-BE49-F238E27FC236}">
-                <a16:creationId xmlns:a16="http://schemas.microsoft.com/office/drawing/2014/main" id="{2AAFE63F-7EBA-437A-89D3-9EF0F61B1D04}"/>
+                <a16:creationId xmlns:a16="http://schemas.microsoft.com/office/drawing/2014/main" id="{141DE91E-D10C-4BE3-97F6-514923CD8B7A}"/>
               </a:ext>
             </a:extLst>
           </p:cNvPr>
@@ -5330,7 +5327,7 @@
           <p:cNvPr id="3" name="">
             <a:extLst xmlns:a="http://schemas.openxmlformats.org/drawingml/2006/main">
               <a:ext uri="{FF2B5EF4-FFF2-40B4-BE49-F238E27FC236}">
-                <a16:creationId xmlns:a16="http://schemas.microsoft.com/office/drawing/2014/main" id="{4972FFAB-3E34-4117-B231-102ABA0C90A3}"/>
+                <a16:creationId xmlns:a16="http://schemas.microsoft.com/office/drawing/2014/main" id="{53B8AAF7-4BED-4F46-BEF7-D3180A7BF77F}"/>
               </a:ext>
             </a:extLst>
           </p:cNvPr>
@@ -5375,7 +5372,7 @@
           <p:cNvPr id="4" name="">
             <a:extLst xmlns:a="http://schemas.openxmlformats.org/drawingml/2006/main">
               <a:ext uri="{FF2B5EF4-FFF2-40B4-BE49-F238E27FC236}">
-                <a16:creationId xmlns:a16="http://schemas.microsoft.com/office/drawing/2014/main" id="{C5FE7818-652B-4705-9671-4D5FD38C38CC}"/>
+                <a16:creationId xmlns:a16="http://schemas.microsoft.com/office/drawing/2014/main" id="{86D014DA-EF3F-4357-92AF-FF935185639E}"/>
               </a:ext>
             </a:extLst>
           </p:cNvPr>
@@ -5420,7 +5417,7 @@
           <p:cNvPr id="5" name="">
             <a:extLst xmlns:a="http://schemas.openxmlformats.org/drawingml/2006/main">
               <a:ext uri="{FF2B5EF4-FFF2-40B4-BE49-F238E27FC236}">
-                <a16:creationId xmlns:a16="http://schemas.microsoft.com/office/drawing/2014/main" id="{01400FC5-FD5D-4162-8F7C-1DBBE573F549}"/>
+                <a16:creationId xmlns:a16="http://schemas.microsoft.com/office/drawing/2014/main" id="{2CE7BC1C-0EF7-48D9-A47E-C8779E1B6B9D}"/>
               </a:ext>
             </a:extLst>
           </p:cNvPr>
@@ -5472,7 +5469,7 @@
         </p:xfrm>
         <a:graphic xmlns:a="http://schemas.openxmlformats.org/drawingml/2006/main">
           <a:graphicData uri="http://schemas.openxmlformats.org/drawingml/2006/chart">
-            <c:chart xmlns:r="http://schemas.openxmlformats.org/officeDocument/2006/relationships" xmlns:c="http://schemas.openxmlformats.org/drawingml/2006/chart" r:id="Reb44abe68c3a4d15"/>
+            <c:chart xmlns:r="http://schemas.openxmlformats.org/officeDocument/2006/relationships" xmlns:c="http://schemas.openxmlformats.org/drawingml/2006/chart" r:id="R3f1b886a38ee45b4"/>
           </a:graphicData>
         </a:graphic>
       </p:graphicFrame>
@@ -5481,7 +5478,7 @@
           <p:cNvPr id="7" name="">
             <a:extLst xmlns:a="http://schemas.openxmlformats.org/drawingml/2006/main">
               <a:ext uri="{FF2B5EF4-FFF2-40B4-BE49-F238E27FC236}">
-                <a16:creationId xmlns:a16="http://schemas.microsoft.com/office/drawing/2014/main" id="{D7E91095-ACDE-462B-9324-EBAF50F9DF86}"/>
+                <a16:creationId xmlns:a16="http://schemas.microsoft.com/office/drawing/2014/main" id="{A6AA0800-EDB8-436F-97F6-2A37CDF554FE}"/>
               </a:ext>
             </a:extLst>
           </p:cNvPr>
@@ -5526,7 +5523,7 @@
           <p:cNvPr id="8" name="">
             <a:extLst xmlns:a="http://schemas.openxmlformats.org/drawingml/2006/main">
               <a:ext uri="{FF2B5EF4-FFF2-40B4-BE49-F238E27FC236}">
-                <a16:creationId xmlns:a16="http://schemas.microsoft.com/office/drawing/2014/main" id="{086C4E62-CA16-4E56-8F0A-08950EDFA95C}"/>
+                <a16:creationId xmlns:a16="http://schemas.microsoft.com/office/drawing/2014/main" id="{0940C905-E0EC-44BC-BB64-BE13C781F547}"/>
               </a:ext>
             </a:extLst>
           </p:cNvPr>
@@ -5571,7 +5568,7 @@
           <p:cNvPr id="9" name="">
             <a:extLst xmlns:a="http://schemas.openxmlformats.org/drawingml/2006/main">
               <a:ext uri="{FF2B5EF4-FFF2-40B4-BE49-F238E27FC236}">
-                <a16:creationId xmlns:a16="http://schemas.microsoft.com/office/drawing/2014/main" id="{B38C2F03-CAE6-4800-9CBF-85EF092695ED}"/>
+                <a16:creationId xmlns:a16="http://schemas.microsoft.com/office/drawing/2014/main" id="{D64EFDBF-4A0C-43C5-8F5F-84E4258A6C2B}"/>
               </a:ext>
             </a:extLst>
           </p:cNvPr>
@@ -5616,7 +5613,7 @@
           <p:cNvPr id="10" name="">
             <a:extLst xmlns:a="http://schemas.openxmlformats.org/drawingml/2006/main">
               <a:ext uri="{FF2B5EF4-FFF2-40B4-BE49-F238E27FC236}">
-                <a16:creationId xmlns:a16="http://schemas.microsoft.com/office/drawing/2014/main" id="{1C89836F-3828-4503-A389-FE173AC28D06}"/>
+                <a16:creationId xmlns:a16="http://schemas.microsoft.com/office/drawing/2014/main" id="{2123859E-A145-4D35-BC62-62531060EDB4}"/>
               </a:ext>
             </a:extLst>
           </p:cNvPr>
@@ -5661,7 +5658,7 @@
           <p:cNvPr id="11" name="">
             <a:extLst xmlns:a="http://schemas.openxmlformats.org/drawingml/2006/main">
               <a:ext uri="{FF2B5EF4-FFF2-40B4-BE49-F238E27FC236}">
-                <a16:creationId xmlns:a16="http://schemas.microsoft.com/office/drawing/2014/main" id="{925D28A0-0C15-4B5B-945A-8B3FF3C465F6}"/>
+                <a16:creationId xmlns:a16="http://schemas.microsoft.com/office/drawing/2014/main" id="{B4D39B74-C97A-4122-8FD7-2DDAB6856C4C}"/>
               </a:ext>
             </a:extLst>
           </p:cNvPr>
@@ -5696,7 +5693,7 @@
                   <a:srgbClr val="FF5A66"/>
                 </a:solidFill>
               </a:rPr>
-              <a:t>5/5</a:t>
+              <a:t>6/6</a:t>
             </a:r>
           </a:p>
         </p:txBody>
@@ -5706,7 +5703,7 @@
           <p:cNvPr id="12" name="">
             <a:extLst xmlns:a="http://schemas.openxmlformats.org/drawingml/2006/main">
               <a:ext uri="{FF2B5EF4-FFF2-40B4-BE49-F238E27FC236}">
-                <a16:creationId xmlns:a16="http://schemas.microsoft.com/office/drawing/2014/main" id="{AC67A56C-55CB-451E-90C9-4E9D8F39C69D}"/>
+                <a16:creationId xmlns:a16="http://schemas.microsoft.com/office/drawing/2014/main" id="{D18B3D17-46DE-4087-86D2-C109D1B02DC5}"/>
               </a:ext>
             </a:extLst>
           </p:cNvPr>
@@ -5751,7 +5748,7 @@
           <p:cNvPr id="13" name="footer">
             <a:extLst xmlns:a="http://schemas.openxmlformats.org/drawingml/2006/main">
               <a:ext uri="{FF2B5EF4-FFF2-40B4-BE49-F238E27FC236}">
-                <a16:creationId xmlns:a16="http://schemas.microsoft.com/office/drawing/2014/main" id="{C818BD44-32A9-4799-A548-2BBC163C3F1D}"/>
+                <a16:creationId xmlns:a16="http://schemas.microsoft.com/office/drawing/2014/main" id="{A1D7C4C6-DDF5-447F-9254-E6AC6B659610}"/>
               </a:ext>
             </a:extLst>
           </p:cNvPr>
@@ -5794,7 +5791,7 @@
     </p:spTree>
     <p:extLst>
       <p:ext uri="{BB962C8B-B14F-4D97-AF65-F5344CB8AC3E}">
-        <p14:creationId xmlns:p14="http://schemas.microsoft.com/office/powerpoint/2010/main" val="1924052551"/>
+        <p14:creationId xmlns:p14="http://schemas.microsoft.com/office/powerpoint/2010/main" val="128207758"/>
       </p:ext>
     </p:extLst>
   </p:cSld>
@@ -5818,7 +5815,7 @@
           <p:cNvPr id="1" name="background">
             <a:extLst xmlns:a="http://schemas.openxmlformats.org/drawingml/2006/main">
               <a:ext uri="{FF2B5EF4-FFF2-40B4-BE49-F238E27FC236}">
-                <a16:creationId xmlns:a16="http://schemas.microsoft.com/office/drawing/2014/main" id="{C7511343-61BE-428E-824E-5BFE37B73ACE}"/>
+                <a16:creationId xmlns:a16="http://schemas.microsoft.com/office/drawing/2014/main" id="{71D54F9E-14E9-4D54-893C-8F01D2ADB431}"/>
               </a:ext>
             </a:extLst>
           </p:cNvPr>
@@ -5845,7 +5842,7 @@
           <p:cNvPr id="2" name="">
             <a:extLst xmlns:a="http://schemas.openxmlformats.org/drawingml/2006/main">
               <a:ext uri="{FF2B5EF4-FFF2-40B4-BE49-F238E27FC236}">
-                <a16:creationId xmlns:a16="http://schemas.microsoft.com/office/drawing/2014/main" id="{7882B6A8-6F8F-4C22-954D-9789749C2730}"/>
+                <a16:creationId xmlns:a16="http://schemas.microsoft.com/office/drawing/2014/main" id="{739C78F0-F91E-4F57-9E2C-B5780BFE6D5F}"/>
               </a:ext>
             </a:extLst>
           </p:cNvPr>
@@ -5872,7 +5869,7 @@
           <p:cNvPr id="3" name="">
             <a:extLst xmlns:a="http://schemas.openxmlformats.org/drawingml/2006/main">
               <a:ext uri="{FF2B5EF4-FFF2-40B4-BE49-F238E27FC236}">
-                <a16:creationId xmlns:a16="http://schemas.microsoft.com/office/drawing/2014/main" id="{AF7D708B-3775-4D76-A29B-D40D1E6B3A76}"/>
+                <a16:creationId xmlns:a16="http://schemas.microsoft.com/office/drawing/2014/main" id="{5EAACADE-8219-4E86-B0C0-C1B8B0F6BD16}"/>
               </a:ext>
             </a:extLst>
           </p:cNvPr>
@@ -5917,7 +5914,7 @@
           <p:cNvPr id="4" name="">
             <a:extLst xmlns:a="http://schemas.openxmlformats.org/drawingml/2006/main">
               <a:ext uri="{FF2B5EF4-FFF2-40B4-BE49-F238E27FC236}">
-                <a16:creationId xmlns:a16="http://schemas.microsoft.com/office/drawing/2014/main" id="{1FBF3C4A-6376-4E54-ABFA-462CB2A83ACA}"/>
+                <a16:creationId xmlns:a16="http://schemas.microsoft.com/office/drawing/2014/main" id="{930C0151-6AD7-4A68-94D0-EE830ED52BA4}"/>
               </a:ext>
             </a:extLst>
           </p:cNvPr>
@@ -5962,7 +5959,7 @@
           <p:cNvPr id="5" name="">
             <a:extLst xmlns:a="http://schemas.openxmlformats.org/drawingml/2006/main">
               <a:ext uri="{FF2B5EF4-FFF2-40B4-BE49-F238E27FC236}">
-                <a16:creationId xmlns:a16="http://schemas.microsoft.com/office/drawing/2014/main" id="{2D7CE0B9-73EA-404F-A1AD-81388BD33AAA}"/>
+                <a16:creationId xmlns:a16="http://schemas.microsoft.com/office/drawing/2014/main" id="{8C452CC8-CE82-46DC-91A3-F9D454BE97D8}"/>
               </a:ext>
             </a:extLst>
           </p:cNvPr>
@@ -6007,7 +6004,7 @@
           <p:cNvPr id="6" name="badge-tesla-t4">
             <a:extLst xmlns:a="http://schemas.openxmlformats.org/drawingml/2006/main">
               <a:ext uri="{FF2B5EF4-FFF2-40B4-BE49-F238E27FC236}">
-                <a16:creationId xmlns:a16="http://schemas.microsoft.com/office/drawing/2014/main" id="{05FC7A06-3BEC-45AA-A33D-90EA270B2203}"/>
+                <a16:creationId xmlns:a16="http://schemas.microsoft.com/office/drawing/2014/main" id="{EBE8A4D3-FF79-4B0B-B3CF-AF1A77F3BE79}"/>
               </a:ext>
             </a:extLst>
           </p:cNvPr>
@@ -6036,7 +6033,7 @@
           <p:cNvPr id="7" name="">
             <a:extLst xmlns:a="http://schemas.openxmlformats.org/drawingml/2006/main">
               <a:ext uri="{FF2B5EF4-FFF2-40B4-BE49-F238E27FC236}">
-                <a16:creationId xmlns:a16="http://schemas.microsoft.com/office/drawing/2014/main" id="{FF51916C-156B-47E5-8EAE-D18ED872F759}"/>
+                <a16:creationId xmlns:a16="http://schemas.microsoft.com/office/drawing/2014/main" id="{1AB0D011-9F68-4A87-8A75-BB0D548DF49A}"/>
               </a:ext>
             </a:extLst>
           </p:cNvPr>
@@ -6081,7 +6078,7 @@
           <p:cNvPr id="8" name="badge-160-new-tokens">
             <a:extLst xmlns:a="http://schemas.openxmlformats.org/drawingml/2006/main">
               <a:ext uri="{FF2B5EF4-FFF2-40B4-BE49-F238E27FC236}">
-                <a16:creationId xmlns:a16="http://schemas.microsoft.com/office/drawing/2014/main" id="{E977EE89-0837-4E34-B956-68D0284257F3}"/>
+                <a16:creationId xmlns:a16="http://schemas.microsoft.com/office/drawing/2014/main" id="{97FDC2E6-13E5-4945-BB67-A7A7F9A99D2F}"/>
               </a:ext>
             </a:extLst>
           </p:cNvPr>
@@ -6110,7 +6107,7 @@
           <p:cNvPr id="9" name="">
             <a:extLst xmlns:a="http://schemas.openxmlformats.org/drawingml/2006/main">
               <a:ext uri="{FF2B5EF4-FFF2-40B4-BE49-F238E27FC236}">
-                <a16:creationId xmlns:a16="http://schemas.microsoft.com/office/drawing/2014/main" id="{5D15CCD2-42EF-4C70-836C-F8A4EE292565}"/>
+                <a16:creationId xmlns:a16="http://schemas.microsoft.com/office/drawing/2014/main" id="{1D037025-4B7D-4F8F-BE2B-B40EB9586FBB}"/>
               </a:ext>
             </a:extLst>
           </p:cNvPr>
@@ -6155,7 +6152,7 @@
           <p:cNvPr id="10" name="badge-18-014s-recorded-latency">
             <a:extLst xmlns:a="http://schemas.openxmlformats.org/drawingml/2006/main">
               <a:ext uri="{FF2B5EF4-FFF2-40B4-BE49-F238E27FC236}">
-                <a16:creationId xmlns:a16="http://schemas.microsoft.com/office/drawing/2014/main" id="{5D4E2D87-8BB5-4C2C-B476-24B8CDD5325E}"/>
+                <a16:creationId xmlns:a16="http://schemas.microsoft.com/office/drawing/2014/main" id="{FE86A578-EB10-4001-BBD5-E8DA99856549}"/>
               </a:ext>
             </a:extLst>
           </p:cNvPr>
@@ -6184,7 +6181,7 @@
           <p:cNvPr id="11" name="">
             <a:extLst xmlns:a="http://schemas.openxmlformats.org/drawingml/2006/main">
               <a:ext uri="{FF2B5EF4-FFF2-40B4-BE49-F238E27FC236}">
-                <a16:creationId xmlns:a16="http://schemas.microsoft.com/office/drawing/2014/main" id="{0A96362F-2D61-47B3-BA00-D22692A64850}"/>
+                <a16:creationId xmlns:a16="http://schemas.microsoft.com/office/drawing/2014/main" id="{B0784861-FDC2-4185-82A7-117470EC56FD}"/>
               </a:ext>
             </a:extLst>
           </p:cNvPr>
@@ -6229,7 +6226,7 @@
           <p:cNvPr id="12" name="">
             <a:extLst xmlns:a="http://schemas.openxmlformats.org/drawingml/2006/main">
               <a:ext uri="{FF2B5EF4-FFF2-40B4-BE49-F238E27FC236}">
-                <a16:creationId xmlns:a16="http://schemas.microsoft.com/office/drawing/2014/main" id="{8CD3DB13-5956-4E2E-BF6F-873B50869B67}"/>
+                <a16:creationId xmlns:a16="http://schemas.microsoft.com/office/drawing/2014/main" id="{025C52B5-EA26-4839-8AF5-C0E450F9105B}"/>
               </a:ext>
             </a:extLst>
           </p:cNvPr>
@@ -6268,7 +6265,7 @@
           <p:nvPr/>
         </p:nvPicPr>
         <p:blipFill>
-          <a:blip xmlns:r="http://schemas.openxmlformats.org/officeDocument/2006/relationships" xmlns:a="http://schemas.openxmlformats.org/drawingml/2006/main" r:embed="R63029c33cd7741e6"/>
+          <a:blip xmlns:r="http://schemas.openxmlformats.org/officeDocument/2006/relationships" xmlns:a="http://schemas.openxmlformats.org/drawingml/2006/main" r:embed="R195b01e61e6f4e2f"/>
           <a:stretch xmlns:a="http://schemas.openxmlformats.org/drawingml/2006/main"/>
         </p:blipFill>
         <p:spPr>
@@ -6284,7 +6281,7 @@
     </p:spTree>
     <p:extLst>
       <p:ext uri="{BB962C8B-B14F-4D97-AF65-F5344CB8AC3E}">
-        <p14:creationId xmlns:p14="http://schemas.microsoft.com/office/powerpoint/2010/main" val="1275719242"/>
+        <p14:creationId xmlns:p14="http://schemas.microsoft.com/office/powerpoint/2010/main" val="285641546"/>
       </p:ext>
     </p:extLst>
   </p:cSld>
@@ -6308,7 +6305,7 @@
           <p:cNvPr id="1" name="background">
             <a:extLst xmlns:a="http://schemas.openxmlformats.org/drawingml/2006/main">
               <a:ext uri="{FF2B5EF4-FFF2-40B4-BE49-F238E27FC236}">
-                <a16:creationId xmlns:a16="http://schemas.microsoft.com/office/drawing/2014/main" id="{65AD927D-86C2-4C56-B959-8FDCC794F58F}"/>
+                <a16:creationId xmlns:a16="http://schemas.microsoft.com/office/drawing/2014/main" id="{0BF2CED1-ECFF-46B9-8C27-56904CFBC246}"/>
               </a:ext>
             </a:extLst>
           </p:cNvPr>
@@ -6335,7 +6332,7 @@
           <p:cNvPr id="2" name="">
             <a:extLst xmlns:a="http://schemas.openxmlformats.org/drawingml/2006/main">
               <a:ext uri="{FF2B5EF4-FFF2-40B4-BE49-F238E27FC236}">
-                <a16:creationId xmlns:a16="http://schemas.microsoft.com/office/drawing/2014/main" id="{44A9BB0A-D7BD-4C50-ACAF-8A73015425DE}"/>
+                <a16:creationId xmlns:a16="http://schemas.microsoft.com/office/drawing/2014/main" id="{CE00F30E-E226-4B61-BF7D-FA1832432C10}"/>
               </a:ext>
             </a:extLst>
           </p:cNvPr>
@@ -6362,7 +6359,7 @@
           <p:cNvPr id="3" name="">
             <a:extLst xmlns:a="http://schemas.openxmlformats.org/drawingml/2006/main">
               <a:ext uri="{FF2B5EF4-FFF2-40B4-BE49-F238E27FC236}">
-                <a16:creationId xmlns:a16="http://schemas.microsoft.com/office/drawing/2014/main" id="{6BB79A20-DED8-4C17-81EA-EAADBD48921E}"/>
+                <a16:creationId xmlns:a16="http://schemas.microsoft.com/office/drawing/2014/main" id="{0F88546D-3658-4220-A71F-A2EF0B252D1F}"/>
               </a:ext>
             </a:extLst>
           </p:cNvPr>
@@ -6407,7 +6404,7 @@
           <p:cNvPr id="4" name="">
             <a:extLst xmlns:a="http://schemas.openxmlformats.org/drawingml/2006/main">
               <a:ext uri="{FF2B5EF4-FFF2-40B4-BE49-F238E27FC236}">
-                <a16:creationId xmlns:a16="http://schemas.microsoft.com/office/drawing/2014/main" id="{9D9C118D-62F0-4006-BD44-265CC8A9D38E}"/>
+                <a16:creationId xmlns:a16="http://schemas.microsoft.com/office/drawing/2014/main" id="{4D3E97F4-5B5E-4C82-A496-809F774F8BA0}"/>
               </a:ext>
             </a:extLst>
           </p:cNvPr>
@@ -6452,7 +6449,7 @@
           <p:cNvPr id="5" name="">
             <a:extLst xmlns:a="http://schemas.openxmlformats.org/drawingml/2006/main">
               <a:ext uri="{FF2B5EF4-FFF2-40B4-BE49-F238E27FC236}">
-                <a16:creationId xmlns:a16="http://schemas.microsoft.com/office/drawing/2014/main" id="{B161BA29-D0D5-4A8B-AE3E-F789052A6A69}"/>
+                <a16:creationId xmlns:a16="http://schemas.microsoft.com/office/drawing/2014/main" id="{70312FF7-F170-4D54-B4B6-31B089D2198B}"/>
               </a:ext>
             </a:extLst>
           </p:cNvPr>
@@ -6464,7 +6461,7 @@
         <p:spPr>
           <a:xfrm xmlns:a="http://schemas.openxmlformats.org/drawingml/2006/main">
             <a:off x="895350" y="3067050"/>
-            <a:ext cx="11715750" cy="685800"/>
+            <a:ext cx="11277600" cy="685800"/>
           </a:xfrm>
           <a:prstGeom xmlns:a="http://schemas.openxmlformats.org/drawingml/2006/main" prst="rect">
             <a:avLst/>
@@ -6487,7 +6484,7 @@
                   <a:srgbClr val="D6DEE9"/>
                 </a:solidFill>
               </a:rPr>
-              <a:t>This is deliberately narrow: one crisis workflow, visible safety constraints, public evidence, and a clear path to stronger multilingual Gemma 4 generation.</a:t>
+              <a:t>This is deliberately narrow: one crisis workflow, visible safety constraints, official-resource checks, public evidence, and a clear path to stronger multilingual Gemma 4 generation.</a:t>
             </a:r>
           </a:p>
         </p:txBody>
@@ -6497,7 +6494,7 @@
           <p:cNvPr id="6" name="">
             <a:extLst xmlns:a="http://schemas.openxmlformats.org/drawingml/2006/main">
               <a:ext uri="{FF2B5EF4-FFF2-40B4-BE49-F238E27FC236}">
-                <a16:creationId xmlns:a16="http://schemas.microsoft.com/office/drawing/2014/main" id="{44F2DBD8-B848-4AAB-90F5-1212224C3491}"/>
+                <a16:creationId xmlns:a16="http://schemas.microsoft.com/office/drawing/2014/main" id="{F48BE8FC-0F5E-4614-85B9-3A620BEBC912}"/>
               </a:ext>
             </a:extLst>
           </p:cNvPr>
@@ -6526,7 +6523,7 @@
           <p:cNvPr id="7" name="">
             <a:extLst xmlns:a="http://schemas.openxmlformats.org/drawingml/2006/main">
               <a:ext uri="{FF2B5EF4-FFF2-40B4-BE49-F238E27FC236}">
-                <a16:creationId xmlns:a16="http://schemas.microsoft.com/office/drawing/2014/main" id="{7AFC54CD-8BA7-40A3-B799-D4D356D9DB2A}"/>
+                <a16:creationId xmlns:a16="http://schemas.microsoft.com/office/drawing/2014/main" id="{57E9CBBD-6EC4-400D-8FCA-7EEA292EC703}"/>
               </a:ext>
             </a:extLst>
           </p:cNvPr>
@@ -6571,7 +6568,7 @@
           <p:cNvPr id="8" name="">
             <a:extLst xmlns:a="http://schemas.openxmlformats.org/drawingml/2006/main">
               <a:ext uri="{FF2B5EF4-FFF2-40B4-BE49-F238E27FC236}">
-                <a16:creationId xmlns:a16="http://schemas.microsoft.com/office/drawing/2014/main" id="{99B36B39-A834-4E5D-A8DD-5B9757917434}"/>
+                <a16:creationId xmlns:a16="http://schemas.microsoft.com/office/drawing/2014/main" id="{D016BC71-60D8-4285-931D-2F768CC7CC92}"/>
               </a:ext>
             </a:extLst>
           </p:cNvPr>
@@ -6616,7 +6613,7 @@
           <p:cNvPr id="9" name="">
             <a:extLst xmlns:a="http://schemas.openxmlformats.org/drawingml/2006/main">
               <a:ext uri="{FF2B5EF4-FFF2-40B4-BE49-F238E27FC236}">
-                <a16:creationId xmlns:a16="http://schemas.microsoft.com/office/drawing/2014/main" id="{A0FA3228-773D-4FB2-9A04-CA1B82C4936A}"/>
+                <a16:creationId xmlns:a16="http://schemas.microsoft.com/office/drawing/2014/main" id="{33C0E762-2768-4D3E-BE7B-E10888AA5150}"/>
               </a:ext>
             </a:extLst>
           </p:cNvPr>
@@ -6645,7 +6642,7 @@
           <p:cNvPr id="10" name="">
             <a:extLst xmlns:a="http://schemas.openxmlformats.org/drawingml/2006/main">
               <a:ext uri="{FF2B5EF4-FFF2-40B4-BE49-F238E27FC236}">
-                <a16:creationId xmlns:a16="http://schemas.microsoft.com/office/drawing/2014/main" id="{9A3EC04C-AC5E-4219-82A4-D4A426A18C28}"/>
+                <a16:creationId xmlns:a16="http://schemas.microsoft.com/office/drawing/2014/main" id="{BAE6AD84-6483-49C5-9DC4-2B2B62006872}"/>
               </a:ext>
             </a:extLst>
           </p:cNvPr>
@@ -6690,7 +6687,7 @@
           <p:cNvPr id="11" name="">
             <a:extLst xmlns:a="http://schemas.openxmlformats.org/drawingml/2006/main">
               <a:ext uri="{FF2B5EF4-FFF2-40B4-BE49-F238E27FC236}">
-                <a16:creationId xmlns:a16="http://schemas.microsoft.com/office/drawing/2014/main" id="{E5609B85-AB31-4FAB-930B-C6EEA01C42AF}"/>
+                <a16:creationId xmlns:a16="http://schemas.microsoft.com/office/drawing/2014/main" id="{58DAA285-4CAD-4D23-8EE6-2C6A7E8FE1BC}"/>
               </a:ext>
             </a:extLst>
           </p:cNvPr>
@@ -6735,7 +6732,7 @@
           <p:cNvPr id="12" name="">
             <a:extLst xmlns:a="http://schemas.openxmlformats.org/drawingml/2006/main">
               <a:ext uri="{FF2B5EF4-FFF2-40B4-BE49-F238E27FC236}">
-                <a16:creationId xmlns:a16="http://schemas.microsoft.com/office/drawing/2014/main" id="{3E9C1AE2-B066-4C38-8C94-D7130CF9A6DC}"/>
+                <a16:creationId xmlns:a16="http://schemas.microsoft.com/office/drawing/2014/main" id="{6F4DBAE4-1FB4-424E-8B1A-05B6CAEB3FDE}"/>
               </a:ext>
             </a:extLst>
           </p:cNvPr>
@@ -6764,7 +6761,7 @@
           <p:cNvPr id="13" name="">
             <a:extLst xmlns:a="http://schemas.openxmlformats.org/drawingml/2006/main">
               <a:ext uri="{FF2B5EF4-FFF2-40B4-BE49-F238E27FC236}">
-                <a16:creationId xmlns:a16="http://schemas.microsoft.com/office/drawing/2014/main" id="{70EAB026-B352-4A62-9648-A3A77CA3224F}"/>
+                <a16:creationId xmlns:a16="http://schemas.microsoft.com/office/drawing/2014/main" id="{5E08C1F5-1E6C-4B08-887D-AF6F477880E1}"/>
               </a:ext>
             </a:extLst>
           </p:cNvPr>
@@ -6809,7 +6806,7 @@
           <p:cNvPr id="14" name="">
             <a:extLst xmlns:a="http://schemas.openxmlformats.org/drawingml/2006/main">
               <a:ext uri="{FF2B5EF4-FFF2-40B4-BE49-F238E27FC236}">
-                <a16:creationId xmlns:a16="http://schemas.microsoft.com/office/drawing/2014/main" id="{29E6D789-6E0C-4CCE-BC47-95EA30D19865}"/>
+                <a16:creationId xmlns:a16="http://schemas.microsoft.com/office/drawing/2014/main" id="{0A7E877D-B976-4F9B-B50C-AE10414448DA}"/>
               </a:ext>
             </a:extLst>
           </p:cNvPr>
@@ -6854,7 +6851,7 @@
           <p:cNvPr id="15" name="footer">
             <a:extLst xmlns:a="http://schemas.openxmlformats.org/drawingml/2006/main">
               <a:ext uri="{FF2B5EF4-FFF2-40B4-BE49-F238E27FC236}">
-                <a16:creationId xmlns:a16="http://schemas.microsoft.com/office/drawing/2014/main" id="{3605C099-5D30-435F-8F89-CDF071096EED}"/>
+                <a16:creationId xmlns:a16="http://schemas.microsoft.com/office/drawing/2014/main" id="{92B822D3-ADC7-4DA7-9C9D-A511D82D7B52}"/>
               </a:ext>
             </a:extLst>
           </p:cNvPr>
@@ -6897,7 +6894,7 @@
     </p:spTree>
     <p:extLst>
       <p:ext uri="{BB962C8B-B14F-4D97-AF65-F5344CB8AC3E}">
-        <p14:creationId xmlns:p14="http://schemas.microsoft.com/office/powerpoint/2010/main" val="1659834039"/>
+        <p14:creationId xmlns:p14="http://schemas.microsoft.com/office/powerpoint/2010/main" val="391581187"/>
       </p:ext>
     </p:extLst>
   </p:cSld>

</xml_diff>

<commit_message>
Refresh Resilience Copilot EXP-021 demo
Sync public GitHub Pages demo, README, pitch deck, and final submission bundle with the Kaggle EXP-021 final evidence package.
</commit_message>
<xml_diff>
--- a/resilience_copilot_pitch_v2.pptx
+++ b/resilience_copilot_pitch_v2.pptx
@@ -2,20 +2,20 @@
 <file path=ppt/presentation.xml><?xml version="1.0" encoding="utf-8"?>
 <p:presentation xmlns:p="http://schemas.openxmlformats.org/presentationml/2006/main">
   <p:sldMasterIdLst>
-    <p:sldMasterId xmlns:r="http://schemas.openxmlformats.org/officeDocument/2006/relationships" id="2147483648" r:id="R413a699b948c4c0b"/>
+    <p:sldMasterId xmlns:r="http://schemas.openxmlformats.org/officeDocument/2006/relationships" id="2147483648" r:id="R36bf89b1b7b2467e"/>
   </p:sldMasterIdLst>
   <p:notesMasterIdLst>
-    <p:notesMasterId xmlns:r="http://schemas.openxmlformats.org/officeDocument/2006/relationships" r:id="R059d02a8074141b5"/>
+    <p:notesMasterId xmlns:r="http://schemas.openxmlformats.org/officeDocument/2006/relationships" r:id="R25e3e1231c3b4ffb"/>
   </p:notesMasterIdLst>
   <p:sldIdLst>
-    <p:sldId xmlns:r="http://schemas.openxmlformats.org/officeDocument/2006/relationships" id="256" r:id="Rac03978c22ab41d6"/>
-    <p:sldId xmlns:r="http://schemas.openxmlformats.org/officeDocument/2006/relationships" id="257" r:id="R5dec164cd17648a0"/>
-    <p:sldId xmlns:r="http://schemas.openxmlformats.org/officeDocument/2006/relationships" id="258" r:id="R73fef34d4c6342b9"/>
-    <p:sldId xmlns:r="http://schemas.openxmlformats.org/officeDocument/2006/relationships" id="259" r:id="Rec6d31c428814424"/>
-    <p:sldId xmlns:r="http://schemas.openxmlformats.org/officeDocument/2006/relationships" id="260" r:id="Re8c6c5d06f564675"/>
-    <p:sldId xmlns:r="http://schemas.openxmlformats.org/officeDocument/2006/relationships" id="261" r:id="R6622a9eb7b084591"/>
-    <p:sldId xmlns:r="http://schemas.openxmlformats.org/officeDocument/2006/relationships" id="262" r:id="Reb17b779b8f441c8"/>
-    <p:sldId xmlns:r="http://schemas.openxmlformats.org/officeDocument/2006/relationships" id="263" r:id="Rbed4335f502c48fd"/>
+    <p:sldId xmlns:r="http://schemas.openxmlformats.org/officeDocument/2006/relationships" id="256" r:id="R9fd4d6e7d1c34dce"/>
+    <p:sldId xmlns:r="http://schemas.openxmlformats.org/officeDocument/2006/relationships" id="257" r:id="Rbcdfcf4a32ac45ea"/>
+    <p:sldId xmlns:r="http://schemas.openxmlformats.org/officeDocument/2006/relationships" id="258" r:id="Rff7d71ee778e472c"/>
+    <p:sldId xmlns:r="http://schemas.openxmlformats.org/officeDocument/2006/relationships" id="259" r:id="R1aff3d87c64f4421"/>
+    <p:sldId xmlns:r="http://schemas.openxmlformats.org/officeDocument/2006/relationships" id="260" r:id="R92853a9834f742c5"/>
+    <p:sldId xmlns:r="http://schemas.openxmlformats.org/officeDocument/2006/relationships" id="261" r:id="Rf431fb177cdf44b8"/>
+    <p:sldId xmlns:r="http://schemas.openxmlformats.org/officeDocument/2006/relationships" id="262" r:id="R75eb75443ea54f7d"/>
+    <p:sldId xmlns:r="http://schemas.openxmlformats.org/officeDocument/2006/relationships" id="263" r:id="R1ecfba7a175a45a9"/>
   </p:sldIdLst>
   <p:sldSz cx="18288000" cy="10287000"/>
   <p:notesSz cx="6858000" cy="9144000"/>
@@ -1024,7 +1024,7 @@
   </p:cSld>
   <p:clrMap bg1="lt1" tx1="dk1" bg2="lt2" tx2="dk2" accent1="accent1" accent2="accent2" accent3="accent3" accent4="accent4" accent5="accent5" accent6="accent6" hlink="hlink" folHlink="folHlink"/>
   <p:sldLayoutIdLst>
-    <p:sldLayoutId xmlns:r="http://schemas.openxmlformats.org/officeDocument/2006/relationships" id="2147483649" r:id="R4fb301c150c04e21"/>
+    <p:sldLayoutId xmlns:r="http://schemas.openxmlformats.org/officeDocument/2006/relationships" id="2147483649" r:id="R625455fffc194348"/>
   </p:sldLayoutIdLst>
   <p:txStyles>
     <p:titleStyle>
@@ -1363,7 +1363,7 @@
                 <c:v>2</c:v>
               </c:pt>
               <c:pt idx="2">
-                <c:v>6</c:v>
+                <c:v>10</c:v>
               </c:pt>
             </c:numLit>
           </c:val>
@@ -1399,7 +1399,7 @@
                 <c:v>2</c:v>
               </c:pt>
               <c:pt idx="2">
-                <c:v>6</c:v>
+                <c:v>10</c:v>
               </c:pt>
             </c:numLit>
           </c:val>
@@ -1515,7 +1515,7 @@
           <p:cNvPr id="1" name="background">
             <a:extLst xmlns:a="http://schemas.openxmlformats.org/drawingml/2006/main">
               <a:ext uri="{FF2B5EF4-FFF2-40B4-BE49-F238E27FC236}">
-                <a16:creationId xmlns:a16="http://schemas.microsoft.com/office/drawing/2014/main" id="{BDF78D5A-B8D7-41A8-87E8-1BD9893EC830}"/>
+                <a16:creationId xmlns:a16="http://schemas.microsoft.com/office/drawing/2014/main" id="{59D6D0B4-0AFF-4EDF-981D-052A76334F7E}"/>
               </a:ext>
             </a:extLst>
           </p:cNvPr>
@@ -1542,7 +1542,7 @@
           <p:cNvPr id="2" name="badge-gemma-4-good">
             <a:extLst xmlns:a="http://schemas.openxmlformats.org/drawingml/2006/main">
               <a:ext uri="{FF2B5EF4-FFF2-40B4-BE49-F238E27FC236}">
-                <a16:creationId xmlns:a16="http://schemas.microsoft.com/office/drawing/2014/main" id="{417CD06F-871B-48F4-884C-403FB37AACC7}"/>
+                <a16:creationId xmlns:a16="http://schemas.microsoft.com/office/drawing/2014/main" id="{FEBE17FE-338F-4A5C-931D-90D446D230DF}"/>
               </a:ext>
             </a:extLst>
           </p:cNvPr>
@@ -1571,7 +1571,7 @@
           <p:cNvPr id="3" name="">
             <a:extLst xmlns:a="http://schemas.openxmlformats.org/drawingml/2006/main">
               <a:ext uri="{FF2B5EF4-FFF2-40B4-BE49-F238E27FC236}">
-                <a16:creationId xmlns:a16="http://schemas.microsoft.com/office/drawing/2014/main" id="{56E929E3-4EDB-4521-8389-2E9823B64D61}"/>
+                <a16:creationId xmlns:a16="http://schemas.microsoft.com/office/drawing/2014/main" id="{D13BE279-A994-494D-91B3-2F0DAA3AC700}"/>
               </a:ext>
             </a:extLst>
           </p:cNvPr>
@@ -1616,7 +1616,7 @@
           <p:cNvPr id="4" name="badge-safety-first-crisis-ai">
             <a:extLst xmlns:a="http://schemas.openxmlformats.org/drawingml/2006/main">
               <a:ext uri="{FF2B5EF4-FFF2-40B4-BE49-F238E27FC236}">
-                <a16:creationId xmlns:a16="http://schemas.microsoft.com/office/drawing/2014/main" id="{8F20C630-27FF-4CB8-B248-E47A04781B12}"/>
+                <a16:creationId xmlns:a16="http://schemas.microsoft.com/office/drawing/2014/main" id="{7EE5449C-FCD7-4CC5-97D0-DF402E35957F}"/>
               </a:ext>
             </a:extLst>
           </p:cNvPr>
@@ -1645,7 +1645,7 @@
           <p:cNvPr id="5" name="">
             <a:extLst xmlns:a="http://schemas.openxmlformats.org/drawingml/2006/main">
               <a:ext uri="{FF2B5EF4-FFF2-40B4-BE49-F238E27FC236}">
-                <a16:creationId xmlns:a16="http://schemas.microsoft.com/office/drawing/2014/main" id="{2D4CEE7F-DEEF-4E6D-8391-3422A2C2784B}"/>
+                <a16:creationId xmlns:a16="http://schemas.microsoft.com/office/drawing/2014/main" id="{90A58181-9969-4777-B2A0-635ED4A36C40}"/>
               </a:ext>
             </a:extLst>
           </p:cNvPr>
@@ -1690,7 +1690,7 @@
           <p:cNvPr id="6" name="">
             <a:extLst xmlns:a="http://schemas.openxmlformats.org/drawingml/2006/main">
               <a:ext uri="{FF2B5EF4-FFF2-40B4-BE49-F238E27FC236}">
-                <a16:creationId xmlns:a16="http://schemas.microsoft.com/office/drawing/2014/main" id="{E4C653AE-0A84-4EC1-8862-36E874A25CAE}"/>
+                <a16:creationId xmlns:a16="http://schemas.microsoft.com/office/drawing/2014/main" id="{958B1AE4-F84A-4928-AE68-6B12FA36F500}"/>
               </a:ext>
             </a:extLst>
           </p:cNvPr>
@@ -1752,7 +1752,7 @@
           <p:cNvPr id="7" name="">
             <a:extLst xmlns:a="http://schemas.openxmlformats.org/drawingml/2006/main">
               <a:ext uri="{FF2B5EF4-FFF2-40B4-BE49-F238E27FC236}">
-                <a16:creationId xmlns:a16="http://schemas.microsoft.com/office/drawing/2014/main" id="{0A3D1095-6438-47C8-831D-AC86E60A3F9B}"/>
+                <a16:creationId xmlns:a16="http://schemas.microsoft.com/office/drawing/2014/main" id="{111EFD19-0546-42B2-BB16-CD9A63BD75DA}"/>
               </a:ext>
             </a:extLst>
           </p:cNvPr>
@@ -1787,7 +1787,7 @@
                   <a:srgbClr val="DDE5EE"/>
                 </a:solidFill>
               </a:rPr>
-              <a:t>A field-ready assistant that turns messy disaster notes into official checks and safer responder handoffs.</a:t>
+              <a:t>A field-ready assistant that turns messy disaster notes into playbook-backed checks and safer handoffs.</a:t>
             </a:r>
           </a:p>
         </p:txBody>
@@ -1797,7 +1797,7 @@
           <p:cNvPr id="8" name="">
             <a:extLst xmlns:a="http://schemas.openxmlformats.org/drawingml/2006/main">
               <a:ext uri="{FF2B5EF4-FFF2-40B4-BE49-F238E27FC236}">
-                <a16:creationId xmlns:a16="http://schemas.microsoft.com/office/drawing/2014/main" id="{8F16D7A4-317B-4CAE-B3CE-CF3947461FC2}"/>
+                <a16:creationId xmlns:a16="http://schemas.microsoft.com/office/drawing/2014/main" id="{A92F98AC-3E2D-4A06-A35D-3645ECDDDB7A}"/>
               </a:ext>
             </a:extLst>
           </p:cNvPr>
@@ -1826,42 +1826,42 @@
           <p:cNvPr id="9" name="">
             <a:extLst xmlns:a="http://schemas.openxmlformats.org/drawingml/2006/main">
               <a:ext uri="{FF2B5EF4-FFF2-40B4-BE49-F238E27FC236}">
-                <a16:creationId xmlns:a16="http://schemas.microsoft.com/office/drawing/2014/main" id="{477D962A-41E6-4A66-AB66-0118C4F5C133}"/>
-              </a:ext>
-            </a:extLst>
-          </p:cNvPr>
-          <p:cNvSpPr>
-            <a:spLocks xmlns:a="http://schemas.openxmlformats.org/drawingml/2006/main" noGrp="1"/>
-          </p:cNvSpPr>
-          <p:nvPr/>
-        </p:nvSpPr>
-        <p:spPr>
-          <a:xfrm xmlns:a="http://schemas.openxmlformats.org/drawingml/2006/main">
-            <a:off x="10039350" y="895350"/>
-            <a:ext cx="7162800" cy="266700"/>
-          </a:xfrm>
-          <a:prstGeom xmlns:a="http://schemas.openxmlformats.org/drawingml/2006/main" prst="rect">
-            <a:avLst/>
-          </a:prstGeom>
-        </p:spPr>
-        <p:txBody>
-          <a:bodyPr xmlns:a="http://schemas.openxmlformats.org/drawingml/2006/main" lIns="0" tIns="0" rIns="0" bIns="0"/>
-          <a:lstStyle xmlns:a="http://schemas.openxmlformats.org/drawingml/2006/main"/>
-          <a:p xmlns:a="http://schemas.openxmlformats.org/drawingml/2006/main">
-            <a:pPr>
-              <a:defRPr sz="1650" b="1">
+                <a16:creationId xmlns:a16="http://schemas.microsoft.com/office/drawing/2014/main" id="{185EF919-2FA6-4959-8F02-F2183CB07243}"/>
+              </a:ext>
+            </a:extLst>
+          </p:cNvPr>
+          <p:cNvSpPr>
+            <a:spLocks xmlns:a="http://schemas.openxmlformats.org/drawingml/2006/main" noGrp="1"/>
+          </p:cNvSpPr>
+          <p:nvPr/>
+        </p:nvSpPr>
+        <p:spPr>
+          <a:xfrm xmlns:a="http://schemas.openxmlformats.org/drawingml/2006/main">
+            <a:off x="10039350" y="914400"/>
+            <a:ext cx="7162800" cy="228600"/>
+          </a:xfrm>
+          <a:prstGeom xmlns:a="http://schemas.openxmlformats.org/drawingml/2006/main" prst="rect">
+            <a:avLst/>
+          </a:prstGeom>
+        </p:spPr>
+        <p:txBody>
+          <a:bodyPr xmlns:a="http://schemas.openxmlformats.org/drawingml/2006/main" lIns="0" tIns="0" rIns="0" bIns="0"/>
+          <a:lstStyle xmlns:a="http://schemas.openxmlformats.org/drawingml/2006/main"/>
+          <a:p xmlns:a="http://schemas.openxmlformats.org/drawingml/2006/main">
+            <a:pPr>
+              <a:defRPr sz="1575" b="1">
                 <a:solidFill>
                   <a:srgbClr val="10151F"/>
                 </a:solidFill>
               </a:defRPr>
             </a:pPr>
             <a:r>
-              <a:rPr sz="1650" b="1">
+              <a:rPr sz="1575" b="1">
                 <a:solidFill>
                   <a:srgbClr val="10151F"/>
                 </a:solidFill>
               </a:rPr>
-              <a:t>rough note -&gt; risk sidecar -&gt; official checks -&gt; Gemma 4 -&gt; handoff</a:t>
+              <a:t>rough note -&gt; risk sidecar -&gt; playbook basis -&gt; Gemma 4 -&gt; responder packet</a:t>
             </a:r>
           </a:p>
         </p:txBody>
@@ -1871,7 +1871,7 @@
           <p:cNvPr id="10" name="">
             <a:extLst xmlns:a="http://schemas.openxmlformats.org/drawingml/2006/main">
               <a:ext uri="{FF2B5EF4-FFF2-40B4-BE49-F238E27FC236}">
-                <a16:creationId xmlns:a16="http://schemas.microsoft.com/office/drawing/2014/main" id="{40801D48-15AD-4B4C-8718-A169C92215E4}"/>
+                <a16:creationId xmlns:a16="http://schemas.microsoft.com/office/drawing/2014/main" id="{F152C926-BC9D-4323-8A39-6D2E76B6EACF}"/>
               </a:ext>
             </a:extLst>
           </p:cNvPr>
@@ -1910,7 +1910,7 @@
           <p:nvPr/>
         </p:nvPicPr>
         <p:blipFill>
-          <a:blip xmlns:r="http://schemas.openxmlformats.org/officeDocument/2006/relationships" xmlns:a="http://schemas.openxmlformats.org/drawingml/2006/main" r:embed="Rdf53345680eb4dd6"/>
+          <a:blip xmlns:r="http://schemas.openxmlformats.org/officeDocument/2006/relationships" xmlns:a="http://schemas.openxmlformats.org/drawingml/2006/main" r:embed="R8584316925554a2c"/>
           <a:stretch xmlns:a="http://schemas.openxmlformats.org/drawingml/2006/main"/>
         </p:blipFill>
         <p:spPr>
@@ -1926,7 +1926,7 @@
     </p:spTree>
     <p:extLst>
       <p:ext uri="{BB962C8B-B14F-4D97-AF65-F5344CB8AC3E}">
-        <p14:creationId xmlns:p14="http://schemas.microsoft.com/office/powerpoint/2010/main" val="1503214366"/>
+        <p14:creationId xmlns:p14="http://schemas.microsoft.com/office/powerpoint/2010/main" val="1373339649"/>
       </p:ext>
     </p:extLst>
   </p:cSld>
@@ -1950,7 +1950,7 @@
           <p:cNvPr id="1" name="background">
             <a:extLst xmlns:a="http://schemas.openxmlformats.org/drawingml/2006/main">
               <a:ext uri="{FF2B5EF4-FFF2-40B4-BE49-F238E27FC236}">
-                <a16:creationId xmlns:a16="http://schemas.microsoft.com/office/drawing/2014/main" id="{038E78A9-E8AC-4CE5-A8DF-6CEC380576F8}"/>
+                <a16:creationId xmlns:a16="http://schemas.microsoft.com/office/drawing/2014/main" id="{F31E9FAE-C7C6-4858-A1DE-5B76A5CE53C1}"/>
               </a:ext>
             </a:extLst>
           </p:cNvPr>
@@ -1977,7 +1977,7 @@
           <p:cNvPr id="2" name="">
             <a:extLst xmlns:a="http://schemas.openxmlformats.org/drawingml/2006/main">
               <a:ext uri="{FF2B5EF4-FFF2-40B4-BE49-F238E27FC236}">
-                <a16:creationId xmlns:a16="http://schemas.microsoft.com/office/drawing/2014/main" id="{A34CBA58-580C-4A8B-BD78-AE90F64CB243}"/>
+                <a16:creationId xmlns:a16="http://schemas.microsoft.com/office/drawing/2014/main" id="{15A66525-8527-4BB5-97E3-75E053A7D6AD}"/>
               </a:ext>
             </a:extLst>
           </p:cNvPr>
@@ -2004,7 +2004,7 @@
           <p:cNvPr id="3" name="">
             <a:extLst xmlns:a="http://schemas.openxmlformats.org/drawingml/2006/main">
               <a:ext uri="{FF2B5EF4-FFF2-40B4-BE49-F238E27FC236}">
-                <a16:creationId xmlns:a16="http://schemas.microsoft.com/office/drawing/2014/main" id="{875AC760-0DB4-4B8E-AB86-F1F4419DB441}"/>
+                <a16:creationId xmlns:a16="http://schemas.microsoft.com/office/drawing/2014/main" id="{BF285EBD-E3FA-4CEE-81F1-45BD2DF1F55B}"/>
               </a:ext>
             </a:extLst>
           </p:cNvPr>
@@ -2049,7 +2049,7 @@
           <p:cNvPr id="4" name="">
             <a:extLst xmlns:a="http://schemas.openxmlformats.org/drawingml/2006/main">
               <a:ext uri="{FF2B5EF4-FFF2-40B4-BE49-F238E27FC236}">
-                <a16:creationId xmlns:a16="http://schemas.microsoft.com/office/drawing/2014/main" id="{8B7F4571-3D2E-45B5-8E33-9D1819E3D3FA}"/>
+                <a16:creationId xmlns:a16="http://schemas.microsoft.com/office/drawing/2014/main" id="{C28C2768-2C27-4C03-8458-0EECCC1B4C04}"/>
               </a:ext>
             </a:extLst>
           </p:cNvPr>
@@ -2094,7 +2094,7 @@
           <p:cNvPr id="5" name="">
             <a:extLst xmlns:a="http://schemas.openxmlformats.org/drawingml/2006/main">
               <a:ext uri="{FF2B5EF4-FFF2-40B4-BE49-F238E27FC236}">
-                <a16:creationId xmlns:a16="http://schemas.microsoft.com/office/drawing/2014/main" id="{C4AD25A9-CB11-4076-B423-3654407C59EA}"/>
+                <a16:creationId xmlns:a16="http://schemas.microsoft.com/office/drawing/2014/main" id="{8C7FE2E1-138E-4E26-8D75-89EDC6EDC021}"/>
               </a:ext>
             </a:extLst>
           </p:cNvPr>
@@ -2139,7 +2139,7 @@
           <p:cNvPr id="6" name="footer">
             <a:extLst xmlns:a="http://schemas.openxmlformats.org/drawingml/2006/main">
               <a:ext uri="{FF2B5EF4-FFF2-40B4-BE49-F238E27FC236}">
-                <a16:creationId xmlns:a16="http://schemas.microsoft.com/office/drawing/2014/main" id="{80390FF7-8041-4F21-86C6-9BD6EC99D0D3}"/>
+                <a16:creationId xmlns:a16="http://schemas.microsoft.com/office/drawing/2014/main" id="{196B8456-9307-4FB1-899E-F3E15DA8155C}"/>
               </a:ext>
             </a:extLst>
           </p:cNvPr>
@@ -2184,7 +2184,7 @@
           <p:cNvPr id="7" name="">
             <a:extLst xmlns:a="http://schemas.openxmlformats.org/drawingml/2006/main">
               <a:ext uri="{FF2B5EF4-FFF2-40B4-BE49-F238E27FC236}">
-                <a16:creationId xmlns:a16="http://schemas.microsoft.com/office/drawing/2014/main" id="{C0C5ECC9-A418-4316-BEC4-8B16AE2228CE}"/>
+                <a16:creationId xmlns:a16="http://schemas.microsoft.com/office/drawing/2014/main" id="{9FBEA362-0D7A-4EFE-A804-6BDB5CBBDE0B}"/>
               </a:ext>
             </a:extLst>
           </p:cNvPr>
@@ -2219,7 +2219,7 @@
           <p:cNvPr id="8" name="">
             <a:extLst xmlns:a="http://schemas.openxmlformats.org/drawingml/2006/main">
               <a:ext uri="{FF2B5EF4-FFF2-40B4-BE49-F238E27FC236}">
-                <a16:creationId xmlns:a16="http://schemas.microsoft.com/office/drawing/2014/main" id="{B42A1FEA-B1AC-4907-AC49-10DD0C30FBD1}"/>
+                <a16:creationId xmlns:a16="http://schemas.microsoft.com/office/drawing/2014/main" id="{2144F057-D614-46D0-B439-57609CF6A329}"/>
               </a:ext>
             </a:extLst>
           </p:cNvPr>
@@ -2246,7 +2246,7 @@
           <p:cNvPr id="9" name="">
             <a:extLst xmlns:a="http://schemas.openxmlformats.org/drawingml/2006/main">
               <a:ext uri="{FF2B5EF4-FFF2-40B4-BE49-F238E27FC236}">
-                <a16:creationId xmlns:a16="http://schemas.microsoft.com/office/drawing/2014/main" id="{EBA6B967-C33E-4512-B492-EF02521A24F6}"/>
+                <a16:creationId xmlns:a16="http://schemas.microsoft.com/office/drawing/2014/main" id="{0BAA08A1-074F-4C2D-8272-0C7D114EA2C2}"/>
               </a:ext>
             </a:extLst>
           </p:cNvPr>
@@ -2291,7 +2291,7 @@
           <p:cNvPr id="10" name="">
             <a:extLst xmlns:a="http://schemas.openxmlformats.org/drawingml/2006/main">
               <a:ext uri="{FF2B5EF4-FFF2-40B4-BE49-F238E27FC236}">
-                <a16:creationId xmlns:a16="http://schemas.microsoft.com/office/drawing/2014/main" id="{C04EE216-DA27-48F7-825D-EAEB29B25D03}"/>
+                <a16:creationId xmlns:a16="http://schemas.microsoft.com/office/drawing/2014/main" id="{F80E1F0D-1451-47C2-BCDE-8D1AB28C806B}"/>
               </a:ext>
             </a:extLst>
           </p:cNvPr>
@@ -2336,7 +2336,7 @@
           <p:cNvPr id="11" name="">
             <a:extLst xmlns:a="http://schemas.openxmlformats.org/drawingml/2006/main">
               <a:ext uri="{FF2B5EF4-FFF2-40B4-BE49-F238E27FC236}">
-                <a16:creationId xmlns:a16="http://schemas.microsoft.com/office/drawing/2014/main" id="{893B474A-B6C4-4D8A-BA3A-CD576FBF403F}"/>
+                <a16:creationId xmlns:a16="http://schemas.microsoft.com/office/drawing/2014/main" id="{6F6ACFBB-A971-4C1E-B93F-9C909EBA468A}"/>
               </a:ext>
             </a:extLst>
           </p:cNvPr>
@@ -2363,7 +2363,7 @@
           <p:cNvPr id="12" name="">
             <a:extLst xmlns:a="http://schemas.openxmlformats.org/drawingml/2006/main">
               <a:ext uri="{FF2B5EF4-FFF2-40B4-BE49-F238E27FC236}">
-                <a16:creationId xmlns:a16="http://schemas.microsoft.com/office/drawing/2014/main" id="{8E507736-411E-4B59-93DB-F2301AE39669}"/>
+                <a16:creationId xmlns:a16="http://schemas.microsoft.com/office/drawing/2014/main" id="{05064E67-B790-4548-92BB-74E03C12BD41}"/>
               </a:ext>
             </a:extLst>
           </p:cNvPr>
@@ -2408,7 +2408,7 @@
           <p:cNvPr id="13" name="">
             <a:extLst xmlns:a="http://schemas.openxmlformats.org/drawingml/2006/main">
               <a:ext uri="{FF2B5EF4-FFF2-40B4-BE49-F238E27FC236}">
-                <a16:creationId xmlns:a16="http://schemas.microsoft.com/office/drawing/2014/main" id="{1F42C0AF-F76E-44B4-AAE7-A4CAFF60B4DE}"/>
+                <a16:creationId xmlns:a16="http://schemas.microsoft.com/office/drawing/2014/main" id="{87F003DD-708D-4438-9BF4-4A8DBFFEE9E1}"/>
               </a:ext>
             </a:extLst>
           </p:cNvPr>
@@ -2453,7 +2453,7 @@
           <p:cNvPr id="14" name="">
             <a:extLst xmlns:a="http://schemas.openxmlformats.org/drawingml/2006/main">
               <a:ext uri="{FF2B5EF4-FFF2-40B4-BE49-F238E27FC236}">
-                <a16:creationId xmlns:a16="http://schemas.microsoft.com/office/drawing/2014/main" id="{9599B378-3AC4-4445-9895-63166D1EC029}"/>
+                <a16:creationId xmlns:a16="http://schemas.microsoft.com/office/drawing/2014/main" id="{E17EDA1D-E2DE-47FC-812F-BCCFEE106ABA}"/>
               </a:ext>
             </a:extLst>
           </p:cNvPr>
@@ -2480,7 +2480,7 @@
           <p:cNvPr id="15" name="">
             <a:extLst xmlns:a="http://schemas.openxmlformats.org/drawingml/2006/main">
               <a:ext uri="{FF2B5EF4-FFF2-40B4-BE49-F238E27FC236}">
-                <a16:creationId xmlns:a16="http://schemas.microsoft.com/office/drawing/2014/main" id="{3544F09C-0477-4000-BC32-11D04DF5CEAB}"/>
+                <a16:creationId xmlns:a16="http://schemas.microsoft.com/office/drawing/2014/main" id="{D7B1410D-39DC-4F91-96CC-D96E6296C915}"/>
               </a:ext>
             </a:extLst>
           </p:cNvPr>
@@ -2525,7 +2525,7 @@
           <p:cNvPr id="16" name="">
             <a:extLst xmlns:a="http://schemas.openxmlformats.org/drawingml/2006/main">
               <a:ext uri="{FF2B5EF4-FFF2-40B4-BE49-F238E27FC236}">
-                <a16:creationId xmlns:a16="http://schemas.microsoft.com/office/drawing/2014/main" id="{AB4BF60A-EAEC-4903-A665-F5BE10A2AA24}"/>
+                <a16:creationId xmlns:a16="http://schemas.microsoft.com/office/drawing/2014/main" id="{23DE6221-DF69-4FAF-802E-2DBFA99DF7E9}"/>
               </a:ext>
             </a:extLst>
           </p:cNvPr>
@@ -2570,7 +2570,7 @@
           <p:cNvPr id="17" name="">
             <a:extLst xmlns:a="http://schemas.openxmlformats.org/drawingml/2006/main">
               <a:ext uri="{FF2B5EF4-FFF2-40B4-BE49-F238E27FC236}">
-                <a16:creationId xmlns:a16="http://schemas.microsoft.com/office/drawing/2014/main" id="{E44BE4DC-B8E5-4BFF-B7E8-3B3D84ED9834}"/>
+                <a16:creationId xmlns:a16="http://schemas.microsoft.com/office/drawing/2014/main" id="{6934E974-8170-45A7-8D54-1EB73D627FF4}"/>
               </a:ext>
             </a:extLst>
           </p:cNvPr>
@@ -2605,7 +2605,7 @@
                   <a:srgbClr val="FF5A66"/>
                 </a:solidFill>
               </a:rPr>
-              <a:t>8</a:t>
+              <a:t>12</a:t>
             </a:r>
           </a:p>
         </p:txBody>
@@ -2615,7 +2615,7 @@
           <p:cNvPr id="18" name="">
             <a:extLst xmlns:a="http://schemas.openxmlformats.org/drawingml/2006/main">
               <a:ext uri="{FF2B5EF4-FFF2-40B4-BE49-F238E27FC236}">
-                <a16:creationId xmlns:a16="http://schemas.microsoft.com/office/drawing/2014/main" id="{4D4C72D4-E929-43E9-AB8D-C5DF772ECB61}"/>
+                <a16:creationId xmlns:a16="http://schemas.microsoft.com/office/drawing/2014/main" id="{C0A163EE-644F-478D-B862-3DCDCA3C646D}"/>
               </a:ext>
             </a:extLst>
           </p:cNvPr>
@@ -2660,7 +2660,7 @@
           <p:cNvPr id="19" name="">
             <a:extLst xmlns:a="http://schemas.openxmlformats.org/drawingml/2006/main">
               <a:ext uri="{FF2B5EF4-FFF2-40B4-BE49-F238E27FC236}">
-                <a16:creationId xmlns:a16="http://schemas.microsoft.com/office/drawing/2014/main" id="{20615F11-5501-40BA-8FCF-8AA6B8BF90BA}"/>
+                <a16:creationId xmlns:a16="http://schemas.microsoft.com/office/drawing/2014/main" id="{E41EE4C1-7B1F-4B1E-A876-D19047D2BA40}"/>
               </a:ext>
             </a:extLst>
           </p:cNvPr>
@@ -2695,7 +2695,7 @@
                   <a:srgbClr val="4EA5FF"/>
                 </a:solidFill>
               </a:rPr>
-              <a:t>10</a:t>
+              <a:t>14</a:t>
             </a:r>
           </a:p>
         </p:txBody>
@@ -2705,7 +2705,7 @@
           <p:cNvPr id="20" name="">
             <a:extLst xmlns:a="http://schemas.openxmlformats.org/drawingml/2006/main">
               <a:ext uri="{FF2B5EF4-FFF2-40B4-BE49-F238E27FC236}">
-                <a16:creationId xmlns:a16="http://schemas.microsoft.com/office/drawing/2014/main" id="{CAC4767B-9E2E-43C9-BB27-340C624BB86D}"/>
+                <a16:creationId xmlns:a16="http://schemas.microsoft.com/office/drawing/2014/main" id="{686C9448-6136-4074-99F5-D3B9FA37631C}"/>
               </a:ext>
             </a:extLst>
           </p:cNvPr>
@@ -2750,7 +2750,7 @@
           <p:cNvPr id="21" name="">
             <a:extLst xmlns:a="http://schemas.openxmlformats.org/drawingml/2006/main">
               <a:ext uri="{FF2B5EF4-FFF2-40B4-BE49-F238E27FC236}">
-                <a16:creationId xmlns:a16="http://schemas.microsoft.com/office/drawing/2014/main" id="{28A7C28C-2DA4-4230-9282-95A1A4C87F35}"/>
+                <a16:creationId xmlns:a16="http://schemas.microsoft.com/office/drawing/2014/main" id="{0A5473C2-24D5-4343-81A7-E5571F464A20}"/>
               </a:ext>
             </a:extLst>
           </p:cNvPr>
@@ -2795,7 +2795,7 @@
           <p:cNvPr id="22" name="">
             <a:extLst xmlns:a="http://schemas.openxmlformats.org/drawingml/2006/main">
               <a:ext uri="{FF2B5EF4-FFF2-40B4-BE49-F238E27FC236}">
-                <a16:creationId xmlns:a16="http://schemas.microsoft.com/office/drawing/2014/main" id="{AFFF5AA0-12C0-4B84-ABA7-01CEBE08D4D4}"/>
+                <a16:creationId xmlns:a16="http://schemas.microsoft.com/office/drawing/2014/main" id="{DFD93481-14CE-491F-95CE-D8D0CBFC9FD4}"/>
               </a:ext>
             </a:extLst>
           </p:cNvPr>
@@ -2838,7 +2838,7 @@
     </p:spTree>
     <p:extLst>
       <p:ext uri="{BB962C8B-B14F-4D97-AF65-F5344CB8AC3E}">
-        <p14:creationId xmlns:p14="http://schemas.microsoft.com/office/powerpoint/2010/main" val="231050306"/>
+        <p14:creationId xmlns:p14="http://schemas.microsoft.com/office/powerpoint/2010/main" val="1083575234"/>
       </p:ext>
     </p:extLst>
   </p:cSld>
@@ -2862,7 +2862,7 @@
           <p:cNvPr id="1" name="background">
             <a:extLst xmlns:a="http://schemas.openxmlformats.org/drawingml/2006/main">
               <a:ext uri="{FF2B5EF4-FFF2-40B4-BE49-F238E27FC236}">
-                <a16:creationId xmlns:a16="http://schemas.microsoft.com/office/drawing/2014/main" id="{2C76C84A-2DD7-4CF7-838A-B85438FAEDAF}"/>
+                <a16:creationId xmlns:a16="http://schemas.microsoft.com/office/drawing/2014/main" id="{D969388A-7D8B-48F6-AFB1-2208D2F70C39}"/>
               </a:ext>
             </a:extLst>
           </p:cNvPr>
@@ -2889,7 +2889,7 @@
           <p:cNvPr id="2" name="">
             <a:extLst xmlns:a="http://schemas.openxmlformats.org/drawingml/2006/main">
               <a:ext uri="{FF2B5EF4-FFF2-40B4-BE49-F238E27FC236}">
-                <a16:creationId xmlns:a16="http://schemas.microsoft.com/office/drawing/2014/main" id="{8915FF88-C1E8-42E2-BF83-8C6E8E760FA7}"/>
+                <a16:creationId xmlns:a16="http://schemas.microsoft.com/office/drawing/2014/main" id="{F21C00EF-821F-477E-BC5E-E2A6F77076B7}"/>
               </a:ext>
             </a:extLst>
           </p:cNvPr>
@@ -2916,7 +2916,7 @@
           <p:cNvPr id="3" name="">
             <a:extLst xmlns:a="http://schemas.openxmlformats.org/drawingml/2006/main">
               <a:ext uri="{FF2B5EF4-FFF2-40B4-BE49-F238E27FC236}">
-                <a16:creationId xmlns:a16="http://schemas.microsoft.com/office/drawing/2014/main" id="{C15D51AA-5DF9-4A99-A1B3-AAFA6EA01A59}"/>
+                <a16:creationId xmlns:a16="http://schemas.microsoft.com/office/drawing/2014/main" id="{8A0864C8-7EED-4603-868D-9BF97BF782E0}"/>
               </a:ext>
             </a:extLst>
           </p:cNvPr>
@@ -2961,7 +2961,7 @@
           <p:cNvPr id="4" name="">
             <a:extLst xmlns:a="http://schemas.openxmlformats.org/drawingml/2006/main">
               <a:ext uri="{FF2B5EF4-FFF2-40B4-BE49-F238E27FC236}">
-                <a16:creationId xmlns:a16="http://schemas.microsoft.com/office/drawing/2014/main" id="{4F456776-7A1D-47D1-AECC-588BACC5E6B8}"/>
+                <a16:creationId xmlns:a16="http://schemas.microsoft.com/office/drawing/2014/main" id="{01020AA4-DD89-4C21-8E57-C5F4CFB27713}"/>
               </a:ext>
             </a:extLst>
           </p:cNvPr>
@@ -3006,7 +3006,7 @@
           <p:cNvPr id="5" name="">
             <a:extLst xmlns:a="http://schemas.openxmlformats.org/drawingml/2006/main">
               <a:ext uri="{FF2B5EF4-FFF2-40B4-BE49-F238E27FC236}">
-                <a16:creationId xmlns:a16="http://schemas.microsoft.com/office/drawing/2014/main" id="{5B4CAEE6-5DC9-431F-82AF-3E7D428C29D3}"/>
+                <a16:creationId xmlns:a16="http://schemas.microsoft.com/office/drawing/2014/main" id="{60948A5A-B22E-4763-B3FF-2CC2D68AD9CF}"/>
               </a:ext>
             </a:extLst>
           </p:cNvPr>
@@ -3035,7 +3035,7 @@
           <p:cNvPr id="6" name="badge-1">
             <a:extLst xmlns:a="http://schemas.openxmlformats.org/drawingml/2006/main">
               <a:ext uri="{FF2B5EF4-FFF2-40B4-BE49-F238E27FC236}">
-                <a16:creationId xmlns:a16="http://schemas.microsoft.com/office/drawing/2014/main" id="{CB3C7322-A929-4D82-8CA4-F1DBB4E0461B}"/>
+                <a16:creationId xmlns:a16="http://schemas.microsoft.com/office/drawing/2014/main" id="{6F13E4E0-3733-4702-8551-4F791A458642}"/>
               </a:ext>
             </a:extLst>
           </p:cNvPr>
@@ -3064,7 +3064,7 @@
           <p:cNvPr id="7" name="">
             <a:extLst xmlns:a="http://schemas.openxmlformats.org/drawingml/2006/main">
               <a:ext uri="{FF2B5EF4-FFF2-40B4-BE49-F238E27FC236}">
-                <a16:creationId xmlns:a16="http://schemas.microsoft.com/office/drawing/2014/main" id="{27663E33-B132-41A5-8508-E02988C305D6}"/>
+                <a16:creationId xmlns:a16="http://schemas.microsoft.com/office/drawing/2014/main" id="{8C5C3961-35E8-429C-AD16-5649ED77BE69}"/>
               </a:ext>
             </a:extLst>
           </p:cNvPr>
@@ -3109,7 +3109,7 @@
           <p:cNvPr id="8" name="">
             <a:extLst xmlns:a="http://schemas.openxmlformats.org/drawingml/2006/main">
               <a:ext uri="{FF2B5EF4-FFF2-40B4-BE49-F238E27FC236}">
-                <a16:creationId xmlns:a16="http://schemas.microsoft.com/office/drawing/2014/main" id="{D93C7ECF-F464-46D3-837A-627C61B2EFE4}"/>
+                <a16:creationId xmlns:a16="http://schemas.microsoft.com/office/drawing/2014/main" id="{D75C9FB8-F229-4CEA-B21F-EAA4352DC0E2}"/>
               </a:ext>
             </a:extLst>
           </p:cNvPr>
@@ -3154,7 +3154,7 @@
           <p:cNvPr id="9" name="">
             <a:extLst xmlns:a="http://schemas.openxmlformats.org/drawingml/2006/main">
               <a:ext uri="{FF2B5EF4-FFF2-40B4-BE49-F238E27FC236}">
-                <a16:creationId xmlns:a16="http://schemas.microsoft.com/office/drawing/2014/main" id="{BE5F5A4B-2286-4E1B-877C-3F8C3D33CD0C}"/>
+                <a16:creationId xmlns:a16="http://schemas.microsoft.com/office/drawing/2014/main" id="{16883037-B106-4862-8F3E-BDA666719AA8}"/>
               </a:ext>
             </a:extLst>
           </p:cNvPr>
@@ -3199,7 +3199,7 @@
           <p:cNvPr id="10" name="">
             <a:extLst xmlns:a="http://schemas.openxmlformats.org/drawingml/2006/main">
               <a:ext uri="{FF2B5EF4-FFF2-40B4-BE49-F238E27FC236}">
-                <a16:creationId xmlns:a16="http://schemas.microsoft.com/office/drawing/2014/main" id="{FA083E9E-535D-4AFC-9C25-3AC63096A100}"/>
+                <a16:creationId xmlns:a16="http://schemas.microsoft.com/office/drawing/2014/main" id="{4BDDF516-BE32-4A65-8160-340C9AB7E1E7}"/>
               </a:ext>
             </a:extLst>
           </p:cNvPr>
@@ -3244,7 +3244,7 @@
           <p:cNvPr id="11" name="">
             <a:extLst xmlns:a="http://schemas.openxmlformats.org/drawingml/2006/main">
               <a:ext uri="{FF2B5EF4-FFF2-40B4-BE49-F238E27FC236}">
-                <a16:creationId xmlns:a16="http://schemas.microsoft.com/office/drawing/2014/main" id="{15EFBAA2-E2E6-4913-BCB6-45E7B9BBC11D}"/>
+                <a16:creationId xmlns:a16="http://schemas.microsoft.com/office/drawing/2014/main" id="{6231B53A-2077-4C63-AEA6-AB6A99AF68DA}"/>
               </a:ext>
             </a:extLst>
           </p:cNvPr>
@@ -3273,7 +3273,7 @@
           <p:cNvPr id="12" name="badge-2">
             <a:extLst xmlns:a="http://schemas.openxmlformats.org/drawingml/2006/main">
               <a:ext uri="{FF2B5EF4-FFF2-40B4-BE49-F238E27FC236}">
-                <a16:creationId xmlns:a16="http://schemas.microsoft.com/office/drawing/2014/main" id="{1044BE57-7110-4FAD-955A-FC3F5D0FC9A7}"/>
+                <a16:creationId xmlns:a16="http://schemas.microsoft.com/office/drawing/2014/main" id="{93A052B0-38DA-4955-9DF8-973E0E161B4C}"/>
               </a:ext>
             </a:extLst>
           </p:cNvPr>
@@ -3302,7 +3302,7 @@
           <p:cNvPr id="13" name="">
             <a:extLst xmlns:a="http://schemas.openxmlformats.org/drawingml/2006/main">
               <a:ext uri="{FF2B5EF4-FFF2-40B4-BE49-F238E27FC236}">
-                <a16:creationId xmlns:a16="http://schemas.microsoft.com/office/drawing/2014/main" id="{5DE8A83F-2170-41C7-A4E5-957F3C4BDE54}"/>
+                <a16:creationId xmlns:a16="http://schemas.microsoft.com/office/drawing/2014/main" id="{1C6F079D-F400-4BB8-8884-6E15BAE3C0D0}"/>
               </a:ext>
             </a:extLst>
           </p:cNvPr>
@@ -3347,7 +3347,7 @@
           <p:cNvPr id="14" name="">
             <a:extLst xmlns:a="http://schemas.openxmlformats.org/drawingml/2006/main">
               <a:ext uri="{FF2B5EF4-FFF2-40B4-BE49-F238E27FC236}">
-                <a16:creationId xmlns:a16="http://schemas.microsoft.com/office/drawing/2014/main" id="{779F1585-3391-4302-AC1A-1DD9C4435BCF}"/>
+                <a16:creationId xmlns:a16="http://schemas.microsoft.com/office/drawing/2014/main" id="{DEB02C7D-A647-46E5-9AD4-3BA453BAC379}"/>
               </a:ext>
             </a:extLst>
           </p:cNvPr>
@@ -3392,7 +3392,7 @@
           <p:cNvPr id="15" name="">
             <a:extLst xmlns:a="http://schemas.openxmlformats.org/drawingml/2006/main">
               <a:ext uri="{FF2B5EF4-FFF2-40B4-BE49-F238E27FC236}">
-                <a16:creationId xmlns:a16="http://schemas.microsoft.com/office/drawing/2014/main" id="{EAF4D847-1BE7-4BB7-B9F1-85550EC03A17}"/>
+                <a16:creationId xmlns:a16="http://schemas.microsoft.com/office/drawing/2014/main" id="{3A15351C-31D9-432D-8804-E957D5B6E3EC}"/>
               </a:ext>
             </a:extLst>
           </p:cNvPr>
@@ -3427,7 +3427,7 @@
                   <a:srgbClr val="C6F7EE"/>
                 </a:solidFill>
               </a:rPr>
-              <a:t>Flags insulin, oxygen, pregnancy, floodwater, rumors, language access, and official resource checks.</a:t>
+              <a:t>Flags insulin, oxygen, pregnancy, floodwater, rumors, language access, official checks, and playbook rules.</a:t>
             </a:r>
           </a:p>
         </p:txBody>
@@ -3437,7 +3437,7 @@
           <p:cNvPr id="16" name="">
             <a:extLst xmlns:a="http://schemas.openxmlformats.org/drawingml/2006/main">
               <a:ext uri="{FF2B5EF4-FFF2-40B4-BE49-F238E27FC236}">
-                <a16:creationId xmlns:a16="http://schemas.microsoft.com/office/drawing/2014/main" id="{8C4F2B76-4B49-4DB4-A5AF-1FED74BEAE96}"/>
+                <a16:creationId xmlns:a16="http://schemas.microsoft.com/office/drawing/2014/main" id="{C21E99EA-99C8-42A5-B99A-9453097DE83F}"/>
               </a:ext>
             </a:extLst>
           </p:cNvPr>
@@ -3482,7 +3482,7 @@
           <p:cNvPr id="17" name="">
             <a:extLst xmlns:a="http://schemas.openxmlformats.org/drawingml/2006/main">
               <a:ext uri="{FF2B5EF4-FFF2-40B4-BE49-F238E27FC236}">
-                <a16:creationId xmlns:a16="http://schemas.microsoft.com/office/drawing/2014/main" id="{E19F3E7B-E8CB-4586-BCAB-657717BC87C3}"/>
+                <a16:creationId xmlns:a16="http://schemas.microsoft.com/office/drawing/2014/main" id="{CE32B5DF-1E95-4282-83B6-93B37F90C3DA}"/>
               </a:ext>
             </a:extLst>
           </p:cNvPr>
@@ -3511,7 +3511,7 @@
           <p:cNvPr id="18" name="badge-3">
             <a:extLst xmlns:a="http://schemas.openxmlformats.org/drawingml/2006/main">
               <a:ext uri="{FF2B5EF4-FFF2-40B4-BE49-F238E27FC236}">
-                <a16:creationId xmlns:a16="http://schemas.microsoft.com/office/drawing/2014/main" id="{D910E94F-5EA7-4406-B531-1A53488A4036}"/>
+                <a16:creationId xmlns:a16="http://schemas.microsoft.com/office/drawing/2014/main" id="{EC5FD266-4170-4CF7-BE7D-E0104162CAC8}"/>
               </a:ext>
             </a:extLst>
           </p:cNvPr>
@@ -3540,7 +3540,7 @@
           <p:cNvPr id="19" name="">
             <a:extLst xmlns:a="http://schemas.openxmlformats.org/drawingml/2006/main">
               <a:ext uri="{FF2B5EF4-FFF2-40B4-BE49-F238E27FC236}">
-                <a16:creationId xmlns:a16="http://schemas.microsoft.com/office/drawing/2014/main" id="{230A88E2-6A3E-43F2-AB89-1A389F286E12}"/>
+                <a16:creationId xmlns:a16="http://schemas.microsoft.com/office/drawing/2014/main" id="{B9236D3C-4706-499D-AFB4-E7C961D78A64}"/>
               </a:ext>
             </a:extLst>
           </p:cNvPr>
@@ -3585,7 +3585,7 @@
           <p:cNvPr id="20" name="">
             <a:extLst xmlns:a="http://schemas.openxmlformats.org/drawingml/2006/main">
               <a:ext uri="{FF2B5EF4-FFF2-40B4-BE49-F238E27FC236}">
-                <a16:creationId xmlns:a16="http://schemas.microsoft.com/office/drawing/2014/main" id="{CEBF373C-8722-431B-B8BB-46EB2EEE6D21}"/>
+                <a16:creationId xmlns:a16="http://schemas.microsoft.com/office/drawing/2014/main" id="{204CA0AB-DBED-4731-B461-B994E0078C06}"/>
               </a:ext>
             </a:extLst>
           </p:cNvPr>
@@ -3630,7 +3630,7 @@
           <p:cNvPr id="21" name="">
             <a:extLst xmlns:a="http://schemas.openxmlformats.org/drawingml/2006/main">
               <a:ext uri="{FF2B5EF4-FFF2-40B4-BE49-F238E27FC236}">
-                <a16:creationId xmlns:a16="http://schemas.microsoft.com/office/drawing/2014/main" id="{B579773A-CA91-408C-AA9B-F879C6AF8A43}"/>
+                <a16:creationId xmlns:a16="http://schemas.microsoft.com/office/drawing/2014/main" id="{86059B4C-FF57-4BE9-A322-117EDFC33052}"/>
               </a:ext>
             </a:extLst>
           </p:cNvPr>
@@ -3665,7 +3665,7 @@
                   <a:srgbClr val="E6DEFF"/>
                 </a:solidFill>
               </a:rPr>
-              <a:t>Structured plan, clarifying questions, and visible safety boundary.</a:t>
+              <a:t>Structured plan, playbook references, clarifying questions, and visible safety boundary.</a:t>
             </a:r>
           </a:p>
         </p:txBody>
@@ -3675,7 +3675,7 @@
           <p:cNvPr id="22" name="">
             <a:extLst xmlns:a="http://schemas.openxmlformats.org/drawingml/2006/main">
               <a:ext uri="{FF2B5EF4-FFF2-40B4-BE49-F238E27FC236}">
-                <a16:creationId xmlns:a16="http://schemas.microsoft.com/office/drawing/2014/main" id="{3CB3CEBE-3524-460A-B180-17BF4BB24B2E}"/>
+                <a16:creationId xmlns:a16="http://schemas.microsoft.com/office/drawing/2014/main" id="{B686F78A-1BA6-4E97-884C-1DC51DEDB42F}"/>
               </a:ext>
             </a:extLst>
           </p:cNvPr>
@@ -3720,7 +3720,7 @@
           <p:cNvPr id="23" name="">
             <a:extLst xmlns:a="http://schemas.openxmlformats.org/drawingml/2006/main">
               <a:ext uri="{FF2B5EF4-FFF2-40B4-BE49-F238E27FC236}">
-                <a16:creationId xmlns:a16="http://schemas.microsoft.com/office/drawing/2014/main" id="{202729A0-03B9-404D-A4DA-213DE33CA0F2}"/>
+                <a16:creationId xmlns:a16="http://schemas.microsoft.com/office/drawing/2014/main" id="{D967DC61-2532-44EC-9594-2A0E44C65850}"/>
               </a:ext>
             </a:extLst>
           </p:cNvPr>
@@ -3749,7 +3749,7 @@
           <p:cNvPr id="24" name="badge-4">
             <a:extLst xmlns:a="http://schemas.openxmlformats.org/drawingml/2006/main">
               <a:ext uri="{FF2B5EF4-FFF2-40B4-BE49-F238E27FC236}">
-                <a16:creationId xmlns:a16="http://schemas.microsoft.com/office/drawing/2014/main" id="{CBCF7407-3E78-42B5-8F23-9D9E41660030}"/>
+                <a16:creationId xmlns:a16="http://schemas.microsoft.com/office/drawing/2014/main" id="{5AC77416-34C4-4D02-BCFF-357DAFE9050F}"/>
               </a:ext>
             </a:extLst>
           </p:cNvPr>
@@ -3778,7 +3778,7 @@
           <p:cNvPr id="25" name="">
             <a:extLst xmlns:a="http://schemas.openxmlformats.org/drawingml/2006/main">
               <a:ext uri="{FF2B5EF4-FFF2-40B4-BE49-F238E27FC236}">
-                <a16:creationId xmlns:a16="http://schemas.microsoft.com/office/drawing/2014/main" id="{F14F745A-D7A6-46BC-8FBE-DD2EAD494450}"/>
+                <a16:creationId xmlns:a16="http://schemas.microsoft.com/office/drawing/2014/main" id="{71B82023-385B-4B6B-90A5-9A1319959A57}"/>
               </a:ext>
             </a:extLst>
           </p:cNvPr>
@@ -3823,7 +3823,7 @@
           <p:cNvPr id="26" name="">
             <a:extLst xmlns:a="http://schemas.openxmlformats.org/drawingml/2006/main">
               <a:ext uri="{FF2B5EF4-FFF2-40B4-BE49-F238E27FC236}">
-                <a16:creationId xmlns:a16="http://schemas.microsoft.com/office/drawing/2014/main" id="{D452B45F-41E2-4975-9F1D-11D112DDD022}"/>
+                <a16:creationId xmlns:a16="http://schemas.microsoft.com/office/drawing/2014/main" id="{E0F26084-D66E-4358-9F1D-D7748616A297}"/>
               </a:ext>
             </a:extLst>
           </p:cNvPr>
@@ -3868,7 +3868,7 @@
           <p:cNvPr id="27" name="">
             <a:extLst xmlns:a="http://schemas.openxmlformats.org/drawingml/2006/main">
               <a:ext uri="{FF2B5EF4-FFF2-40B4-BE49-F238E27FC236}">
-                <a16:creationId xmlns:a16="http://schemas.microsoft.com/office/drawing/2014/main" id="{3BFE7D77-C796-4B0A-B5CA-D689D2B39843}"/>
+                <a16:creationId xmlns:a16="http://schemas.microsoft.com/office/drawing/2014/main" id="{B239B7DA-50FB-4EC7-AA30-197CFF19EF4E}"/>
               </a:ext>
             </a:extLst>
           </p:cNvPr>
@@ -3903,7 +3903,7 @@
                   <a:srgbClr val="D9F9D7"/>
                 </a:solidFill>
               </a:rPr>
-              <a:t>A safer next-action note for human teams, not a replacement for them.</a:t>
+              <a:t>A copy-ready handoff plus an audit trace, not a replacement for human teams.</a:t>
             </a:r>
           </a:p>
         </p:txBody>
@@ -3911,7 +3911,7 @@
     </p:spTree>
     <p:extLst>
       <p:ext uri="{BB962C8B-B14F-4D97-AF65-F5344CB8AC3E}">
-        <p14:creationId xmlns:p14="http://schemas.microsoft.com/office/powerpoint/2010/main" val="753152497"/>
+        <p14:creationId xmlns:p14="http://schemas.microsoft.com/office/powerpoint/2010/main" val="669977708"/>
       </p:ext>
     </p:extLst>
   </p:cSld>
@@ -3935,7 +3935,7 @@
           <p:cNvPr id="1" name="background">
             <a:extLst xmlns:a="http://schemas.openxmlformats.org/drawingml/2006/main">
               <a:ext uri="{FF2B5EF4-FFF2-40B4-BE49-F238E27FC236}">
-                <a16:creationId xmlns:a16="http://schemas.microsoft.com/office/drawing/2014/main" id="{3259C9FA-6FD1-4113-A3D0-ABD17BE3FFA0}"/>
+                <a16:creationId xmlns:a16="http://schemas.microsoft.com/office/drawing/2014/main" id="{093D60C5-2360-4957-A0FF-4CC9D9AB4508}"/>
               </a:ext>
             </a:extLst>
           </p:cNvPr>
@@ -3962,7 +3962,7 @@
           <p:cNvPr id="2" name="">
             <a:extLst xmlns:a="http://schemas.openxmlformats.org/drawingml/2006/main">
               <a:ext uri="{FF2B5EF4-FFF2-40B4-BE49-F238E27FC236}">
-                <a16:creationId xmlns:a16="http://schemas.microsoft.com/office/drawing/2014/main" id="{CCD24DD8-C001-4E0E-AE4B-2E33A110552A}"/>
+                <a16:creationId xmlns:a16="http://schemas.microsoft.com/office/drawing/2014/main" id="{4D726791-04DC-4A33-8897-2D4B4D943DAB}"/>
               </a:ext>
             </a:extLst>
           </p:cNvPr>
@@ -3989,7 +3989,7 @@
           <p:cNvPr id="3" name="">
             <a:extLst xmlns:a="http://schemas.openxmlformats.org/drawingml/2006/main">
               <a:ext uri="{FF2B5EF4-FFF2-40B4-BE49-F238E27FC236}">
-                <a16:creationId xmlns:a16="http://schemas.microsoft.com/office/drawing/2014/main" id="{952EF349-3166-411D-B8BD-83D54A1CDDEE}"/>
+                <a16:creationId xmlns:a16="http://schemas.microsoft.com/office/drawing/2014/main" id="{6873E08C-7CF3-42E5-B26A-4CB884BCEB46}"/>
               </a:ext>
             </a:extLst>
           </p:cNvPr>
@@ -4034,7 +4034,7 @@
           <p:cNvPr id="4" name="">
             <a:extLst xmlns:a="http://schemas.openxmlformats.org/drawingml/2006/main">
               <a:ext uri="{FF2B5EF4-FFF2-40B4-BE49-F238E27FC236}">
-                <a16:creationId xmlns:a16="http://schemas.microsoft.com/office/drawing/2014/main" id="{5B76CFFC-447D-4900-A741-DCA4A0DF389C}"/>
+                <a16:creationId xmlns:a16="http://schemas.microsoft.com/office/drawing/2014/main" id="{65ED7657-452B-4180-8BB5-6D5397FC9B4D}"/>
               </a:ext>
             </a:extLst>
           </p:cNvPr>
@@ -4079,7 +4079,7 @@
           <p:cNvPr id="5" name="">
             <a:extLst xmlns:a="http://schemas.openxmlformats.org/drawingml/2006/main">
               <a:ext uri="{FF2B5EF4-FFF2-40B4-BE49-F238E27FC236}">
-                <a16:creationId xmlns:a16="http://schemas.microsoft.com/office/drawing/2014/main" id="{5C59ACDB-E004-465A-BD1E-DB55349E4B70}"/>
+                <a16:creationId xmlns:a16="http://schemas.microsoft.com/office/drawing/2014/main" id="{76580D14-FCF0-4A46-910A-53BD6AA3A5C0}"/>
               </a:ext>
             </a:extLst>
           </p:cNvPr>
@@ -4091,7 +4091,7 @@
         <p:spPr>
           <a:xfrm xmlns:a="http://schemas.openxmlformats.org/drawingml/2006/main">
             <a:off x="857250" y="3752850"/>
-            <a:ext cx="6419850" cy="933450"/>
+            <a:ext cx="6381750" cy="933450"/>
           </a:xfrm>
           <a:prstGeom xmlns:a="http://schemas.openxmlformats.org/drawingml/2006/main" prst="rect">
             <a:avLst/>
@@ -4114,7 +4114,7 @@
                   <a:srgbClr val="5D6470"/>
                 </a:solidFill>
               </a:rPr>
-              <a:t>The public demo exposes the same eight-section output used in local validation, including official resource checks, language support, and handoff.</a:t>
+              <a:t>The refreshed static demo shows a twelve-section workflow: playbook references, official checks, household message, and audit trace.</a:t>
             </a:r>
           </a:p>
         </p:txBody>
@@ -4124,7 +4124,7 @@
           <p:cNvPr id="6" name="badge-public-demo">
             <a:extLst xmlns:a="http://schemas.openxmlformats.org/drawingml/2006/main">
               <a:ext uri="{FF2B5EF4-FFF2-40B4-BE49-F238E27FC236}">
-                <a16:creationId xmlns:a16="http://schemas.microsoft.com/office/drawing/2014/main" id="{3238E0BD-8E33-410F-865A-FD22D9DFE358}"/>
+                <a16:creationId xmlns:a16="http://schemas.microsoft.com/office/drawing/2014/main" id="{FFCDA57A-6742-4B91-86C4-E49AEB2CC7F8}"/>
               </a:ext>
             </a:extLst>
           </p:cNvPr>
@@ -4153,7 +4153,7 @@
           <p:cNvPr id="7" name="">
             <a:extLst xmlns:a="http://schemas.openxmlformats.org/drawingml/2006/main">
               <a:ext uri="{FF2B5EF4-FFF2-40B4-BE49-F238E27FC236}">
-                <a16:creationId xmlns:a16="http://schemas.microsoft.com/office/drawing/2014/main" id="{C1F47154-8133-4A4A-BB50-5F1AAE190E6D}"/>
+                <a16:creationId xmlns:a16="http://schemas.microsoft.com/office/drawing/2014/main" id="{C8346A8C-C35B-464D-A062-121489FCF11C}"/>
               </a:ext>
             </a:extLst>
           </p:cNvPr>
@@ -4198,7 +4198,7 @@
           <p:cNvPr id="8" name="badge-public-code">
             <a:extLst xmlns:a="http://schemas.openxmlformats.org/drawingml/2006/main">
               <a:ext uri="{FF2B5EF4-FFF2-40B4-BE49-F238E27FC236}">
-                <a16:creationId xmlns:a16="http://schemas.microsoft.com/office/drawing/2014/main" id="{E7278EEA-CECA-4317-A784-3321B027E335}"/>
+                <a16:creationId xmlns:a16="http://schemas.microsoft.com/office/drawing/2014/main" id="{9265FC6D-4C1F-4AD2-B9DC-FDB82D2BEB5E}"/>
               </a:ext>
             </a:extLst>
           </p:cNvPr>
@@ -4227,7 +4227,7 @@
           <p:cNvPr id="9" name="">
             <a:extLst xmlns:a="http://schemas.openxmlformats.org/drawingml/2006/main">
               <a:ext uri="{FF2B5EF4-FFF2-40B4-BE49-F238E27FC236}">
-                <a16:creationId xmlns:a16="http://schemas.microsoft.com/office/drawing/2014/main" id="{F6F6421D-293D-411C-9A65-FD9A2CCB7F76}"/>
+                <a16:creationId xmlns:a16="http://schemas.microsoft.com/office/drawing/2014/main" id="{34AF444F-E0C1-4CB5-8E0F-A28456066BEE}"/>
               </a:ext>
             </a:extLst>
           </p:cNvPr>
@@ -4272,7 +4272,7 @@
           <p:cNvPr id="10" name="badge-video-pitch">
             <a:extLst xmlns:a="http://schemas.openxmlformats.org/drawingml/2006/main">
               <a:ext uri="{FF2B5EF4-FFF2-40B4-BE49-F238E27FC236}">
-                <a16:creationId xmlns:a16="http://schemas.microsoft.com/office/drawing/2014/main" id="{3D308539-A05E-4EA6-9961-221D82E4D203}"/>
+                <a16:creationId xmlns:a16="http://schemas.microsoft.com/office/drawing/2014/main" id="{4DDF25A4-CF08-499F-A34E-4F59D4BC58BD}"/>
               </a:ext>
             </a:extLst>
           </p:cNvPr>
@@ -4301,7 +4301,7 @@
           <p:cNvPr id="11" name="">
             <a:extLst xmlns:a="http://schemas.openxmlformats.org/drawingml/2006/main">
               <a:ext uri="{FF2B5EF4-FFF2-40B4-BE49-F238E27FC236}">
-                <a16:creationId xmlns:a16="http://schemas.microsoft.com/office/drawing/2014/main" id="{EF7198E8-0820-48BE-94DB-A8D6665AB3C8}"/>
+                <a16:creationId xmlns:a16="http://schemas.microsoft.com/office/drawing/2014/main" id="{96722FC2-8E00-4DE6-A57A-E247841CDD64}"/>
               </a:ext>
             </a:extLst>
           </p:cNvPr>
@@ -4346,7 +4346,7 @@
           <p:cNvPr id="12" name="footer">
             <a:extLst xmlns:a="http://schemas.openxmlformats.org/drawingml/2006/main">
               <a:ext uri="{FF2B5EF4-FFF2-40B4-BE49-F238E27FC236}">
-                <a16:creationId xmlns:a16="http://schemas.microsoft.com/office/drawing/2014/main" id="{6B66C870-3A93-4597-92A7-B7CD179D0091}"/>
+                <a16:creationId xmlns:a16="http://schemas.microsoft.com/office/drawing/2014/main" id="{4C1F4A34-FB10-4352-9698-8811247ECC35}"/>
               </a:ext>
             </a:extLst>
           </p:cNvPr>
@@ -4391,7 +4391,7 @@
           <p:cNvPr id="13" name="">
             <a:extLst xmlns:a="http://schemas.openxmlformats.org/drawingml/2006/main">
               <a:ext uri="{FF2B5EF4-FFF2-40B4-BE49-F238E27FC236}">
-                <a16:creationId xmlns:a16="http://schemas.microsoft.com/office/drawing/2014/main" id="{6C35F177-E249-43D6-9C3B-A16CE0ACE799}"/>
+                <a16:creationId xmlns:a16="http://schemas.microsoft.com/office/drawing/2014/main" id="{F63F8FE9-ABAB-4CF2-920B-B2371B8C5ACE}"/>
               </a:ext>
             </a:extLst>
           </p:cNvPr>
@@ -4430,13 +4430,13 @@
           <p:nvPr/>
         </p:nvPicPr>
         <p:blipFill>
-          <a:blip xmlns:r="http://schemas.openxmlformats.org/officeDocument/2006/relationships" xmlns:a="http://schemas.openxmlformats.org/drawingml/2006/main" r:embed="Rb1944854de3a4929"/>
+          <a:blip xmlns:r="http://schemas.openxmlformats.org/officeDocument/2006/relationships" xmlns:a="http://schemas.openxmlformats.org/drawingml/2006/main" r:embed="R58e725b8888b47b9"/>
           <a:stretch xmlns:a="http://schemas.openxmlformats.org/drawingml/2006/main"/>
         </p:blipFill>
         <p:spPr>
           <a:xfrm xmlns:a="http://schemas.openxmlformats.org/drawingml/2006/main">
-            <a:off x="8223790" y="2143125"/>
-            <a:ext cx="8641080" cy="6000750"/>
+            <a:off x="8326567" y="2143125"/>
+            <a:ext cx="8435525" cy="6000750"/>
           </a:xfrm>
           <a:prstGeom xmlns:a="http://schemas.openxmlformats.org/drawingml/2006/main" prst="rect">
             <a:avLst/>
@@ -4446,7 +4446,7 @@
     </p:spTree>
     <p:extLst>
       <p:ext uri="{BB962C8B-B14F-4D97-AF65-F5344CB8AC3E}">
-        <p14:creationId xmlns:p14="http://schemas.microsoft.com/office/powerpoint/2010/main" val="1934426531"/>
+        <p14:creationId xmlns:p14="http://schemas.microsoft.com/office/powerpoint/2010/main" val="1616754957"/>
       </p:ext>
     </p:extLst>
   </p:cSld>
@@ -4470,7 +4470,7 @@
           <p:cNvPr id="1" name="background">
             <a:extLst xmlns:a="http://schemas.openxmlformats.org/drawingml/2006/main">
               <a:ext uri="{FF2B5EF4-FFF2-40B4-BE49-F238E27FC236}">
-                <a16:creationId xmlns:a16="http://schemas.microsoft.com/office/drawing/2014/main" id="{0CBB6525-96B2-40CA-AEC0-2D513C80074F}"/>
+                <a16:creationId xmlns:a16="http://schemas.microsoft.com/office/drawing/2014/main" id="{DA57FDB8-C499-454E-BD37-408C4712901D}"/>
               </a:ext>
             </a:extLst>
           </p:cNvPr>
@@ -4497,18 +4497,18 @@
           <p:cNvPr id="2" name="">
             <a:extLst xmlns:a="http://schemas.openxmlformats.org/drawingml/2006/main">
               <a:ext uri="{FF2B5EF4-FFF2-40B4-BE49-F238E27FC236}">
-                <a16:creationId xmlns:a16="http://schemas.microsoft.com/office/drawing/2014/main" id="{43AD78AA-B56B-4A67-89E3-F5BE00638DAB}"/>
-              </a:ext>
-            </a:extLst>
-          </p:cNvPr>
-          <p:cNvSpPr>
-            <a:spLocks xmlns:a="http://schemas.openxmlformats.org/drawingml/2006/main" noGrp="1"/>
-          </p:cNvSpPr>
-          <p:nvPr/>
-        </p:nvSpPr>
-        <p:spPr>
-          <a:xfrm xmlns:a="http://schemas.openxmlformats.org/drawingml/2006/main">
-            <a:off x="838200" y="3733800"/>
+                <a16:creationId xmlns:a16="http://schemas.microsoft.com/office/drawing/2014/main" id="{F2399433-91B6-4845-92B2-9A27AF704905}"/>
+              </a:ext>
+            </a:extLst>
+          </p:cNvPr>
+          <p:cNvSpPr>
+            <a:spLocks xmlns:a="http://schemas.openxmlformats.org/drawingml/2006/main" noGrp="1"/>
+          </p:cNvSpPr>
+          <p:nvPr/>
+        </p:nvSpPr>
+        <p:spPr>
+          <a:xfrm xmlns:a="http://schemas.openxmlformats.org/drawingml/2006/main">
+            <a:off x="838200" y="3314700"/>
             <a:ext cx="400050" cy="66675"/>
           </a:xfrm>
           <a:prstGeom xmlns:a="http://schemas.openxmlformats.org/drawingml/2006/main" prst="rect">
@@ -4524,18 +4524,18 @@
           <p:cNvPr id="3" name="">
             <a:extLst xmlns:a="http://schemas.openxmlformats.org/drawingml/2006/main">
               <a:ext uri="{FF2B5EF4-FFF2-40B4-BE49-F238E27FC236}">
-                <a16:creationId xmlns:a16="http://schemas.microsoft.com/office/drawing/2014/main" id="{A248FD19-CD82-41B7-9A28-90140B47FD6A}"/>
-              </a:ext>
-            </a:extLst>
-          </p:cNvPr>
-          <p:cNvSpPr>
-            <a:spLocks xmlns:a="http://schemas.openxmlformats.org/drawingml/2006/main" noGrp="1"/>
-          </p:cNvSpPr>
-          <p:nvPr/>
-        </p:nvSpPr>
-        <p:spPr>
-          <a:xfrm xmlns:a="http://schemas.openxmlformats.org/drawingml/2006/main">
-            <a:off x="1352550" y="3657600"/>
+                <a16:creationId xmlns:a16="http://schemas.microsoft.com/office/drawing/2014/main" id="{A3EC6767-3D3C-49FB-AB9A-67ACDD15BFF5}"/>
+              </a:ext>
+            </a:extLst>
+          </p:cNvPr>
+          <p:cNvSpPr>
+            <a:spLocks xmlns:a="http://schemas.openxmlformats.org/drawingml/2006/main" noGrp="1"/>
+          </p:cNvSpPr>
+          <p:nvPr/>
+        </p:nvSpPr>
+        <p:spPr>
+          <a:xfrm xmlns:a="http://schemas.openxmlformats.org/drawingml/2006/main">
+            <a:off x="1352550" y="3238500"/>
             <a:ext cx="1028700" cy="190500"/>
           </a:xfrm>
           <a:prstGeom xmlns:a="http://schemas.openxmlformats.org/drawingml/2006/main" prst="rect">
@@ -4569,19 +4569,19 @@
           <p:cNvPr id="4" name="">
             <a:extLst xmlns:a="http://schemas.openxmlformats.org/drawingml/2006/main">
               <a:ext uri="{FF2B5EF4-FFF2-40B4-BE49-F238E27FC236}">
-                <a16:creationId xmlns:a16="http://schemas.microsoft.com/office/drawing/2014/main" id="{C109FAF3-034E-4F26-958B-6C0542467176}"/>
-              </a:ext>
-            </a:extLst>
-          </p:cNvPr>
-          <p:cNvSpPr>
-            <a:spLocks xmlns:a="http://schemas.openxmlformats.org/drawingml/2006/main" noGrp="1"/>
-          </p:cNvSpPr>
-          <p:nvPr/>
-        </p:nvSpPr>
-        <p:spPr>
-          <a:xfrm xmlns:a="http://schemas.openxmlformats.org/drawingml/2006/main">
-            <a:off x="838200" y="4095750"/>
-            <a:ext cx="6896100" cy="1657350"/>
+                <a16:creationId xmlns:a16="http://schemas.microsoft.com/office/drawing/2014/main" id="{1227C6A6-4FEB-4C40-953A-A8303B985E3B}"/>
+              </a:ext>
+            </a:extLst>
+          </p:cNvPr>
+          <p:cNvSpPr>
+            <a:spLocks xmlns:a="http://schemas.openxmlformats.org/drawingml/2006/main" noGrp="1"/>
+          </p:cNvSpPr>
+          <p:nvPr/>
+        </p:nvSpPr>
+        <p:spPr>
+          <a:xfrm xmlns:a="http://schemas.openxmlformats.org/drawingml/2006/main">
+            <a:off x="838200" y="3676650"/>
+            <a:ext cx="6896100" cy="2476500"/>
           </a:xfrm>
           <a:prstGeom xmlns:a="http://schemas.openxmlformats.org/drawingml/2006/main" prst="rect">
             <a:avLst/>
@@ -4604,7 +4604,7 @@
                   <a:srgbClr val="FFFFFF"/>
                 </a:solidFill>
               </a:rPr>
-              <a:t>Small detector, bigger field discipline.</a:t>
+              <a:t>Small detector, auditable field discipline.</a:t>
             </a:r>
           </a:p>
         </p:txBody>
@@ -4614,18 +4614,18 @@
           <p:cNvPr id="5" name="">
             <a:extLst xmlns:a="http://schemas.openxmlformats.org/drawingml/2006/main">
               <a:ext uri="{FF2B5EF4-FFF2-40B4-BE49-F238E27FC236}">
-                <a16:creationId xmlns:a16="http://schemas.microsoft.com/office/drawing/2014/main" id="{DEEFCDAA-8238-4B7C-8FC0-FA9E4A4E054A}"/>
-              </a:ext>
-            </a:extLst>
-          </p:cNvPr>
-          <p:cNvSpPr>
-            <a:spLocks xmlns:a="http://schemas.openxmlformats.org/drawingml/2006/main" noGrp="1"/>
-          </p:cNvSpPr>
-          <p:nvPr/>
-        </p:nvSpPr>
-        <p:spPr>
-          <a:xfrm xmlns:a="http://schemas.openxmlformats.org/drawingml/2006/main">
-            <a:off x="838200" y="5981700"/>
+                <a16:creationId xmlns:a16="http://schemas.microsoft.com/office/drawing/2014/main" id="{1B2D6AA6-A72F-4EFD-8B45-D3B0D11489BC}"/>
+              </a:ext>
+            </a:extLst>
+          </p:cNvPr>
+          <p:cNvSpPr>
+            <a:spLocks xmlns:a="http://schemas.openxmlformats.org/drawingml/2006/main" noGrp="1"/>
+          </p:cNvSpPr>
+          <p:nvPr/>
+        </p:nvSpPr>
+        <p:spPr>
+          <a:xfrm xmlns:a="http://schemas.openxmlformats.org/drawingml/2006/main">
+            <a:off x="838200" y="6400800"/>
             <a:ext cx="6515100" cy="647700"/>
           </a:xfrm>
           <a:prstGeom xmlns:a="http://schemas.openxmlformats.org/drawingml/2006/main" prst="rect">
@@ -4649,7 +4649,7 @@
                   <a:srgbClr val="CBD5E1"/>
                 </a:solidFill>
               </a:rPr>
-              <a:t>Original branch: expand the sidecar beyond demo cases into official-channel checks that generic assistants often flatten.</a:t>
+              <a:t>Original branch: expand the sidecar beyond demo cases into official-channel checks and traceable playbook rule IDs.</a:t>
             </a:r>
           </a:p>
         </p:txBody>
@@ -4659,7 +4659,7 @@
           <p:cNvPr id="6" name="badge-children-cold-exposure">
             <a:extLst xmlns:a="http://schemas.openxmlformats.org/drawingml/2006/main">
               <a:ext uri="{FF2B5EF4-FFF2-40B4-BE49-F238E27FC236}">
-                <a16:creationId xmlns:a16="http://schemas.microsoft.com/office/drawing/2014/main" id="{D31A5C6B-0085-4770-B226-51447651329C}"/>
+                <a16:creationId xmlns:a16="http://schemas.microsoft.com/office/drawing/2014/main" id="{08D2DCD9-46A0-4F48-9E5E-32DB787A6E4D}"/>
               </a:ext>
             </a:extLst>
           </p:cNvPr>
@@ -4688,7 +4688,7 @@
           <p:cNvPr id="7" name="">
             <a:extLst xmlns:a="http://schemas.openxmlformats.org/drawingml/2006/main">
               <a:ext uri="{FF2B5EF4-FFF2-40B4-BE49-F238E27FC236}">
-                <a16:creationId xmlns:a16="http://schemas.microsoft.com/office/drawing/2014/main" id="{20AB6215-8397-407B-B5FD-F5E6CC5FA1A9}"/>
+                <a16:creationId xmlns:a16="http://schemas.microsoft.com/office/drawing/2014/main" id="{909D1F45-DA18-4847-94AC-79F017D9AB59}"/>
               </a:ext>
             </a:extLst>
           </p:cNvPr>
@@ -4733,7 +4733,7 @@
           <p:cNvPr id="8" name="badge-medication-interruption">
             <a:extLst xmlns:a="http://schemas.openxmlformats.org/drawingml/2006/main">
               <a:ext uri="{FF2B5EF4-FFF2-40B4-BE49-F238E27FC236}">
-                <a16:creationId xmlns:a16="http://schemas.microsoft.com/office/drawing/2014/main" id="{9787FC15-A95B-42D9-8FE8-CB4B16BE9BA8}"/>
+                <a16:creationId xmlns:a16="http://schemas.microsoft.com/office/drawing/2014/main" id="{B82BF2F0-B31C-4E81-9EDE-522A8F203624}"/>
               </a:ext>
             </a:extLst>
           </p:cNvPr>
@@ -4762,7 +4762,7 @@
           <p:cNvPr id="9" name="">
             <a:extLst xmlns:a="http://schemas.openxmlformats.org/drawingml/2006/main">
               <a:ext uri="{FF2B5EF4-FFF2-40B4-BE49-F238E27FC236}">
-                <a16:creationId xmlns:a16="http://schemas.microsoft.com/office/drawing/2014/main" id="{841D659D-4EBA-4871-93E9-A0CC7E031859}"/>
+                <a16:creationId xmlns:a16="http://schemas.microsoft.com/office/drawing/2014/main" id="{D0A7A7D5-1D75-4623-B4D8-8E2C33D9A5AF}"/>
               </a:ext>
             </a:extLst>
           </p:cNvPr>
@@ -4807,7 +4807,7 @@
           <p:cNvPr id="10" name="badge-pregnancy-insulin">
             <a:extLst xmlns:a="http://schemas.openxmlformats.org/drawingml/2006/main">
               <a:ext uri="{FF2B5EF4-FFF2-40B4-BE49-F238E27FC236}">
-                <a16:creationId xmlns:a16="http://schemas.microsoft.com/office/drawing/2014/main" id="{C6B2344D-E431-48F1-A0E7-EA858EFF3FB9}"/>
+                <a16:creationId xmlns:a16="http://schemas.microsoft.com/office/drawing/2014/main" id="{1376FD3B-B767-43BB-AAC7-DE0C13434C43}"/>
               </a:ext>
             </a:extLst>
           </p:cNvPr>
@@ -4836,7 +4836,7 @@
           <p:cNvPr id="11" name="">
             <a:extLst xmlns:a="http://schemas.openxmlformats.org/drawingml/2006/main">
               <a:ext uri="{FF2B5EF4-FFF2-40B4-BE49-F238E27FC236}">
-                <a16:creationId xmlns:a16="http://schemas.microsoft.com/office/drawing/2014/main" id="{ADFFA5C3-CDE0-43D2-8B40-A531C05398B9}"/>
+                <a16:creationId xmlns:a16="http://schemas.microsoft.com/office/drawing/2014/main" id="{6AD66C76-FDB0-4FB1-9420-2DB362C004FA}"/>
               </a:ext>
             </a:extLst>
           </p:cNvPr>
@@ -4881,7 +4881,7 @@
           <p:cNvPr id="12" name="badge-oxygen-power-loss">
             <a:extLst xmlns:a="http://schemas.openxmlformats.org/drawingml/2006/main">
               <a:ext uri="{FF2B5EF4-FFF2-40B4-BE49-F238E27FC236}">
-                <a16:creationId xmlns:a16="http://schemas.microsoft.com/office/drawing/2014/main" id="{BD0C2C4F-EA64-4D84-AE32-59F907E892D7}"/>
+                <a16:creationId xmlns:a16="http://schemas.microsoft.com/office/drawing/2014/main" id="{80988B94-D2FE-40BF-AF58-04431AFAE01A}"/>
               </a:ext>
             </a:extLst>
           </p:cNvPr>
@@ -4910,7 +4910,7 @@
           <p:cNvPr id="13" name="">
             <a:extLst xmlns:a="http://schemas.openxmlformats.org/drawingml/2006/main">
               <a:ext uri="{FF2B5EF4-FFF2-40B4-BE49-F238E27FC236}">
-                <a16:creationId xmlns:a16="http://schemas.microsoft.com/office/drawing/2014/main" id="{210812F9-8DAA-4D5D-A0FB-41FE92C97983}"/>
+                <a16:creationId xmlns:a16="http://schemas.microsoft.com/office/drawing/2014/main" id="{B4076437-082A-458C-824A-98DDA877DDCC}"/>
               </a:ext>
             </a:extLst>
           </p:cNvPr>
@@ -4955,7 +4955,7 @@
           <p:cNvPr id="14" name="badge-language-access-barrier">
             <a:extLst xmlns:a="http://schemas.openxmlformats.org/drawingml/2006/main">
               <a:ext uri="{FF2B5EF4-FFF2-40B4-BE49-F238E27FC236}">
-                <a16:creationId xmlns:a16="http://schemas.microsoft.com/office/drawing/2014/main" id="{23C23F53-DE60-4602-AA5F-EFE5DFFBEA9C}"/>
+                <a16:creationId xmlns:a16="http://schemas.microsoft.com/office/drawing/2014/main" id="{F6509140-B373-41F1-BB75-E9FC5083BF33}"/>
               </a:ext>
             </a:extLst>
           </p:cNvPr>
@@ -4984,7 +4984,7 @@
           <p:cNvPr id="15" name="">
             <a:extLst xmlns:a="http://schemas.openxmlformats.org/drawingml/2006/main">
               <a:ext uri="{FF2B5EF4-FFF2-40B4-BE49-F238E27FC236}">
-                <a16:creationId xmlns:a16="http://schemas.microsoft.com/office/drawing/2014/main" id="{D7FE1E32-E83B-4360-A7EE-0F9796461A65}"/>
+                <a16:creationId xmlns:a16="http://schemas.microsoft.com/office/drawing/2014/main" id="{8AB7E6F5-4634-4CAF-B6BB-39664F4966E5}"/>
               </a:ext>
             </a:extLst>
           </p:cNvPr>
@@ -5029,7 +5029,7 @@
           <p:cNvPr id="16" name="badge-unverified-shelter-rumor">
             <a:extLst xmlns:a="http://schemas.openxmlformats.org/drawingml/2006/main">
               <a:ext uri="{FF2B5EF4-FFF2-40B4-BE49-F238E27FC236}">
-                <a16:creationId xmlns:a16="http://schemas.microsoft.com/office/drawing/2014/main" id="{3F29BB98-ED28-4479-9F56-62324E60462A}"/>
+                <a16:creationId xmlns:a16="http://schemas.microsoft.com/office/drawing/2014/main" id="{0EBA95B7-619A-4B6E-B85E-A838292B93A4}"/>
               </a:ext>
             </a:extLst>
           </p:cNvPr>
@@ -5058,7 +5058,7 @@
           <p:cNvPr id="17" name="">
             <a:extLst xmlns:a="http://schemas.openxmlformats.org/drawingml/2006/main">
               <a:ext uri="{FF2B5EF4-FFF2-40B4-BE49-F238E27FC236}">
-                <a16:creationId xmlns:a16="http://schemas.microsoft.com/office/drawing/2014/main" id="{727D6E01-641E-4D0A-8157-3C8D871506CA}"/>
+                <a16:creationId xmlns:a16="http://schemas.microsoft.com/office/drawing/2014/main" id="{D09B9487-94D5-45B3-8DEE-DD4993A1639A}"/>
               </a:ext>
             </a:extLst>
           </p:cNvPr>
@@ -5100,10 +5100,10 @@
       </p:sp>
       <p:sp>
         <p:nvSpPr>
-          <p:cNvPr id="18" name="badge-official-resource-routing">
-            <a:extLst xmlns:a="http://schemas.openxmlformats.org/drawingml/2006/main">
-              <a:ext uri="{FF2B5EF4-FFF2-40B4-BE49-F238E27FC236}">
-                <a16:creationId xmlns:a16="http://schemas.microsoft.com/office/drawing/2014/main" id="{73ECEBAE-3799-4BFE-812B-B485767EDE5E}"/>
+          <p:cNvPr id="18" name="badge-playbook-grounding">
+            <a:extLst xmlns:a="http://schemas.openxmlformats.org/drawingml/2006/main">
+              <a:ext uri="{FF2B5EF4-FFF2-40B4-BE49-F238E27FC236}">
+                <a16:creationId xmlns:a16="http://schemas.microsoft.com/office/drawing/2014/main" id="{E41F62A5-63C1-4897-9D56-F28BBA64422F}"/>
               </a:ext>
             </a:extLst>
           </p:cNvPr>
@@ -5132,19 +5132,19 @@
           <p:cNvPr id="19" name="">
             <a:extLst xmlns:a="http://schemas.openxmlformats.org/drawingml/2006/main">
               <a:ext uri="{FF2B5EF4-FFF2-40B4-BE49-F238E27FC236}">
-                <a16:creationId xmlns:a16="http://schemas.microsoft.com/office/drawing/2014/main" id="{6B59F97F-F9E9-414E-B8B5-844F17C6607D}"/>
-              </a:ext>
-            </a:extLst>
-          </p:cNvPr>
-          <p:cNvSpPr>
-            <a:spLocks xmlns:a="http://schemas.openxmlformats.org/drawingml/2006/main" noGrp="1"/>
-          </p:cNvSpPr>
-          <p:nvPr/>
-        </p:nvSpPr>
-        <p:spPr>
-          <a:xfrm xmlns:a="http://schemas.openxmlformats.org/drawingml/2006/main">
-            <a:off x="9696450" y="8362950"/>
-            <a:ext cx="1676400" cy="419100"/>
+                <a16:creationId xmlns:a16="http://schemas.microsoft.com/office/drawing/2014/main" id="{C457E62B-8E03-48BA-9D2A-3D91B6285896}"/>
+              </a:ext>
+            </a:extLst>
+          </p:cNvPr>
+          <p:cNvSpPr>
+            <a:spLocks xmlns:a="http://schemas.openxmlformats.org/drawingml/2006/main" noGrp="1"/>
+          </p:cNvSpPr>
+          <p:nvPr/>
+        </p:nvSpPr>
+        <p:spPr>
+          <a:xfrm xmlns:a="http://schemas.openxmlformats.org/drawingml/2006/main">
+            <a:off x="9829800" y="8477250"/>
+            <a:ext cx="1409700" cy="190500"/>
           </a:xfrm>
           <a:prstGeom xmlns:a="http://schemas.openxmlformats.org/drawingml/2006/main" prst="rect">
             <a:avLst/>
@@ -5167,17 +5167,17 @@
                   <a:srgbClr val="10151F"/>
                 </a:solidFill>
               </a:rPr>
-              <a:t>official resource routing</a:t>
-            </a:r>
-          </a:p>
-        </p:txBody>
-      </p:sp>
-      <p:sp>
-        <p:nvSpPr>
-          <p:cNvPr id="20" name="badge-responder-handoff">
-            <a:extLst xmlns:a="http://schemas.openxmlformats.org/drawingml/2006/main">
-              <a:ext uri="{FF2B5EF4-FFF2-40B4-BE49-F238E27FC236}">
-                <a16:creationId xmlns:a16="http://schemas.microsoft.com/office/drawing/2014/main" id="{AD60F445-FDBF-411D-983D-61B2671D24A8}"/>
+              <a:t>playbook grounding</a:t>
+            </a:r>
+          </a:p>
+        </p:txBody>
+      </p:sp>
+      <p:sp>
+        <p:nvSpPr>
+          <p:cNvPr id="20" name="badge-audit-trace">
+            <a:extLst xmlns:a="http://schemas.openxmlformats.org/drawingml/2006/main">
+              <a:ext uri="{FF2B5EF4-FFF2-40B4-BE49-F238E27FC236}">
+                <a16:creationId xmlns:a16="http://schemas.microsoft.com/office/drawing/2014/main" id="{0136AFB5-346D-4EBE-B102-27B7C2B812B1}"/>
               </a:ext>
             </a:extLst>
           </p:cNvPr>
@@ -5206,19 +5206,19 @@
           <p:cNvPr id="21" name="">
             <a:extLst xmlns:a="http://schemas.openxmlformats.org/drawingml/2006/main">
               <a:ext uri="{FF2B5EF4-FFF2-40B4-BE49-F238E27FC236}">
-                <a16:creationId xmlns:a16="http://schemas.microsoft.com/office/drawing/2014/main" id="{34C77C42-671E-4833-87D3-2EC06A6BAE83}"/>
-              </a:ext>
-            </a:extLst>
-          </p:cNvPr>
-          <p:cNvSpPr>
-            <a:spLocks xmlns:a="http://schemas.openxmlformats.org/drawingml/2006/main" noGrp="1"/>
-          </p:cNvSpPr>
-          <p:nvPr/>
-        </p:nvSpPr>
-        <p:spPr>
-          <a:xfrm xmlns:a="http://schemas.openxmlformats.org/drawingml/2006/main">
-            <a:off x="14554200" y="8362950"/>
-            <a:ext cx="1333500" cy="419100"/>
+                <a16:creationId xmlns:a16="http://schemas.microsoft.com/office/drawing/2014/main" id="{47ADEBEF-33E1-4867-85D5-19753DF68580}"/>
+              </a:ext>
+            </a:extLst>
+          </p:cNvPr>
+          <p:cNvSpPr>
+            <a:spLocks xmlns:a="http://schemas.openxmlformats.org/drawingml/2006/main" noGrp="1"/>
+          </p:cNvSpPr>
+          <p:nvPr/>
+        </p:nvSpPr>
+        <p:spPr>
+          <a:xfrm xmlns:a="http://schemas.openxmlformats.org/drawingml/2006/main">
+            <a:off x="14839950" y="8477250"/>
+            <a:ext cx="762000" cy="190500"/>
           </a:xfrm>
           <a:prstGeom xmlns:a="http://schemas.openxmlformats.org/drawingml/2006/main" prst="rect">
             <a:avLst/>
@@ -5241,7 +5241,7 @@
                   <a:srgbClr val="10151F"/>
                 </a:solidFill>
               </a:rPr>
-              <a:t>responder handoff</a:t>
+              <a:t>audit trace</a:t>
             </a:r>
           </a:p>
         </p:txBody>
@@ -5249,7 +5249,7 @@
     </p:spTree>
     <p:extLst>
       <p:ext uri="{BB962C8B-B14F-4D97-AF65-F5344CB8AC3E}">
-        <p14:creationId xmlns:p14="http://schemas.microsoft.com/office/powerpoint/2010/main" val="872388824"/>
+        <p14:creationId xmlns:p14="http://schemas.microsoft.com/office/powerpoint/2010/main" val="1270360855"/>
       </p:ext>
     </p:extLst>
   </p:cSld>
@@ -5273,7 +5273,7 @@
           <p:cNvPr id="1" name="background">
             <a:extLst xmlns:a="http://schemas.openxmlformats.org/drawingml/2006/main">
               <a:ext uri="{FF2B5EF4-FFF2-40B4-BE49-F238E27FC236}">
-                <a16:creationId xmlns:a16="http://schemas.microsoft.com/office/drawing/2014/main" id="{A785B97E-8450-4E50-85FF-C4FFD2AADFC7}"/>
+                <a16:creationId xmlns:a16="http://schemas.microsoft.com/office/drawing/2014/main" id="{8F6F227A-FBC6-4A8C-B33C-EF1834AECE8C}"/>
               </a:ext>
             </a:extLst>
           </p:cNvPr>
@@ -5300,7 +5300,7 @@
           <p:cNvPr id="2" name="">
             <a:extLst xmlns:a="http://schemas.openxmlformats.org/drawingml/2006/main">
               <a:ext uri="{FF2B5EF4-FFF2-40B4-BE49-F238E27FC236}">
-                <a16:creationId xmlns:a16="http://schemas.microsoft.com/office/drawing/2014/main" id="{141DE91E-D10C-4BE3-97F6-514923CD8B7A}"/>
+                <a16:creationId xmlns:a16="http://schemas.microsoft.com/office/drawing/2014/main" id="{45AD0938-0126-4BB4-A181-343F69EE1A1D}"/>
               </a:ext>
             </a:extLst>
           </p:cNvPr>
@@ -5327,7 +5327,7 @@
           <p:cNvPr id="3" name="">
             <a:extLst xmlns:a="http://schemas.openxmlformats.org/drawingml/2006/main">
               <a:ext uri="{FF2B5EF4-FFF2-40B4-BE49-F238E27FC236}">
-                <a16:creationId xmlns:a16="http://schemas.microsoft.com/office/drawing/2014/main" id="{53B8AAF7-4BED-4F46-BEF7-D3180A7BF77F}"/>
+                <a16:creationId xmlns:a16="http://schemas.microsoft.com/office/drawing/2014/main" id="{ACD254B7-96C0-4EAE-96E4-02A7B7415DE2}"/>
               </a:ext>
             </a:extLst>
           </p:cNvPr>
@@ -5372,7 +5372,7 @@
           <p:cNvPr id="4" name="">
             <a:extLst xmlns:a="http://schemas.openxmlformats.org/drawingml/2006/main">
               <a:ext uri="{FF2B5EF4-FFF2-40B4-BE49-F238E27FC236}">
-                <a16:creationId xmlns:a16="http://schemas.microsoft.com/office/drawing/2014/main" id="{86D014DA-EF3F-4357-92AF-FF935185639E}"/>
+                <a16:creationId xmlns:a16="http://schemas.microsoft.com/office/drawing/2014/main" id="{19ADE8B5-FD42-4427-9A66-9FA08679F18A}"/>
               </a:ext>
             </a:extLst>
           </p:cNvPr>
@@ -5417,7 +5417,7 @@
           <p:cNvPr id="5" name="">
             <a:extLst xmlns:a="http://schemas.openxmlformats.org/drawingml/2006/main">
               <a:ext uri="{FF2B5EF4-FFF2-40B4-BE49-F238E27FC236}">
-                <a16:creationId xmlns:a16="http://schemas.microsoft.com/office/drawing/2014/main" id="{2CE7BC1C-0EF7-48D9-A47E-C8779E1B6B9D}"/>
+                <a16:creationId xmlns:a16="http://schemas.microsoft.com/office/drawing/2014/main" id="{96C6FAF0-7E45-4C36-BEC4-97EEFEB33AFE}"/>
               </a:ext>
             </a:extLst>
           </p:cNvPr>
@@ -5469,7 +5469,7 @@
         </p:xfrm>
         <a:graphic xmlns:a="http://schemas.openxmlformats.org/drawingml/2006/main">
           <a:graphicData uri="http://schemas.openxmlformats.org/drawingml/2006/chart">
-            <c:chart xmlns:r="http://schemas.openxmlformats.org/officeDocument/2006/relationships" xmlns:c="http://schemas.openxmlformats.org/drawingml/2006/chart" r:id="R3f1b886a38ee45b4"/>
+            <c:chart xmlns:r="http://schemas.openxmlformats.org/officeDocument/2006/relationships" xmlns:c="http://schemas.openxmlformats.org/drawingml/2006/chart" r:id="R4e66bfff2f1b43de"/>
           </a:graphicData>
         </a:graphic>
       </p:graphicFrame>
@@ -5478,7 +5478,7 @@
           <p:cNvPr id="7" name="">
             <a:extLst xmlns:a="http://schemas.openxmlformats.org/drawingml/2006/main">
               <a:ext uri="{FF2B5EF4-FFF2-40B4-BE49-F238E27FC236}">
-                <a16:creationId xmlns:a16="http://schemas.microsoft.com/office/drawing/2014/main" id="{A6AA0800-EDB8-436F-97F6-2A37CDF554FE}"/>
+                <a16:creationId xmlns:a16="http://schemas.microsoft.com/office/drawing/2014/main" id="{8745EF64-D19D-469B-B1ED-2062517A6E7F}"/>
               </a:ext>
             </a:extLst>
           </p:cNvPr>
@@ -5523,7 +5523,7 @@
           <p:cNvPr id="8" name="">
             <a:extLst xmlns:a="http://schemas.openxmlformats.org/drawingml/2006/main">
               <a:ext uri="{FF2B5EF4-FFF2-40B4-BE49-F238E27FC236}">
-                <a16:creationId xmlns:a16="http://schemas.microsoft.com/office/drawing/2014/main" id="{0940C905-E0EC-44BC-BB64-BE13C781F547}"/>
+                <a16:creationId xmlns:a16="http://schemas.microsoft.com/office/drawing/2014/main" id="{4BE95A3A-5C7A-4ACF-AAD7-292654840D5B}"/>
               </a:ext>
             </a:extLst>
           </p:cNvPr>
@@ -5568,7 +5568,7 @@
           <p:cNvPr id="9" name="">
             <a:extLst xmlns:a="http://schemas.openxmlformats.org/drawingml/2006/main">
               <a:ext uri="{FF2B5EF4-FFF2-40B4-BE49-F238E27FC236}">
-                <a16:creationId xmlns:a16="http://schemas.microsoft.com/office/drawing/2014/main" id="{D64EFDBF-4A0C-43C5-8F5F-84E4258A6C2B}"/>
+                <a16:creationId xmlns:a16="http://schemas.microsoft.com/office/drawing/2014/main" id="{241B989B-E471-4CAE-9247-30E770E2CA34}"/>
               </a:ext>
             </a:extLst>
           </p:cNvPr>
@@ -5613,7 +5613,7 @@
           <p:cNvPr id="10" name="">
             <a:extLst xmlns:a="http://schemas.openxmlformats.org/drawingml/2006/main">
               <a:ext uri="{FF2B5EF4-FFF2-40B4-BE49-F238E27FC236}">
-                <a16:creationId xmlns:a16="http://schemas.microsoft.com/office/drawing/2014/main" id="{2123859E-A145-4D35-BC62-62531060EDB4}"/>
+                <a16:creationId xmlns:a16="http://schemas.microsoft.com/office/drawing/2014/main" id="{25677C01-B587-42A2-86F2-55087ECBF96D}"/>
               </a:ext>
             </a:extLst>
           </p:cNvPr>
@@ -5658,7 +5658,7 @@
           <p:cNvPr id="11" name="">
             <a:extLst xmlns:a="http://schemas.openxmlformats.org/drawingml/2006/main">
               <a:ext uri="{FF2B5EF4-FFF2-40B4-BE49-F238E27FC236}">
-                <a16:creationId xmlns:a16="http://schemas.microsoft.com/office/drawing/2014/main" id="{B4D39B74-C97A-4122-8FD7-2DDAB6856C4C}"/>
+                <a16:creationId xmlns:a16="http://schemas.microsoft.com/office/drawing/2014/main" id="{4AC8B299-14F2-44DC-8F96-C75EE11A7A80}"/>
               </a:ext>
             </a:extLst>
           </p:cNvPr>
@@ -5693,7 +5693,7 @@
                   <a:srgbClr val="FF5A66"/>
                 </a:solidFill>
               </a:rPr>
-              <a:t>6/6</a:t>
+              <a:t>10/10</a:t>
             </a:r>
           </a:p>
         </p:txBody>
@@ -5703,7 +5703,7 @@
           <p:cNvPr id="12" name="">
             <a:extLst xmlns:a="http://schemas.openxmlformats.org/drawingml/2006/main">
               <a:ext uri="{FF2B5EF4-FFF2-40B4-BE49-F238E27FC236}">
-                <a16:creationId xmlns:a16="http://schemas.microsoft.com/office/drawing/2014/main" id="{D18B3D17-46DE-4087-86D2-C109D1B02DC5}"/>
+                <a16:creationId xmlns:a16="http://schemas.microsoft.com/office/drawing/2014/main" id="{ED5C50DF-3491-4A05-9F48-17F2914B5A42}"/>
               </a:ext>
             </a:extLst>
           </p:cNvPr>
@@ -5748,7 +5748,7 @@
           <p:cNvPr id="13" name="footer">
             <a:extLst xmlns:a="http://schemas.openxmlformats.org/drawingml/2006/main">
               <a:ext uri="{FF2B5EF4-FFF2-40B4-BE49-F238E27FC236}">
-                <a16:creationId xmlns:a16="http://schemas.microsoft.com/office/drawing/2014/main" id="{A1D7C4C6-DDF5-447F-9254-E6AC6B659610}"/>
+                <a16:creationId xmlns:a16="http://schemas.microsoft.com/office/drawing/2014/main" id="{24BBE1CD-4575-4369-8701-85C6EE5A8E5D}"/>
               </a:ext>
             </a:extLst>
           </p:cNvPr>
@@ -5791,7 +5791,7 @@
     </p:spTree>
     <p:extLst>
       <p:ext uri="{BB962C8B-B14F-4D97-AF65-F5344CB8AC3E}">
-        <p14:creationId xmlns:p14="http://schemas.microsoft.com/office/powerpoint/2010/main" val="128207758"/>
+        <p14:creationId xmlns:p14="http://schemas.microsoft.com/office/powerpoint/2010/main" val="2026516389"/>
       </p:ext>
     </p:extLst>
   </p:cSld>
@@ -5815,7 +5815,7 @@
           <p:cNvPr id="1" name="background">
             <a:extLst xmlns:a="http://schemas.openxmlformats.org/drawingml/2006/main">
               <a:ext uri="{FF2B5EF4-FFF2-40B4-BE49-F238E27FC236}">
-                <a16:creationId xmlns:a16="http://schemas.microsoft.com/office/drawing/2014/main" id="{71D54F9E-14E9-4D54-893C-8F01D2ADB431}"/>
+                <a16:creationId xmlns:a16="http://schemas.microsoft.com/office/drawing/2014/main" id="{5C1D2BD2-156E-4D0D-B403-E13E92A650C8}"/>
               </a:ext>
             </a:extLst>
           </p:cNvPr>
@@ -5842,7 +5842,7 @@
           <p:cNvPr id="2" name="">
             <a:extLst xmlns:a="http://schemas.openxmlformats.org/drawingml/2006/main">
               <a:ext uri="{FF2B5EF4-FFF2-40B4-BE49-F238E27FC236}">
-                <a16:creationId xmlns:a16="http://schemas.microsoft.com/office/drawing/2014/main" id="{739C78F0-F91E-4F57-9E2C-B5780BFE6D5F}"/>
+                <a16:creationId xmlns:a16="http://schemas.microsoft.com/office/drawing/2014/main" id="{E27DC410-B49D-4EEC-961D-8FDAADD6DE24}"/>
               </a:ext>
             </a:extLst>
           </p:cNvPr>
@@ -5869,7 +5869,7 @@
           <p:cNvPr id="3" name="">
             <a:extLst xmlns:a="http://schemas.openxmlformats.org/drawingml/2006/main">
               <a:ext uri="{FF2B5EF4-FFF2-40B4-BE49-F238E27FC236}">
-                <a16:creationId xmlns:a16="http://schemas.microsoft.com/office/drawing/2014/main" id="{5EAACADE-8219-4E86-B0C0-C1B8B0F6BD16}"/>
+                <a16:creationId xmlns:a16="http://schemas.microsoft.com/office/drawing/2014/main" id="{10F5201C-03F3-4D1B-9AAB-88F1EC79B22A}"/>
               </a:ext>
             </a:extLst>
           </p:cNvPr>
@@ -5914,7 +5914,7 @@
           <p:cNvPr id="4" name="">
             <a:extLst xmlns:a="http://schemas.openxmlformats.org/drawingml/2006/main">
               <a:ext uri="{FF2B5EF4-FFF2-40B4-BE49-F238E27FC236}">
-                <a16:creationId xmlns:a16="http://schemas.microsoft.com/office/drawing/2014/main" id="{930C0151-6AD7-4A68-94D0-EE830ED52BA4}"/>
+                <a16:creationId xmlns:a16="http://schemas.microsoft.com/office/drawing/2014/main" id="{8616306F-CA69-4E92-A8D5-F0A0BF66B1F9}"/>
               </a:ext>
             </a:extLst>
           </p:cNvPr>
@@ -5959,7 +5959,7 @@
           <p:cNvPr id="5" name="">
             <a:extLst xmlns:a="http://schemas.openxmlformats.org/drawingml/2006/main">
               <a:ext uri="{FF2B5EF4-FFF2-40B4-BE49-F238E27FC236}">
-                <a16:creationId xmlns:a16="http://schemas.microsoft.com/office/drawing/2014/main" id="{8C452CC8-CE82-46DC-91A3-F9D454BE97D8}"/>
+                <a16:creationId xmlns:a16="http://schemas.microsoft.com/office/drawing/2014/main" id="{8FE50778-28B6-402B-9B95-A4E24F313699}"/>
               </a:ext>
             </a:extLst>
           </p:cNvPr>
@@ -6004,7 +6004,7 @@
           <p:cNvPr id="6" name="badge-tesla-t4">
             <a:extLst xmlns:a="http://schemas.openxmlformats.org/drawingml/2006/main">
               <a:ext uri="{FF2B5EF4-FFF2-40B4-BE49-F238E27FC236}">
-                <a16:creationId xmlns:a16="http://schemas.microsoft.com/office/drawing/2014/main" id="{EBE8A4D3-FF79-4B0B-B3CF-AF1A77F3BE79}"/>
+                <a16:creationId xmlns:a16="http://schemas.microsoft.com/office/drawing/2014/main" id="{66D47198-71E7-48D7-AB9B-C44A400C9D96}"/>
               </a:ext>
             </a:extLst>
           </p:cNvPr>
@@ -6033,7 +6033,7 @@
           <p:cNvPr id="7" name="">
             <a:extLst xmlns:a="http://schemas.openxmlformats.org/drawingml/2006/main">
               <a:ext uri="{FF2B5EF4-FFF2-40B4-BE49-F238E27FC236}">
-                <a16:creationId xmlns:a16="http://schemas.microsoft.com/office/drawing/2014/main" id="{1AB0D011-9F68-4A87-8A75-BB0D548DF49A}"/>
+                <a16:creationId xmlns:a16="http://schemas.microsoft.com/office/drawing/2014/main" id="{F1182ED6-E62B-4E6F-AF34-B340160ED10E}"/>
               </a:ext>
             </a:extLst>
           </p:cNvPr>
@@ -6078,7 +6078,7 @@
           <p:cNvPr id="8" name="badge-160-new-tokens">
             <a:extLst xmlns:a="http://schemas.openxmlformats.org/drawingml/2006/main">
               <a:ext uri="{FF2B5EF4-FFF2-40B4-BE49-F238E27FC236}">
-                <a16:creationId xmlns:a16="http://schemas.microsoft.com/office/drawing/2014/main" id="{97FDC2E6-13E5-4945-BB67-A7A7F9A99D2F}"/>
+                <a16:creationId xmlns:a16="http://schemas.microsoft.com/office/drawing/2014/main" id="{3B985D49-FACC-416B-B668-88896209B763}"/>
               </a:ext>
             </a:extLst>
           </p:cNvPr>
@@ -6107,7 +6107,7 @@
           <p:cNvPr id="9" name="">
             <a:extLst xmlns:a="http://schemas.openxmlformats.org/drawingml/2006/main">
               <a:ext uri="{FF2B5EF4-FFF2-40B4-BE49-F238E27FC236}">
-                <a16:creationId xmlns:a16="http://schemas.microsoft.com/office/drawing/2014/main" id="{1D037025-4B7D-4F8F-BE2B-B40EB9586FBB}"/>
+                <a16:creationId xmlns:a16="http://schemas.microsoft.com/office/drawing/2014/main" id="{B1AB5B92-D5DA-42BE-B5C4-A313E2117608}"/>
               </a:ext>
             </a:extLst>
           </p:cNvPr>
@@ -6152,7 +6152,7 @@
           <p:cNvPr id="10" name="badge-18-014s-recorded-latency">
             <a:extLst xmlns:a="http://schemas.openxmlformats.org/drawingml/2006/main">
               <a:ext uri="{FF2B5EF4-FFF2-40B4-BE49-F238E27FC236}">
-                <a16:creationId xmlns:a16="http://schemas.microsoft.com/office/drawing/2014/main" id="{FE86A578-EB10-4001-BBD5-E8DA99856549}"/>
+                <a16:creationId xmlns:a16="http://schemas.microsoft.com/office/drawing/2014/main" id="{52AA89D7-AF6F-4C32-A217-6B23F4E0816A}"/>
               </a:ext>
             </a:extLst>
           </p:cNvPr>
@@ -6181,7 +6181,7 @@
           <p:cNvPr id="11" name="">
             <a:extLst xmlns:a="http://schemas.openxmlformats.org/drawingml/2006/main">
               <a:ext uri="{FF2B5EF4-FFF2-40B4-BE49-F238E27FC236}">
-                <a16:creationId xmlns:a16="http://schemas.microsoft.com/office/drawing/2014/main" id="{B0784861-FDC2-4185-82A7-117470EC56FD}"/>
+                <a16:creationId xmlns:a16="http://schemas.microsoft.com/office/drawing/2014/main" id="{52D4A933-2327-48C0-9FBA-131D05029B34}"/>
               </a:ext>
             </a:extLst>
           </p:cNvPr>
@@ -6226,7 +6226,7 @@
           <p:cNvPr id="12" name="">
             <a:extLst xmlns:a="http://schemas.openxmlformats.org/drawingml/2006/main">
               <a:ext uri="{FF2B5EF4-FFF2-40B4-BE49-F238E27FC236}">
-                <a16:creationId xmlns:a16="http://schemas.microsoft.com/office/drawing/2014/main" id="{025C52B5-EA26-4839-8AF5-C0E450F9105B}"/>
+                <a16:creationId xmlns:a16="http://schemas.microsoft.com/office/drawing/2014/main" id="{BD101CC6-F9D8-40A6-978F-555A45815E4B}"/>
               </a:ext>
             </a:extLst>
           </p:cNvPr>
@@ -6265,7 +6265,7 @@
           <p:nvPr/>
         </p:nvPicPr>
         <p:blipFill>
-          <a:blip xmlns:r="http://schemas.openxmlformats.org/officeDocument/2006/relationships" xmlns:a="http://schemas.openxmlformats.org/drawingml/2006/main" r:embed="R195b01e61e6f4e2f"/>
+          <a:blip xmlns:r="http://schemas.openxmlformats.org/officeDocument/2006/relationships" xmlns:a="http://schemas.openxmlformats.org/drawingml/2006/main" r:embed="R0fa5d79ccae64bf6"/>
           <a:stretch xmlns:a="http://schemas.openxmlformats.org/drawingml/2006/main"/>
         </p:blipFill>
         <p:spPr>
@@ -6281,7 +6281,7 @@
     </p:spTree>
     <p:extLst>
       <p:ext uri="{BB962C8B-B14F-4D97-AF65-F5344CB8AC3E}">
-        <p14:creationId xmlns:p14="http://schemas.microsoft.com/office/powerpoint/2010/main" val="285641546"/>
+        <p14:creationId xmlns:p14="http://schemas.microsoft.com/office/powerpoint/2010/main" val="509389658"/>
       </p:ext>
     </p:extLst>
   </p:cSld>
@@ -6305,7 +6305,7 @@
           <p:cNvPr id="1" name="background">
             <a:extLst xmlns:a="http://schemas.openxmlformats.org/drawingml/2006/main">
               <a:ext uri="{FF2B5EF4-FFF2-40B4-BE49-F238E27FC236}">
-                <a16:creationId xmlns:a16="http://schemas.microsoft.com/office/drawing/2014/main" id="{0BF2CED1-ECFF-46B9-8C27-56904CFBC246}"/>
+                <a16:creationId xmlns:a16="http://schemas.microsoft.com/office/drawing/2014/main" id="{FB9E2F5D-C32D-44FE-ADBA-BEFE63FB4E33}"/>
               </a:ext>
             </a:extLst>
           </p:cNvPr>
@@ -6332,7 +6332,7 @@
           <p:cNvPr id="2" name="">
             <a:extLst xmlns:a="http://schemas.openxmlformats.org/drawingml/2006/main">
               <a:ext uri="{FF2B5EF4-FFF2-40B4-BE49-F238E27FC236}">
-                <a16:creationId xmlns:a16="http://schemas.microsoft.com/office/drawing/2014/main" id="{CE00F30E-E226-4B61-BF7D-FA1832432C10}"/>
+                <a16:creationId xmlns:a16="http://schemas.microsoft.com/office/drawing/2014/main" id="{4545C3EC-5C94-4628-A653-C00BB4237E3D}"/>
               </a:ext>
             </a:extLst>
           </p:cNvPr>
@@ -6359,7 +6359,7 @@
           <p:cNvPr id="3" name="">
             <a:extLst xmlns:a="http://schemas.openxmlformats.org/drawingml/2006/main">
               <a:ext uri="{FF2B5EF4-FFF2-40B4-BE49-F238E27FC236}">
-                <a16:creationId xmlns:a16="http://schemas.microsoft.com/office/drawing/2014/main" id="{0F88546D-3658-4220-A71F-A2EF0B252D1F}"/>
+                <a16:creationId xmlns:a16="http://schemas.microsoft.com/office/drawing/2014/main" id="{C1ADDAFB-5FEA-4F51-9817-290E91388BE3}"/>
               </a:ext>
             </a:extLst>
           </p:cNvPr>
@@ -6404,7 +6404,7 @@
           <p:cNvPr id="4" name="">
             <a:extLst xmlns:a="http://schemas.openxmlformats.org/drawingml/2006/main">
               <a:ext uri="{FF2B5EF4-FFF2-40B4-BE49-F238E27FC236}">
-                <a16:creationId xmlns:a16="http://schemas.microsoft.com/office/drawing/2014/main" id="{4D3E97F4-5B5E-4C82-A496-809F774F8BA0}"/>
+                <a16:creationId xmlns:a16="http://schemas.microsoft.com/office/drawing/2014/main" id="{86E42A84-5B8C-4C9D-8B7F-B556CD7EF3F5}"/>
               </a:ext>
             </a:extLst>
           </p:cNvPr>
@@ -6449,7 +6449,7 @@
           <p:cNvPr id="5" name="">
             <a:extLst xmlns:a="http://schemas.openxmlformats.org/drawingml/2006/main">
               <a:ext uri="{FF2B5EF4-FFF2-40B4-BE49-F238E27FC236}">
-                <a16:creationId xmlns:a16="http://schemas.microsoft.com/office/drawing/2014/main" id="{70312FF7-F170-4D54-B4B6-31B089D2198B}"/>
+                <a16:creationId xmlns:a16="http://schemas.microsoft.com/office/drawing/2014/main" id="{A5F94DC4-8529-45AD-B452-A4D5789AC592}"/>
               </a:ext>
             </a:extLst>
           </p:cNvPr>
@@ -6461,7 +6461,7 @@
         <p:spPr>
           <a:xfrm xmlns:a="http://schemas.openxmlformats.org/drawingml/2006/main">
             <a:off x="895350" y="3067050"/>
-            <a:ext cx="11277600" cy="685800"/>
+            <a:ext cx="11468100" cy="1028700"/>
           </a:xfrm>
           <a:prstGeom xmlns:a="http://schemas.openxmlformats.org/drawingml/2006/main" prst="rect">
             <a:avLst/>
@@ -6484,7 +6484,7 @@
                   <a:srgbClr val="D6DEE9"/>
                 </a:solidFill>
               </a:rPr>
-              <a:t>This is deliberately narrow: one crisis workflow, visible safety constraints, official-resource checks, public evidence, and a clear path to stronger multilingual Gemma 4 generation.</a:t>
+              <a:t>This is deliberately narrow: one crisis workflow, visible safety constraints, playbook-backed checks, responder packets, household messages, audit traces, public evidence, and a clear path to stronger multilingual Gemma 4 generation.</a:t>
             </a:r>
           </a:p>
         </p:txBody>
@@ -6494,18 +6494,18 @@
           <p:cNvPr id="6" name="">
             <a:extLst xmlns:a="http://schemas.openxmlformats.org/drawingml/2006/main">
               <a:ext uri="{FF2B5EF4-FFF2-40B4-BE49-F238E27FC236}">
-                <a16:creationId xmlns:a16="http://schemas.microsoft.com/office/drawing/2014/main" id="{F48BE8FC-0F5E-4614-85B9-3A620BEBC912}"/>
-              </a:ext>
-            </a:extLst>
-          </p:cNvPr>
-          <p:cNvSpPr>
-            <a:spLocks xmlns:a="http://schemas.openxmlformats.org/drawingml/2006/main" noGrp="1"/>
-          </p:cNvSpPr>
-          <p:nvPr/>
-        </p:nvSpPr>
-        <p:spPr>
-          <a:xfrm xmlns:a="http://schemas.openxmlformats.org/drawingml/2006/main">
-            <a:off x="895350" y="5570220"/>
+                <a16:creationId xmlns:a16="http://schemas.microsoft.com/office/drawing/2014/main" id="{B9CF6262-762F-486F-948D-3245F315BEEB}"/>
+              </a:ext>
+            </a:extLst>
+          </p:cNvPr>
+          <p:cNvSpPr>
+            <a:spLocks xmlns:a="http://schemas.openxmlformats.org/drawingml/2006/main" noGrp="1"/>
+          </p:cNvSpPr>
+          <p:nvPr/>
+        </p:nvSpPr>
+        <p:spPr>
+          <a:xfrm xmlns:a="http://schemas.openxmlformats.org/drawingml/2006/main">
+            <a:off x="895350" y="5741670"/>
             <a:ext cx="5334000" cy="2000250"/>
           </a:xfrm>
           <a:prstGeom xmlns:a="http://schemas.openxmlformats.org/drawingml/2006/main" prst="roundRect">
@@ -6523,18 +6523,18 @@
           <p:cNvPr id="7" name="">
             <a:extLst xmlns:a="http://schemas.openxmlformats.org/drawingml/2006/main">
               <a:ext uri="{FF2B5EF4-FFF2-40B4-BE49-F238E27FC236}">
-                <a16:creationId xmlns:a16="http://schemas.microsoft.com/office/drawing/2014/main" id="{57E9CBBD-6EC4-400D-8FCA-7EEA292EC703}"/>
-              </a:ext>
-            </a:extLst>
-          </p:cNvPr>
-          <p:cNvSpPr>
-            <a:spLocks xmlns:a="http://schemas.openxmlformats.org/drawingml/2006/main" noGrp="1"/>
-          </p:cNvSpPr>
-          <p:nvPr/>
-        </p:nvSpPr>
-        <p:spPr>
-          <a:xfrm xmlns:a="http://schemas.openxmlformats.org/drawingml/2006/main">
-            <a:off x="1143000" y="6229350"/>
+                <a16:creationId xmlns:a16="http://schemas.microsoft.com/office/drawing/2014/main" id="{75CB2543-5CFA-4C2F-9CAB-157F70262486}"/>
+              </a:ext>
+            </a:extLst>
+          </p:cNvPr>
+          <p:cNvSpPr>
+            <a:spLocks xmlns:a="http://schemas.openxmlformats.org/drawingml/2006/main" noGrp="1"/>
+          </p:cNvSpPr>
+          <p:nvPr/>
+        </p:nvSpPr>
+        <p:spPr>
+          <a:xfrm xmlns:a="http://schemas.openxmlformats.org/drawingml/2006/main">
+            <a:off x="1143000" y="6400800"/>
             <a:ext cx="4838700" cy="381000"/>
           </a:xfrm>
           <a:prstGeom xmlns:a="http://schemas.openxmlformats.org/drawingml/2006/main" prst="rect">
@@ -6568,18 +6568,18 @@
           <p:cNvPr id="8" name="">
             <a:extLst xmlns:a="http://schemas.openxmlformats.org/drawingml/2006/main">
               <a:ext uri="{FF2B5EF4-FFF2-40B4-BE49-F238E27FC236}">
-                <a16:creationId xmlns:a16="http://schemas.microsoft.com/office/drawing/2014/main" id="{D016BC71-60D8-4285-931D-2F768CC7CC92}"/>
-              </a:ext>
-            </a:extLst>
-          </p:cNvPr>
-          <p:cNvSpPr>
-            <a:spLocks xmlns:a="http://schemas.openxmlformats.org/drawingml/2006/main" noGrp="1"/>
-          </p:cNvSpPr>
-          <p:nvPr/>
-        </p:nvSpPr>
-        <p:spPr>
-          <a:xfrm xmlns:a="http://schemas.openxmlformats.org/drawingml/2006/main">
-            <a:off x="1143000" y="6705600"/>
+                <a16:creationId xmlns:a16="http://schemas.microsoft.com/office/drawing/2014/main" id="{9ED11659-3A95-4356-920B-C69AD3ABA5FA}"/>
+              </a:ext>
+            </a:extLst>
+          </p:cNvPr>
+          <p:cNvSpPr>
+            <a:spLocks xmlns:a="http://schemas.openxmlformats.org/drawingml/2006/main" noGrp="1"/>
+          </p:cNvSpPr>
+          <p:nvPr/>
+        </p:nvSpPr>
+        <p:spPr>
+          <a:xfrm xmlns:a="http://schemas.openxmlformats.org/drawingml/2006/main">
+            <a:off x="1143000" y="6877050"/>
             <a:ext cx="4838700" cy="228600"/>
           </a:xfrm>
           <a:prstGeom xmlns:a="http://schemas.openxmlformats.org/drawingml/2006/main" prst="rect">
@@ -6613,18 +6613,18 @@
           <p:cNvPr id="9" name="">
             <a:extLst xmlns:a="http://schemas.openxmlformats.org/drawingml/2006/main">
               <a:ext uri="{FF2B5EF4-FFF2-40B4-BE49-F238E27FC236}">
-                <a16:creationId xmlns:a16="http://schemas.microsoft.com/office/drawing/2014/main" id="{33C0E762-2768-4D3E-BE7B-E10888AA5150}"/>
-              </a:ext>
-            </a:extLst>
-          </p:cNvPr>
-          <p:cNvSpPr>
-            <a:spLocks xmlns:a="http://schemas.openxmlformats.org/drawingml/2006/main" noGrp="1"/>
-          </p:cNvSpPr>
-          <p:nvPr/>
-        </p:nvSpPr>
-        <p:spPr>
-          <a:xfrm xmlns:a="http://schemas.openxmlformats.org/drawingml/2006/main">
-            <a:off x="6477000" y="5570220"/>
+                <a16:creationId xmlns:a16="http://schemas.microsoft.com/office/drawing/2014/main" id="{20DD52AC-B29B-41F7-9B30-574FCDD07659}"/>
+              </a:ext>
+            </a:extLst>
+          </p:cNvPr>
+          <p:cNvSpPr>
+            <a:spLocks xmlns:a="http://schemas.openxmlformats.org/drawingml/2006/main" noGrp="1"/>
+          </p:cNvSpPr>
+          <p:nvPr/>
+        </p:nvSpPr>
+        <p:spPr>
+          <a:xfrm xmlns:a="http://schemas.openxmlformats.org/drawingml/2006/main">
+            <a:off x="6477000" y="5741670"/>
             <a:ext cx="5334000" cy="2000250"/>
           </a:xfrm>
           <a:prstGeom xmlns:a="http://schemas.openxmlformats.org/drawingml/2006/main" prst="roundRect">
@@ -6642,18 +6642,18 @@
           <p:cNvPr id="10" name="">
             <a:extLst xmlns:a="http://schemas.openxmlformats.org/drawingml/2006/main">
               <a:ext uri="{FF2B5EF4-FFF2-40B4-BE49-F238E27FC236}">
-                <a16:creationId xmlns:a16="http://schemas.microsoft.com/office/drawing/2014/main" id="{BAE6AD84-6483-49C5-9DC4-2B2B62006872}"/>
-              </a:ext>
-            </a:extLst>
-          </p:cNvPr>
-          <p:cNvSpPr>
-            <a:spLocks xmlns:a="http://schemas.openxmlformats.org/drawingml/2006/main" noGrp="1"/>
-          </p:cNvSpPr>
-          <p:nvPr/>
-        </p:nvSpPr>
-        <p:spPr>
-          <a:xfrm xmlns:a="http://schemas.openxmlformats.org/drawingml/2006/main">
-            <a:off x="6724650" y="6229350"/>
+                <a16:creationId xmlns:a16="http://schemas.microsoft.com/office/drawing/2014/main" id="{1EE08C31-CE9B-4629-B58D-FAB42DC59E0B}"/>
+              </a:ext>
+            </a:extLst>
+          </p:cNvPr>
+          <p:cNvSpPr>
+            <a:spLocks xmlns:a="http://schemas.openxmlformats.org/drawingml/2006/main" noGrp="1"/>
+          </p:cNvSpPr>
+          <p:nvPr/>
+        </p:nvSpPr>
+        <p:spPr>
+          <a:xfrm xmlns:a="http://schemas.openxmlformats.org/drawingml/2006/main">
+            <a:off x="6724650" y="6400800"/>
             <a:ext cx="4838700" cy="381000"/>
           </a:xfrm>
           <a:prstGeom xmlns:a="http://schemas.openxmlformats.org/drawingml/2006/main" prst="rect">
@@ -6687,18 +6687,18 @@
           <p:cNvPr id="11" name="">
             <a:extLst xmlns:a="http://schemas.openxmlformats.org/drawingml/2006/main">
               <a:ext uri="{FF2B5EF4-FFF2-40B4-BE49-F238E27FC236}">
-                <a16:creationId xmlns:a16="http://schemas.microsoft.com/office/drawing/2014/main" id="{58DAA285-4CAD-4D23-8EE6-2C6A7E8FE1BC}"/>
-              </a:ext>
-            </a:extLst>
-          </p:cNvPr>
-          <p:cNvSpPr>
-            <a:spLocks xmlns:a="http://schemas.openxmlformats.org/drawingml/2006/main" noGrp="1"/>
-          </p:cNvSpPr>
-          <p:nvPr/>
-        </p:nvSpPr>
-        <p:spPr>
-          <a:xfrm xmlns:a="http://schemas.openxmlformats.org/drawingml/2006/main">
-            <a:off x="6724650" y="6705600"/>
+                <a16:creationId xmlns:a16="http://schemas.microsoft.com/office/drawing/2014/main" id="{FA52AC06-6B77-4719-AAB3-8951E4DCA6E4}"/>
+              </a:ext>
+            </a:extLst>
+          </p:cNvPr>
+          <p:cNvSpPr>
+            <a:spLocks xmlns:a="http://schemas.openxmlformats.org/drawingml/2006/main" noGrp="1"/>
+          </p:cNvSpPr>
+          <p:nvPr/>
+        </p:nvSpPr>
+        <p:spPr>
+          <a:xfrm xmlns:a="http://schemas.openxmlformats.org/drawingml/2006/main">
+            <a:off x="6724650" y="6877050"/>
             <a:ext cx="4838700" cy="228600"/>
           </a:xfrm>
           <a:prstGeom xmlns:a="http://schemas.openxmlformats.org/drawingml/2006/main" prst="rect">
@@ -6732,18 +6732,18 @@
           <p:cNvPr id="12" name="">
             <a:extLst xmlns:a="http://schemas.openxmlformats.org/drawingml/2006/main">
               <a:ext uri="{FF2B5EF4-FFF2-40B4-BE49-F238E27FC236}">
-                <a16:creationId xmlns:a16="http://schemas.microsoft.com/office/drawing/2014/main" id="{6F4DBAE4-1FB4-424E-8B1A-05B6CAEB3FDE}"/>
-              </a:ext>
-            </a:extLst>
-          </p:cNvPr>
-          <p:cNvSpPr>
-            <a:spLocks xmlns:a="http://schemas.openxmlformats.org/drawingml/2006/main" noGrp="1"/>
-          </p:cNvSpPr>
-          <p:nvPr/>
-        </p:nvSpPr>
-        <p:spPr>
-          <a:xfrm xmlns:a="http://schemas.openxmlformats.org/drawingml/2006/main">
-            <a:off x="12058650" y="5570220"/>
+                <a16:creationId xmlns:a16="http://schemas.microsoft.com/office/drawing/2014/main" id="{DBCF60F2-6411-44C0-96EA-F5A12870D75C}"/>
+              </a:ext>
+            </a:extLst>
+          </p:cNvPr>
+          <p:cNvSpPr>
+            <a:spLocks xmlns:a="http://schemas.openxmlformats.org/drawingml/2006/main" noGrp="1"/>
+          </p:cNvSpPr>
+          <p:nvPr/>
+        </p:nvSpPr>
+        <p:spPr>
+          <a:xfrm xmlns:a="http://schemas.openxmlformats.org/drawingml/2006/main">
+            <a:off x="12058650" y="5741670"/>
             <a:ext cx="5334000" cy="2000250"/>
           </a:xfrm>
           <a:prstGeom xmlns:a="http://schemas.openxmlformats.org/drawingml/2006/main" prst="roundRect">
@@ -6761,18 +6761,18 @@
           <p:cNvPr id="13" name="">
             <a:extLst xmlns:a="http://schemas.openxmlformats.org/drawingml/2006/main">
               <a:ext uri="{FF2B5EF4-FFF2-40B4-BE49-F238E27FC236}">
-                <a16:creationId xmlns:a16="http://schemas.microsoft.com/office/drawing/2014/main" id="{5E08C1F5-1E6C-4B08-887D-AF6F477880E1}"/>
-              </a:ext>
-            </a:extLst>
-          </p:cNvPr>
-          <p:cNvSpPr>
-            <a:spLocks xmlns:a="http://schemas.openxmlformats.org/drawingml/2006/main" noGrp="1"/>
-          </p:cNvSpPr>
-          <p:nvPr/>
-        </p:nvSpPr>
-        <p:spPr>
-          <a:xfrm xmlns:a="http://schemas.openxmlformats.org/drawingml/2006/main">
-            <a:off x="12306300" y="6210300"/>
+                <a16:creationId xmlns:a16="http://schemas.microsoft.com/office/drawing/2014/main" id="{C9D22585-7EFA-4D3A-9274-7D62E75D28EC}"/>
+              </a:ext>
+            </a:extLst>
+          </p:cNvPr>
+          <p:cNvSpPr>
+            <a:spLocks xmlns:a="http://schemas.openxmlformats.org/drawingml/2006/main" noGrp="1"/>
+          </p:cNvSpPr>
+          <p:nvPr/>
+        </p:nvSpPr>
+        <p:spPr>
+          <a:xfrm xmlns:a="http://schemas.openxmlformats.org/drawingml/2006/main">
+            <a:off x="12306300" y="6381750"/>
             <a:ext cx="4838700" cy="381000"/>
           </a:xfrm>
           <a:prstGeom xmlns:a="http://schemas.openxmlformats.org/drawingml/2006/main" prst="rect">
@@ -6806,18 +6806,18 @@
           <p:cNvPr id="14" name="">
             <a:extLst xmlns:a="http://schemas.openxmlformats.org/drawingml/2006/main">
               <a:ext uri="{FF2B5EF4-FFF2-40B4-BE49-F238E27FC236}">
-                <a16:creationId xmlns:a16="http://schemas.microsoft.com/office/drawing/2014/main" id="{0A7E877D-B976-4F9B-B50C-AE10414448DA}"/>
-              </a:ext>
-            </a:extLst>
-          </p:cNvPr>
-          <p:cNvSpPr>
-            <a:spLocks xmlns:a="http://schemas.openxmlformats.org/drawingml/2006/main" noGrp="1"/>
-          </p:cNvSpPr>
-          <p:nvPr/>
-        </p:nvSpPr>
-        <p:spPr>
-          <a:xfrm xmlns:a="http://schemas.openxmlformats.org/drawingml/2006/main">
-            <a:off x="12306300" y="6686550"/>
+                <a16:creationId xmlns:a16="http://schemas.microsoft.com/office/drawing/2014/main" id="{A0D834BF-DDE0-43F6-985B-0507AD090DF5}"/>
+              </a:ext>
+            </a:extLst>
+          </p:cNvPr>
+          <p:cNvSpPr>
+            <a:spLocks xmlns:a="http://schemas.openxmlformats.org/drawingml/2006/main" noGrp="1"/>
+          </p:cNvSpPr>
+          <p:nvPr/>
+        </p:nvSpPr>
+        <p:spPr>
+          <a:xfrm xmlns:a="http://schemas.openxmlformats.org/drawingml/2006/main">
+            <a:off x="12306300" y="6858000"/>
             <a:ext cx="4838700" cy="266700"/>
           </a:xfrm>
           <a:prstGeom xmlns:a="http://schemas.openxmlformats.org/drawingml/2006/main" prst="rect">
@@ -6851,7 +6851,7 @@
           <p:cNvPr id="15" name="footer">
             <a:extLst xmlns:a="http://schemas.openxmlformats.org/drawingml/2006/main">
               <a:ext uri="{FF2B5EF4-FFF2-40B4-BE49-F238E27FC236}">
-                <a16:creationId xmlns:a16="http://schemas.microsoft.com/office/drawing/2014/main" id="{92B822D3-ADC7-4DA7-9C9D-A511D82D7B52}"/>
+                <a16:creationId xmlns:a16="http://schemas.microsoft.com/office/drawing/2014/main" id="{932AB924-8754-4DD6-A632-D0C549C1454D}"/>
               </a:ext>
             </a:extLst>
           </p:cNvPr>
@@ -6894,7 +6894,7 @@
     </p:spTree>
     <p:extLst>
       <p:ext uri="{BB962C8B-B14F-4D97-AF65-F5344CB8AC3E}">
-        <p14:creationId xmlns:p14="http://schemas.microsoft.com/office/powerpoint/2010/main" val="391581187"/>
+        <p14:creationId xmlns:p14="http://schemas.microsoft.com/office/powerpoint/2010/main" val="453972218"/>
       </p:ext>
     </p:extLst>
   </p:cSld>

</xml_diff>